<commit_message>
feat(mediator): implementar demo con react
Se implementa la demostración práctica del patrón de diseño Mediator en React mediante un formulario de venta de panadería. La solución utiliza un componente padre con el hook useState como mediador central y eventos onChange en los elementos hijos, controlando dos selects condicionados y un botón de confirmación para centralizar la comunicación y evitar dependencias directas entre componentes.
</commit_message>
<xml_diff>
--- a/presentación/Arquitectura SOA  y Patrones Observer, Mediator.pptx
+++ b/presentación/Arquitectura SOA  y Patrones Observer, Mediator.pptx
@@ -5,20 +5,21 @@
     <p:sldMasterId id="2147483648" r:id="rId1"/>
   </p:sldMasterIdLst>
   <p:notesMasterIdLst>
-    <p:notesMasterId r:id="rId13"/>
+    <p:notesMasterId r:id="rId14"/>
   </p:notesMasterIdLst>
   <p:sldIdLst>
     <p:sldId id="256" r:id="rId2"/>
     <p:sldId id="257" r:id="rId3"/>
     <p:sldId id="258" r:id="rId4"/>
     <p:sldId id="259" r:id="rId5"/>
-    <p:sldId id="264" r:id="rId6"/>
-    <p:sldId id="261" r:id="rId7"/>
-    <p:sldId id="262" r:id="rId8"/>
-    <p:sldId id="263" r:id="rId9"/>
-    <p:sldId id="266" r:id="rId10"/>
-    <p:sldId id="267" r:id="rId11"/>
-    <p:sldId id="268" r:id="rId12"/>
+    <p:sldId id="274" r:id="rId6"/>
+    <p:sldId id="264" r:id="rId7"/>
+    <p:sldId id="261" r:id="rId8"/>
+    <p:sldId id="262" r:id="rId9"/>
+    <p:sldId id="263" r:id="rId10"/>
+    <p:sldId id="269" r:id="rId11"/>
+    <p:sldId id="273" r:id="rId12"/>
+    <p:sldId id="272" r:id="rId13"/>
   </p:sldIdLst>
   <p:sldSz cx="9144000" cy="5143500" type="screen16x9"/>
   <p:notesSz cx="5143500" cy="9144000"/>
@@ -331,222 +332,6 @@
 </p:notes>
 </file>
 
-<file path=ppt/notesSlides/notesSlide10.xml><?xml version="1.0" encoding="utf-8"?>
-<p:notes xmlns:a="http://schemas.openxmlformats.org/drawingml/2006/main" xmlns:r="http://schemas.openxmlformats.org/officeDocument/2006/relationships" xmlns:p="http://schemas.openxmlformats.org/presentationml/2006/main">
-  <p:cSld>
-    <p:spTree>
-      <p:nvGrpSpPr>
-        <p:cNvPr id="1" name="">
-          <a:extLst>
-            <a:ext uri="{FF2B5EF4-FFF2-40B4-BE49-F238E27FC236}">
-              <a16:creationId xmlns:a16="http://schemas.microsoft.com/office/drawing/2014/main" id="{696AD2A2-D5EA-5213-76AE-DC4555251C88}"/>
-            </a:ext>
-          </a:extLst>
-        </p:cNvPr>
-        <p:cNvGrpSpPr/>
-        <p:nvPr/>
-      </p:nvGrpSpPr>
-      <p:grpSpPr>
-        <a:xfrm>
-          <a:off x="0" y="0"/>
-          <a:ext cx="0" cy="0"/>
-          <a:chOff x="0" y="0"/>
-          <a:chExt cx="0" cy="0"/>
-        </a:xfrm>
-      </p:grpSpPr>
-      <p:sp>
-        <p:nvSpPr>
-          <p:cNvPr id="2" name="Slide Image Placeholder 1">
-            <a:extLst>
-              <a:ext uri="{FF2B5EF4-FFF2-40B4-BE49-F238E27FC236}">
-                <a16:creationId xmlns:a16="http://schemas.microsoft.com/office/drawing/2014/main" id="{CC0CCADC-7A05-BE3A-56E1-2CFF9E922F48}"/>
-              </a:ext>
-            </a:extLst>
-          </p:cNvPr>
-          <p:cNvSpPr>
-            <a:spLocks noGrp="1" noRot="1" noChangeAspect="1"/>
-          </p:cNvSpPr>
-          <p:nvPr>
-            <p:ph type="sldImg"/>
-          </p:nvPr>
-        </p:nvSpPr>
-        <p:spPr/>
-      </p:sp>
-      <p:sp>
-        <p:nvSpPr>
-          <p:cNvPr id="3" name="Notes Placeholder 2">
-            <a:extLst>
-              <a:ext uri="{FF2B5EF4-FFF2-40B4-BE49-F238E27FC236}">
-                <a16:creationId xmlns:a16="http://schemas.microsoft.com/office/drawing/2014/main" id="{C413B1F4-F0D8-B0AB-9DB7-3CD0E31813CA}"/>
-              </a:ext>
-            </a:extLst>
-          </p:cNvPr>
-          <p:cNvSpPr>
-            <a:spLocks noGrp="1"/>
-          </p:cNvSpPr>
-          <p:nvPr>
-            <p:ph type="body" idx="1"/>
-          </p:nvPr>
-        </p:nvSpPr>
-        <p:spPr/>
-        <p:txBody>
-          <a:bodyPr/>
-          <a:lstStyle/>
-          <a:p>
-            <a:endParaRPr lang="en-US" dirty="0"/>
-          </a:p>
-        </p:txBody>
-      </p:sp>
-      <p:sp>
-        <p:nvSpPr>
-          <p:cNvPr id="4" name="Slide Number Placeholder 3">
-            <a:extLst>
-              <a:ext uri="{FF2B5EF4-FFF2-40B4-BE49-F238E27FC236}">
-                <a16:creationId xmlns:a16="http://schemas.microsoft.com/office/drawing/2014/main" id="{DF22CA4E-5301-7D51-FDB8-8D3A023C1825}"/>
-              </a:ext>
-            </a:extLst>
-          </p:cNvPr>
-          <p:cNvSpPr>
-            <a:spLocks noGrp="1"/>
-          </p:cNvSpPr>
-          <p:nvPr>
-            <p:ph type="sldNum" sz="quarter" idx="10"/>
-          </p:nvPr>
-        </p:nvSpPr>
-        <p:spPr/>
-        <p:txBody>
-          <a:bodyPr/>
-          <a:lstStyle/>
-          <a:p>
-            <a:fld id="{F7021451-1387-4CA6-816F-3879F97B5CBC}" type="slidenum">
-              <a:rPr lang="en-US"/>
-              <a:t>10</a:t>
-            </a:fld>
-            <a:endParaRPr lang="en-US"/>
-          </a:p>
-        </p:txBody>
-      </p:sp>
-    </p:spTree>
-    <p:extLst>
-      <p:ext uri="{BB962C8B-B14F-4D97-AF65-F5344CB8AC3E}">
-        <p14:creationId xmlns:p14="http://schemas.microsoft.com/office/powerpoint/2010/main" val="1971090940"/>
-      </p:ext>
-    </p:extLst>
-  </p:cSld>
-  <p:clrMapOvr>
-    <a:masterClrMapping/>
-  </p:clrMapOvr>
-</p:notes>
-</file>
-
-<file path=ppt/notesSlides/notesSlide11.xml><?xml version="1.0" encoding="utf-8"?>
-<p:notes xmlns:a="http://schemas.openxmlformats.org/drawingml/2006/main" xmlns:r="http://schemas.openxmlformats.org/officeDocument/2006/relationships" xmlns:p="http://schemas.openxmlformats.org/presentationml/2006/main">
-  <p:cSld>
-    <p:spTree>
-      <p:nvGrpSpPr>
-        <p:cNvPr id="1" name="">
-          <a:extLst>
-            <a:ext uri="{FF2B5EF4-FFF2-40B4-BE49-F238E27FC236}">
-              <a16:creationId xmlns:a16="http://schemas.microsoft.com/office/drawing/2014/main" id="{84C8E976-A7A3-DC33-43E0-6318C58CCB77}"/>
-            </a:ext>
-          </a:extLst>
-        </p:cNvPr>
-        <p:cNvGrpSpPr/>
-        <p:nvPr/>
-      </p:nvGrpSpPr>
-      <p:grpSpPr>
-        <a:xfrm>
-          <a:off x="0" y="0"/>
-          <a:ext cx="0" cy="0"/>
-          <a:chOff x="0" y="0"/>
-          <a:chExt cx="0" cy="0"/>
-        </a:xfrm>
-      </p:grpSpPr>
-      <p:sp>
-        <p:nvSpPr>
-          <p:cNvPr id="2" name="Slide Image Placeholder 1">
-            <a:extLst>
-              <a:ext uri="{FF2B5EF4-FFF2-40B4-BE49-F238E27FC236}">
-                <a16:creationId xmlns:a16="http://schemas.microsoft.com/office/drawing/2014/main" id="{C62CE593-228B-98BE-CC6C-CED2719FFF28}"/>
-              </a:ext>
-            </a:extLst>
-          </p:cNvPr>
-          <p:cNvSpPr>
-            <a:spLocks noGrp="1" noRot="1" noChangeAspect="1"/>
-          </p:cNvSpPr>
-          <p:nvPr>
-            <p:ph type="sldImg"/>
-          </p:nvPr>
-        </p:nvSpPr>
-        <p:spPr/>
-      </p:sp>
-      <p:sp>
-        <p:nvSpPr>
-          <p:cNvPr id="3" name="Notes Placeholder 2">
-            <a:extLst>
-              <a:ext uri="{FF2B5EF4-FFF2-40B4-BE49-F238E27FC236}">
-                <a16:creationId xmlns:a16="http://schemas.microsoft.com/office/drawing/2014/main" id="{9B0F50E8-917D-B9E1-7902-8F93F2F156B9}"/>
-              </a:ext>
-            </a:extLst>
-          </p:cNvPr>
-          <p:cNvSpPr>
-            <a:spLocks noGrp="1"/>
-          </p:cNvSpPr>
-          <p:nvPr>
-            <p:ph type="body" idx="1"/>
-          </p:nvPr>
-        </p:nvSpPr>
-        <p:spPr/>
-        <p:txBody>
-          <a:bodyPr/>
-          <a:lstStyle/>
-          <a:p>
-            <a:endParaRPr lang="en-US" dirty="0"/>
-          </a:p>
-        </p:txBody>
-      </p:sp>
-      <p:sp>
-        <p:nvSpPr>
-          <p:cNvPr id="4" name="Slide Number Placeholder 3">
-            <a:extLst>
-              <a:ext uri="{FF2B5EF4-FFF2-40B4-BE49-F238E27FC236}">
-                <a16:creationId xmlns:a16="http://schemas.microsoft.com/office/drawing/2014/main" id="{5C818D37-44A4-7320-D6E6-944592E3E650}"/>
-              </a:ext>
-            </a:extLst>
-          </p:cNvPr>
-          <p:cNvSpPr>
-            <a:spLocks noGrp="1"/>
-          </p:cNvSpPr>
-          <p:nvPr>
-            <p:ph type="sldNum" sz="quarter" idx="10"/>
-          </p:nvPr>
-        </p:nvSpPr>
-        <p:spPr/>
-        <p:txBody>
-          <a:bodyPr/>
-          <a:lstStyle/>
-          <a:p>
-            <a:fld id="{F7021451-1387-4CA6-816F-3879F97B5CBC}" type="slidenum">
-              <a:rPr lang="en-US"/>
-              <a:t>11</a:t>
-            </a:fld>
-            <a:endParaRPr lang="en-US"/>
-          </a:p>
-        </p:txBody>
-      </p:sp>
-    </p:spTree>
-    <p:extLst>
-      <p:ext uri="{BB962C8B-B14F-4D97-AF65-F5344CB8AC3E}">
-        <p14:creationId xmlns:p14="http://schemas.microsoft.com/office/powerpoint/2010/main" val="3587663532"/>
-      </p:ext>
-    </p:extLst>
-  </p:cSld>
-  <p:clrMapOvr>
-    <a:masterClrMapping/>
-  </p:clrMapOvr>
-</p:notes>
-</file>
-
 <file path=ppt/notesSlides/notesSlide2.xml><?xml version="1.0" encoding="utf-8"?>
 <p:notes xmlns:a="http://schemas.openxmlformats.org/drawingml/2006/main" xmlns:r="http://schemas.openxmlformats.org/officeDocument/2006/relationships" xmlns:p="http://schemas.openxmlformats.org/presentationml/2006/main">
   <p:cSld>
@@ -888,7 +673,7 @@
           <a:p>
             <a:fld id="{F7021451-1387-4CA6-816F-3879F97B5CBC}" type="slidenum">
               <a:rPr lang="en-US"/>
-              <a:t>5</a:t>
+              <a:t>6</a:t>
             </a:fld>
             <a:endParaRPr lang="en-US"/>
           </a:p>
@@ -972,7 +757,7 @@
           <a:p>
             <a:fld id="{F7021451-1387-4CA6-816F-3879F97B5CBC}" type="slidenum">
               <a:rPr lang="en-US"/>
-              <a:t>6</a:t>
+              <a:t>7</a:t>
             </a:fld>
             <a:endParaRPr lang="en-US"/>
           </a:p>
@@ -1056,7 +841,7 @@
           <a:p>
             <a:fld id="{F7021451-1387-4CA6-816F-3879F97B5CBC}" type="slidenum">
               <a:rPr lang="en-US"/>
-              <a:t>7</a:t>
+              <a:t>8</a:t>
             </a:fld>
             <a:endParaRPr lang="en-US"/>
           </a:p>
@@ -1140,7 +925,7 @@
           <a:p>
             <a:fld id="{F7021451-1387-4CA6-816F-3879F97B5CBC}" type="slidenum">
               <a:rPr lang="en-US"/>
-              <a:t>8</a:t>
+              <a:t>9</a:t>
             </a:fld>
             <a:endParaRPr lang="en-US"/>
           </a:p>
@@ -1150,114 +935,6 @@
     <p:extLst>
       <p:ext uri="{BB962C8B-B14F-4D97-AF65-F5344CB8AC3E}">
         <p14:creationId xmlns:p14="http://schemas.microsoft.com/office/powerpoint/2010/main" val="1024086991"/>
-      </p:ext>
-    </p:extLst>
-  </p:cSld>
-  <p:clrMapOvr>
-    <a:masterClrMapping/>
-  </p:clrMapOvr>
-</p:notes>
-</file>
-
-<file path=ppt/notesSlides/notesSlide9.xml><?xml version="1.0" encoding="utf-8"?>
-<p:notes xmlns:a="http://schemas.openxmlformats.org/drawingml/2006/main" xmlns:r="http://schemas.openxmlformats.org/officeDocument/2006/relationships" xmlns:p="http://schemas.openxmlformats.org/presentationml/2006/main">
-  <p:cSld>
-    <p:spTree>
-      <p:nvGrpSpPr>
-        <p:cNvPr id="1" name="">
-          <a:extLst>
-            <a:ext uri="{FF2B5EF4-FFF2-40B4-BE49-F238E27FC236}">
-              <a16:creationId xmlns:a16="http://schemas.microsoft.com/office/drawing/2014/main" id="{BA080075-447D-901C-3244-0184D75E379B}"/>
-            </a:ext>
-          </a:extLst>
-        </p:cNvPr>
-        <p:cNvGrpSpPr/>
-        <p:nvPr/>
-      </p:nvGrpSpPr>
-      <p:grpSpPr>
-        <a:xfrm>
-          <a:off x="0" y="0"/>
-          <a:ext cx="0" cy="0"/>
-          <a:chOff x="0" y="0"/>
-          <a:chExt cx="0" cy="0"/>
-        </a:xfrm>
-      </p:grpSpPr>
-      <p:sp>
-        <p:nvSpPr>
-          <p:cNvPr id="2" name="Slide Image Placeholder 1">
-            <a:extLst>
-              <a:ext uri="{FF2B5EF4-FFF2-40B4-BE49-F238E27FC236}">
-                <a16:creationId xmlns:a16="http://schemas.microsoft.com/office/drawing/2014/main" id="{0FA2AF39-7543-FABF-C5B2-CA77E7BD4A27}"/>
-              </a:ext>
-            </a:extLst>
-          </p:cNvPr>
-          <p:cNvSpPr>
-            <a:spLocks noGrp="1" noRot="1" noChangeAspect="1"/>
-          </p:cNvSpPr>
-          <p:nvPr>
-            <p:ph type="sldImg"/>
-          </p:nvPr>
-        </p:nvSpPr>
-        <p:spPr/>
-      </p:sp>
-      <p:sp>
-        <p:nvSpPr>
-          <p:cNvPr id="3" name="Notes Placeholder 2">
-            <a:extLst>
-              <a:ext uri="{FF2B5EF4-FFF2-40B4-BE49-F238E27FC236}">
-                <a16:creationId xmlns:a16="http://schemas.microsoft.com/office/drawing/2014/main" id="{5DF4CDED-CAF2-CA79-EE74-FC2224994722}"/>
-              </a:ext>
-            </a:extLst>
-          </p:cNvPr>
-          <p:cNvSpPr>
-            <a:spLocks noGrp="1"/>
-          </p:cNvSpPr>
-          <p:nvPr>
-            <p:ph type="body" idx="1"/>
-          </p:nvPr>
-        </p:nvSpPr>
-        <p:spPr/>
-        <p:txBody>
-          <a:bodyPr/>
-          <a:lstStyle/>
-          <a:p>
-            <a:endParaRPr lang="en-US" dirty="0"/>
-          </a:p>
-        </p:txBody>
-      </p:sp>
-      <p:sp>
-        <p:nvSpPr>
-          <p:cNvPr id="4" name="Slide Number Placeholder 3">
-            <a:extLst>
-              <a:ext uri="{FF2B5EF4-FFF2-40B4-BE49-F238E27FC236}">
-                <a16:creationId xmlns:a16="http://schemas.microsoft.com/office/drawing/2014/main" id="{C3BF1497-A489-EC0A-9F54-0D0AD37C8B31}"/>
-              </a:ext>
-            </a:extLst>
-          </p:cNvPr>
-          <p:cNvSpPr>
-            <a:spLocks noGrp="1"/>
-          </p:cNvSpPr>
-          <p:nvPr>
-            <p:ph type="sldNum" sz="quarter" idx="10"/>
-          </p:nvPr>
-        </p:nvSpPr>
-        <p:spPr/>
-        <p:txBody>
-          <a:bodyPr/>
-          <a:lstStyle/>
-          <a:p>
-            <a:fld id="{F7021451-1387-4CA6-816F-3879F97B5CBC}" type="slidenum">
-              <a:rPr lang="en-US"/>
-              <a:t>9</a:t>
-            </a:fld>
-            <a:endParaRPr lang="en-US"/>
-          </a:p>
-        </p:txBody>
-      </p:sp>
-    </p:spTree>
-    <p:extLst>
-      <p:ext uri="{BB962C8B-B14F-4D97-AF65-F5344CB8AC3E}">
-        <p14:creationId xmlns:p14="http://schemas.microsoft.com/office/powerpoint/2010/main" val="2464857390"/>
       </p:ext>
     </p:extLst>
   </p:cSld>
@@ -1457,7 +1134,7 @@
           </a:prstGeom>
           <a:extLst>
             <a:ext uri="{C572A759-6A51-4108-AA02-DFA0A04FC94B}">
-              <ma14:wrappingTextBoxFlag xmlns="" xmlns:ma14="http://schemas.microsoft.com/office/mac/drawingml/2011/main" val="0"/>
+              <ma14:wrappingTextBoxFlag xmlns:ma14="http://schemas.microsoft.com/office/mac/drawingml/2011/main" xmlns="" val="0"/>
             </a:ext>
           </a:extLst>
         </p:spPr>
@@ -1483,6 +1160,148 @@
         </p:txBody>
       </p:sp>
     </p:spTree>
+  </p:cSld>
+  <p:clrMapOvr>
+    <a:masterClrMapping/>
+  </p:clrMapOvr>
+</p:sldLayout>
+</file>
+
+<file path=ppt/slideLayouts/slideLayout4.xml><?xml version="1.0" encoding="utf-8"?>
+<p:sldLayout xmlns:a="http://schemas.openxmlformats.org/drawingml/2006/main" xmlns:r="http://schemas.openxmlformats.org/officeDocument/2006/relationships" xmlns:p="http://schemas.openxmlformats.org/presentationml/2006/main" type="titleOnly">
+  <p:cSld name="Solo el título">
+    <p:spTree>
+      <p:nvGrpSpPr>
+        <p:cNvPr id="1" name=""/>
+        <p:cNvGrpSpPr/>
+        <p:nvPr/>
+      </p:nvGrpSpPr>
+      <p:grpSpPr>
+        <a:xfrm>
+          <a:off x="0" y="0"/>
+          <a:ext cx="0" cy="0"/>
+          <a:chOff x="0" y="0"/>
+          <a:chExt cx="0" cy="0"/>
+        </a:xfrm>
+      </p:grpSpPr>
+      <p:sp>
+        <p:nvSpPr>
+          <p:cNvPr id="2" name="Título 1">
+            <a:extLst>
+              <a:ext uri="{FF2B5EF4-FFF2-40B4-BE49-F238E27FC236}">
+                <a16:creationId xmlns:a16="http://schemas.microsoft.com/office/drawing/2014/main" id="{F51CCAD3-7DF5-94B1-7CEF-686D535A842F}"/>
+              </a:ext>
+            </a:extLst>
+          </p:cNvPr>
+          <p:cNvSpPr>
+            <a:spLocks noGrp="1"/>
+          </p:cNvSpPr>
+          <p:nvPr>
+            <p:ph type="title"/>
+          </p:nvPr>
+        </p:nvSpPr>
+        <p:spPr/>
+        <p:txBody>
+          <a:bodyPr/>
+          <a:lstStyle/>
+          <a:p>
+            <a:r>
+              <a:rPr lang="es-ES"/>
+              <a:t>Haga clic para modificar el estilo de título del patrón</a:t>
+            </a:r>
+            <a:endParaRPr lang="es-CO"/>
+          </a:p>
+        </p:txBody>
+      </p:sp>
+      <p:sp>
+        <p:nvSpPr>
+          <p:cNvPr id="3" name="Marcador de fecha 2">
+            <a:extLst>
+              <a:ext uri="{FF2B5EF4-FFF2-40B4-BE49-F238E27FC236}">
+                <a16:creationId xmlns:a16="http://schemas.microsoft.com/office/drawing/2014/main" id="{F3827FD4-BFE5-A255-9040-7E4D962F6D3A}"/>
+              </a:ext>
+            </a:extLst>
+          </p:cNvPr>
+          <p:cNvSpPr>
+            <a:spLocks noGrp="1"/>
+          </p:cNvSpPr>
+          <p:nvPr>
+            <p:ph type="dt" sz="half" idx="10"/>
+          </p:nvPr>
+        </p:nvSpPr>
+        <p:spPr/>
+        <p:txBody>
+          <a:bodyPr/>
+          <a:lstStyle/>
+          <a:p>
+            <a:fld id="{228352A7-4D7D-4A5E-A016-C2965DC63AEC}" type="datetimeFigureOut">
+              <a:rPr lang="es-CO" smtClean="0"/>
+              <a:t>15/10/2026</a:t>
+            </a:fld>
+            <a:endParaRPr lang="es-CO"/>
+          </a:p>
+        </p:txBody>
+      </p:sp>
+      <p:sp>
+        <p:nvSpPr>
+          <p:cNvPr id="4" name="Marcador de pie de página 3">
+            <a:extLst>
+              <a:ext uri="{FF2B5EF4-FFF2-40B4-BE49-F238E27FC236}">
+                <a16:creationId xmlns:a16="http://schemas.microsoft.com/office/drawing/2014/main" id="{909CD20F-F8E8-E721-BFDE-59B5F47CC6D7}"/>
+              </a:ext>
+            </a:extLst>
+          </p:cNvPr>
+          <p:cNvSpPr>
+            <a:spLocks noGrp="1"/>
+          </p:cNvSpPr>
+          <p:nvPr>
+            <p:ph type="ftr" sz="quarter" idx="11"/>
+          </p:nvPr>
+        </p:nvSpPr>
+        <p:spPr/>
+        <p:txBody>
+          <a:bodyPr/>
+          <a:lstStyle/>
+          <a:p>
+            <a:endParaRPr lang="es-CO"/>
+          </a:p>
+        </p:txBody>
+      </p:sp>
+      <p:sp>
+        <p:nvSpPr>
+          <p:cNvPr id="5" name="Marcador de número de diapositiva 4">
+            <a:extLst>
+              <a:ext uri="{FF2B5EF4-FFF2-40B4-BE49-F238E27FC236}">
+                <a16:creationId xmlns:a16="http://schemas.microsoft.com/office/drawing/2014/main" id="{A04BAE63-37D6-D1E1-1078-02CD548153FA}"/>
+              </a:ext>
+            </a:extLst>
+          </p:cNvPr>
+          <p:cNvSpPr>
+            <a:spLocks noGrp="1"/>
+          </p:cNvSpPr>
+          <p:nvPr>
+            <p:ph type="sldNum" sz="quarter" idx="12"/>
+          </p:nvPr>
+        </p:nvSpPr>
+        <p:spPr/>
+        <p:txBody>
+          <a:bodyPr/>
+          <a:lstStyle/>
+          <a:p>
+            <a:fld id="{8BC55409-EAD8-4FD9-9741-7849243000BF}" type="slidenum">
+              <a:rPr lang="es-CO" smtClean="0"/>
+              <a:t>‹Nº›</a:t>
+            </a:fld>
+            <a:endParaRPr lang="es-CO"/>
+          </a:p>
+        </p:txBody>
+      </p:sp>
+    </p:spTree>
+    <p:extLst>
+      <p:ext uri="{BB962C8B-B14F-4D97-AF65-F5344CB8AC3E}">
+        <p14:creationId xmlns:p14="http://schemas.microsoft.com/office/powerpoint/2010/main" val="71186273"/>
+      </p:ext>
+    </p:extLst>
   </p:cSld>
   <p:clrMapOvr>
     <a:masterClrMapping/>
@@ -1532,7 +1351,7 @@
           </a:prstGeom>
           <a:extLst>
             <a:ext uri="{C572A759-6A51-4108-AA02-DFA0A04FC94B}">
-              <ma14:wrappingTextBoxFlag xmlns="" xmlns:ma14="http://schemas.microsoft.com/office/mac/drawingml/2011/main" val="0"/>
+              <ma14:wrappingTextBoxFlag xmlns:ma14="http://schemas.microsoft.com/office/mac/drawingml/2011/main" xmlns="" val="0"/>
             </a:ext>
           </a:extLst>
         </p:spPr>
@@ -1564,6 +1383,7 @@
     <p:sldLayoutId id="2147483649" r:id="rId1"/>
     <p:sldLayoutId id="2147483650" r:id="rId2"/>
     <p:sldLayoutId id="2147483651" r:id="rId3"/>
+    <p:sldLayoutId id="2147483652" r:id="rId4"/>
   </p:sldLayoutIdLst>
   <p:hf sldNum="0" hdr="0" ftr="0" dt="0"/>
   <p:txStyles>
@@ -1997,15 +1817,17 @@
 <file path=ppt/slides/slide10.xml><?xml version="1.0" encoding="utf-8"?>
 <p:sld xmlns:a="http://schemas.openxmlformats.org/drawingml/2006/main" xmlns:r="http://schemas.openxmlformats.org/officeDocument/2006/relationships" xmlns:p="http://schemas.openxmlformats.org/presentationml/2006/main">
   <p:cSld>
+    <p:bg>
+      <p:bgPr>
+        <a:solidFill>
+          <a:srgbClr val="0F122D"/>
+        </a:solidFill>
+        <a:effectLst/>
+      </p:bgPr>
+    </p:bg>
     <p:spTree>
       <p:nvGrpSpPr>
-        <p:cNvPr id="1" name="">
-          <a:extLst>
-            <a:ext uri="{FF2B5EF4-FFF2-40B4-BE49-F238E27FC236}">
-              <a16:creationId xmlns:a16="http://schemas.microsoft.com/office/drawing/2014/main" id="{A10C7E05-BE78-B842-E836-510FEEAA7AEF}"/>
-            </a:ext>
-          </a:extLst>
-        </p:cNvPr>
+        <p:cNvPr id="1" name=""/>
         <p:cNvGrpSpPr/>
         <p:nvPr/>
       </p:nvGrpSpPr>
@@ -2019,10 +1841,80 @@
       </p:grpSpPr>
       <p:sp>
         <p:nvSpPr>
-          <p:cNvPr id="2" name="Text 0">
+          <p:cNvPr id="3" name="Elipse 2">
             <a:extLst>
               <a:ext uri="{FF2B5EF4-FFF2-40B4-BE49-F238E27FC236}">
-                <a16:creationId xmlns:a16="http://schemas.microsoft.com/office/drawing/2014/main" id="{0AECEB0B-F9DC-14B5-6015-7D9A3ABD2120}"/>
+                <a16:creationId xmlns:a16="http://schemas.microsoft.com/office/drawing/2014/main" id="{5FA4C54D-F8F7-667D-27BC-8658065CB91A}"/>
+              </a:ext>
+            </a:extLst>
+          </p:cNvPr>
+          <p:cNvSpPr/>
+          <p:nvPr/>
+        </p:nvSpPr>
+        <p:spPr>
+          <a:xfrm>
+            <a:off x="7620000" y="-762000"/>
+            <a:ext cx="2476500" cy="2476500"/>
+          </a:xfrm>
+          <a:prstGeom prst="ellipse">
+            <a:avLst/>
+          </a:prstGeom>
+          <a:solidFill>
+            <a:srgbClr val="6473F5">
+              <a:alpha val="20000"/>
+            </a:srgbClr>
+          </a:solidFill>
+          <a:ln w="19050" cap="flat" cmpd="sng" algn="ctr">
+            <a:noFill/>
+            <a:prstDash val="solid"/>
+            <a:miter lim="800000"/>
+          </a:ln>
+          <a:effectLst/>
+          <a:extLst>
+            <a:ext uri="{91240B29-F687-4F45-9708-019B960494DF}">
+              <a14:hiddenLine xmlns:a14="http://schemas.microsoft.com/office/drawing/2010/main" w="19050" cap="flat" cmpd="sng" algn="ctr">
+                <a:solidFill>
+                  <a:schemeClr val="accent1">
+                    <a:shade val="15000"/>
+                  </a:schemeClr>
+                </a:solidFill>
+                <a:prstDash val="solid"/>
+                <a:miter lim="800000"/>
+              </a14:hiddenLine>
+            </a:ext>
+          </a:extLst>
+        </p:spPr>
+        <p:style>
+          <a:lnRef idx="2">
+            <a:schemeClr val="accent1">
+              <a:shade val="15000"/>
+            </a:schemeClr>
+          </a:lnRef>
+          <a:fillRef idx="1">
+            <a:schemeClr val="accent1"/>
+          </a:fillRef>
+          <a:effectRef idx="0">
+            <a:schemeClr val="accent1"/>
+          </a:effectRef>
+          <a:fontRef idx="minor">
+            <a:schemeClr val="lt1"/>
+          </a:fontRef>
+        </p:style>
+        <p:txBody>
+          <a:bodyPr rtlCol="0" anchor="ctr"/>
+          <a:lstStyle/>
+          <a:p>
+            <a:pPr algn="ctr"/>
+            <a:endParaRPr lang="es-CO" sz="1350"/>
+          </a:p>
+        </p:txBody>
+      </p:sp>
+      <p:sp>
+        <p:nvSpPr>
+          <p:cNvPr id="2" name="Título 1">
+            <a:extLst>
+              <a:ext uri="{FF2B5EF4-FFF2-40B4-BE49-F238E27FC236}">
+                <a16:creationId xmlns:a16="http://schemas.microsoft.com/office/drawing/2014/main" id="{E7116F78-536A-8DEB-2C90-7E0E23F1D148}"/>
               </a:ext>
             </a:extLst>
           </p:cNvPr>
@@ -2030,572 +1922,181 @@
             <a:spLocks noGrp="1"/>
           </p:cNvSpPr>
           <p:nvPr>
-            <p:ph type="title" idx="100" hasCustomPrompt="1"/>
+            <p:ph type="title"/>
           </p:nvPr>
         </p:nvSpPr>
         <p:spPr>
           <a:xfrm>
-            <a:off x="548640" y="274320"/>
-            <a:ext cx="8046720" cy="640080"/>
-          </a:xfrm>
-          <a:prstGeom prst="rect">
-            <a:avLst/>
-          </a:prstGeom>
-          <a:noFill/>
-          <a:ln/>
-        </p:spPr>
-        <p:txBody>
-          <a:bodyPr wrap="square" lIns="0" tIns="0" rIns="0" bIns="0" rtlCol="0" anchor="ctr"/>
-          <a:lstStyle/>
-          <a:p>
-            <a:pPr marL="0" indent="0" algn="l">
-              <a:buNone/>
-            </a:pPr>
-            <a:r>
-              <a:rPr lang="en-US" dirty="0"/>
-              <a:t>7. </a:t>
-            </a:r>
-            <a:r>
-              <a:rPr lang="en-US" dirty="0" err="1"/>
-              <a:t>Conclusión</a:t>
-            </a:r>
-            <a:r>
-              <a:rPr lang="en-US" dirty="0"/>
-              <a:t>: </a:t>
-            </a:r>
-            <a:r>
-              <a:rPr lang="en-US" dirty="0" err="1"/>
-              <a:t>criterios</a:t>
-            </a:r>
-            <a:r>
-              <a:rPr lang="en-US" dirty="0"/>
-              <a:t> de </a:t>
-            </a:r>
-            <a:r>
-              <a:rPr lang="en-US" dirty="0" err="1"/>
-              <a:t>decisión</a:t>
-            </a:r>
-            <a:endParaRPr lang="en-US" sz="3400" dirty="0"/>
-          </a:p>
-        </p:txBody>
-      </p:sp>
-      <p:sp>
-        <p:nvSpPr>
-          <p:cNvPr id="25" name="Slide Number Placeholder 0">
+            <a:off x="476250" y="238125"/>
+            <a:ext cx="7620000" cy="666750"/>
+          </a:xfrm>
+        </p:spPr>
+        <p:txBody>
+          <a:bodyPr anchor="ctr">
+            <a:normAutofit/>
+          </a:bodyPr>
+          <a:lstStyle/>
+          <a:p>
+            <a:pPr algn="l"/>
+            <a:r>
+              <a:rPr lang="es-MX" sz="2700" b="1" dirty="0">
+                <a:solidFill>
+                  <a:srgbClr val="FFFFFF"/>
+                </a:solidFill>
+                <a:latin typeface="Calibri" panose="020F0502020204030204" pitchFamily="34" charset="0"/>
+              </a:rPr>
+              <a:t>6</a:t>
+            </a:r>
+            <a:r>
+              <a:rPr lang="es-CO" sz="2700" b="1" dirty="0">
+                <a:solidFill>
+                  <a:srgbClr val="FFFFFF"/>
+                </a:solidFill>
+                <a:latin typeface="Calibri" panose="020F0502020204030204" pitchFamily="34" charset="0"/>
+              </a:rPr>
+              <a:t>. Demostración </a:t>
+            </a:r>
+            <a:r>
+              <a:rPr lang="es-CO" sz="2700" b="1" dirty="0" err="1">
+                <a:solidFill>
+                  <a:srgbClr val="FFFFFF"/>
+                </a:solidFill>
+                <a:latin typeface="Calibri" panose="020F0502020204030204" pitchFamily="34" charset="0"/>
+              </a:rPr>
+              <a:t>Observer</a:t>
+            </a:r>
+            <a:endParaRPr lang="es-CO" sz="2700" b="1" dirty="0">
+              <a:solidFill>
+                <a:srgbClr val="FFFFFF"/>
+              </a:solidFill>
+              <a:latin typeface="Calibri" panose="020F0502020204030204" pitchFamily="34" charset="0"/>
+            </a:endParaRPr>
+          </a:p>
+        </p:txBody>
+      </p:sp>
+      <p:sp>
+        <p:nvSpPr>
+          <p:cNvPr id="24" name="Rounded Rectangle 2">
             <a:extLst>
               <a:ext uri="{FF2B5EF4-FFF2-40B4-BE49-F238E27FC236}">
-                <a16:creationId xmlns:a16="http://schemas.microsoft.com/office/drawing/2014/main" id="{0370077A-DFE5-09B5-E395-1B38556EC4CA}"/>
+                <a16:creationId xmlns:a16="http://schemas.microsoft.com/office/drawing/2014/main" id="{251F3E1A-00CD-40F5-8C3B-ED106DFDCE14}"/>
               </a:ext>
             </a:extLst>
           </p:cNvPr>
-          <p:cNvSpPr>
-            <a:spLocks noGrp="1"/>
-          </p:cNvSpPr>
-          <p:nvPr>
-            <p:ph type="sldNum" sz="quarter" idx="4294967295"/>
-          </p:nvPr>
-        </p:nvSpPr>
-        <p:spPr>
-          <a:xfrm>
-            <a:off x="8321040" y="4754880"/>
-            <a:ext cx="457200" cy="274320"/>
-          </a:xfrm>
-          <a:prstGeom prst="rect">
-            <a:avLst/>
-          </a:prstGeom>
-          <a:extLst>
-            <a:ext uri="{C572A759-6A51-4108-AA02-DFA0A04FC94B}">
-              <ma14:wrappingTextBoxFlag xmlns:ma14="http://schemas.microsoft.com/office/mac/drawingml/2011/main" xmlns="" val="0"/>
-            </a:ext>
-          </a:extLst>
-        </p:spPr>
-        <p:txBody>
-          <a:bodyPr/>
-          <a:lstStyle>
-            <a:lvl1pPr>
-              <a:defRPr sz="1000">
-                <a:solidFill>
-                  <a:schemeClr val="tx1"/>
-                </a:solidFill>
-              </a:defRPr>
-            </a:lvl1pPr>
-          </a:lstStyle>
-          <a:p>
-            <a:pPr algn="l"/>
-            <a:fld id="{F7021451-1387-4CA6-816F-3879F97B5CBC}" type="slidenum">
-              <a:rPr lang="en-US" b="0"/>
-              <a:t>10</a:t>
-            </a:fld>
-            <a:endParaRPr lang="en-US"/>
-          </a:p>
-        </p:txBody>
-      </p:sp>
-      <p:graphicFrame>
-        <p:nvGraphicFramePr>
-          <p:cNvPr id="24" name="Tabla 23">
+          <p:cNvSpPr/>
+          <p:nvPr/>
+        </p:nvSpPr>
+        <p:spPr>
+          <a:xfrm>
+            <a:off x="389114" y="904875"/>
+            <a:ext cx="6901148" cy="4069080"/>
+          </a:xfrm>
+          <a:prstGeom prst="roundRect">
+            <a:avLst>
+              <a:gd name="adj" fmla="val 4067"/>
+            </a:avLst>
+          </a:prstGeom>
+          <a:solidFill>
+            <a:srgbClr val="1A1B26"/>
+          </a:solidFill>
+          <a:ln>
+            <a:noFill/>
+          </a:ln>
+          <a:effectLst/>
+        </p:spPr>
+        <p:style>
+          <a:lnRef idx="1">
+            <a:schemeClr val="accent1"/>
+          </a:lnRef>
+          <a:fillRef idx="3">
+            <a:schemeClr val="accent1"/>
+          </a:fillRef>
+          <a:effectRef idx="2">
+            <a:schemeClr val="accent1"/>
+          </a:effectRef>
+          <a:fontRef idx="minor">
+            <a:schemeClr val="lt1"/>
+          </a:fontRef>
+        </p:style>
+        <p:txBody>
+          <a:bodyPr rtlCol="0" anchor="ctr"/>
+          <a:lstStyle/>
+          <a:p>
+            <a:pPr algn="ctr"/>
+            <a:endParaRPr dirty="0"/>
+          </a:p>
+        </p:txBody>
+      </p:sp>
+      <p:pic>
+        <p:nvPicPr>
+          <p:cNvPr id="21" name="Imagen 20">
             <a:extLst>
               <a:ext uri="{FF2B5EF4-FFF2-40B4-BE49-F238E27FC236}">
-                <a16:creationId xmlns:a16="http://schemas.microsoft.com/office/drawing/2014/main" id="{47799EC9-0DE0-BC6F-2937-92681DD88066}"/>
+                <a16:creationId xmlns:a16="http://schemas.microsoft.com/office/drawing/2014/main" id="{D0D8BA4A-1C0B-F821-C7A1-AF3C9FED97DB}"/>
               </a:ext>
             </a:extLst>
           </p:cNvPr>
-          <p:cNvGraphicFramePr>
-            <a:graphicFrameLocks noGrp="1"/>
-          </p:cNvGraphicFramePr>
-          <p:nvPr>
-            <p:extLst>
-              <p:ext uri="{D42A27DB-BD31-4B8C-83A1-F6EECF244321}">
-                <p14:modId xmlns:p14="http://schemas.microsoft.com/office/powerpoint/2010/main" val="1201330749"/>
-              </p:ext>
-            </p:extLst>
-          </p:nvPr>
-        </p:nvGraphicFramePr>
-        <p:xfrm>
-          <a:off x="548640" y="1134110"/>
-          <a:ext cx="8046721" cy="2966720"/>
-        </p:xfrm>
-        <a:graphic>
-          <a:graphicData uri="http://schemas.openxmlformats.org/drawingml/2006/table">
-            <a:tbl>
-              <a:tblPr firstRow="1" bandRow="1">
-                <a:tableStyleId>{5C22544A-7EE6-4342-B048-85BDC9FD1C3A}</a:tableStyleId>
-              </a:tblPr>
-              <a:tblGrid>
-                <a:gridCol w="1195251">
-                  <a:extLst>
-                    <a:ext uri="{9D8B030D-6E8A-4147-A177-3AD203B41FA5}">
-                      <a16:colId xmlns:a16="http://schemas.microsoft.com/office/drawing/2014/main" val="2693359899"/>
-                    </a:ext>
-                  </a:extLst>
-                </a:gridCol>
-                <a:gridCol w="2751230">
-                  <a:extLst>
-                    <a:ext uri="{9D8B030D-6E8A-4147-A177-3AD203B41FA5}">
-                      <a16:colId xmlns:a16="http://schemas.microsoft.com/office/drawing/2014/main" val="112609293"/>
-                    </a:ext>
-                  </a:extLst>
-                </a:gridCol>
-                <a:gridCol w="1883548">
-                  <a:extLst>
-                    <a:ext uri="{9D8B030D-6E8A-4147-A177-3AD203B41FA5}">
-                      <a16:colId xmlns:a16="http://schemas.microsoft.com/office/drawing/2014/main" val="2578955092"/>
-                    </a:ext>
-                  </a:extLst>
-                </a:gridCol>
-                <a:gridCol w="2216692">
-                  <a:extLst>
-                    <a:ext uri="{9D8B030D-6E8A-4147-A177-3AD203B41FA5}">
-                      <a16:colId xmlns:a16="http://schemas.microsoft.com/office/drawing/2014/main" val="1099321022"/>
-                    </a:ext>
-                  </a:extLst>
-                </a:gridCol>
-              </a:tblGrid>
-              <a:tr h="370840">
-                <a:tc>
-                  <a:txBody>
-                    <a:bodyPr/>
-                    <a:lstStyle/>
-                    <a:p>
-                      <a:r>
-                        <a:rPr lang="es-CO" dirty="0"/>
-                        <a:t>Criterio</a:t>
-                      </a:r>
-                    </a:p>
-                  </a:txBody>
-                  <a:tcPr/>
-                </a:tc>
-                <a:tc>
-                  <a:txBody>
-                    <a:bodyPr/>
-                    <a:lstStyle/>
-                    <a:p>
-                      <a:r>
-                        <a:rPr lang="es-CO" dirty="0"/>
-                        <a:t>SOA</a:t>
-                      </a:r>
-                    </a:p>
-                  </a:txBody>
-                  <a:tcPr/>
-                </a:tc>
-                <a:tc>
-                  <a:txBody>
-                    <a:bodyPr/>
-                    <a:lstStyle/>
-                    <a:p>
-                      <a:r>
-                        <a:rPr lang="es-CO" dirty="0" err="1"/>
-                        <a:t>Observer</a:t>
-                      </a:r>
-                      <a:endParaRPr lang="es-CO" dirty="0"/>
-                    </a:p>
-                  </a:txBody>
-                  <a:tcPr/>
-                </a:tc>
-                <a:tc>
-                  <a:txBody>
-                    <a:bodyPr/>
-                    <a:lstStyle/>
-                    <a:p>
-                      <a:r>
-                        <a:rPr lang="es-CO" dirty="0"/>
-                        <a:t>Mediator</a:t>
-                      </a:r>
-                    </a:p>
-                  </a:txBody>
-                  <a:tcPr/>
-                </a:tc>
-                <a:extLst>
-                  <a:ext uri="{0D108BD9-81ED-4DB2-BD59-A6C34878D82A}">
-                    <a16:rowId xmlns:a16="http://schemas.microsoft.com/office/drawing/2014/main" val="3152399151"/>
-                  </a:ext>
-                </a:extLst>
-              </a:tr>
-              <a:tr h="370840">
-                <a:tc>
-                  <a:txBody>
-                    <a:bodyPr/>
-                    <a:lstStyle/>
-                    <a:p>
-                      <a:r>
-                        <a:rPr lang="es-CO" sz="1600" dirty="0"/>
-                        <a:t>Nivel</a:t>
-                      </a:r>
-                    </a:p>
-                  </a:txBody>
-                  <a:tcPr/>
-                </a:tc>
-                <a:tc>
-                  <a:txBody>
-                    <a:bodyPr/>
-                    <a:lstStyle/>
-                    <a:p>
-                      <a:r>
-                        <a:rPr lang="es-CO" sz="1600" dirty="0"/>
-                        <a:t>Arquitectura del Sistema</a:t>
-                      </a:r>
-                    </a:p>
-                  </a:txBody>
-                  <a:tcPr/>
-                </a:tc>
-                <a:tc>
-                  <a:txBody>
-                    <a:bodyPr/>
-                    <a:lstStyle/>
-                    <a:p>
-                      <a:r>
-                        <a:rPr lang="es-CO" sz="1600" dirty="0"/>
-                        <a:t>Diseño del código</a:t>
-                      </a:r>
-                    </a:p>
-                  </a:txBody>
-                  <a:tcPr/>
-                </a:tc>
-                <a:tc>
-                  <a:txBody>
-                    <a:bodyPr/>
-                    <a:lstStyle/>
-                    <a:p>
-                      <a:r>
-                        <a:rPr lang="es-CO" sz="1600" dirty="0"/>
-                        <a:t>Diseño del código</a:t>
-                      </a:r>
-                    </a:p>
-                  </a:txBody>
-                  <a:tcPr/>
-                </a:tc>
-                <a:extLst>
-                  <a:ext uri="{0D108BD9-81ED-4DB2-BD59-A6C34878D82A}">
-                    <a16:rowId xmlns:a16="http://schemas.microsoft.com/office/drawing/2014/main" val="2681534231"/>
-                  </a:ext>
-                </a:extLst>
-              </a:tr>
-              <a:tr h="370840">
-                <a:tc>
-                  <a:txBody>
-                    <a:bodyPr/>
-                    <a:lstStyle/>
-                    <a:p>
-                      <a:r>
-                        <a:rPr lang="es-CO" sz="1600" dirty="0"/>
-                        <a:t>Conviene cuando</a:t>
-                      </a:r>
-                    </a:p>
-                  </a:txBody>
-                  <a:tcPr/>
-                </a:tc>
-                <a:tc>
-                  <a:txBody>
-                    <a:bodyPr/>
-                    <a:lstStyle/>
-                    <a:p>
-                      <a:r>
-                        <a:rPr lang="es-CO" sz="1600" dirty="0"/>
-                        <a:t>Varios sistemas o equipos, integración, escalado por servicio</a:t>
-                      </a:r>
-                    </a:p>
-                  </a:txBody>
-                  <a:tcPr/>
-                </a:tc>
-                <a:tc>
-                  <a:txBody>
-                    <a:bodyPr/>
-                    <a:lstStyle/>
-                    <a:p>
-                      <a:r>
-                        <a:rPr lang="es-CO" sz="1600" b="0" i="0" kern="1200" dirty="0">
-                          <a:solidFill>
-                            <a:schemeClr val="dk1"/>
-                          </a:solidFill>
-                          <a:effectLst/>
-                          <a:latin typeface="+mn-lt"/>
-                          <a:ea typeface="+mn-ea"/>
-                          <a:cs typeface="+mn-cs"/>
-                        </a:rPr>
-                        <a:t>Un cambio debe disparar varias reacciones</a:t>
-                      </a:r>
-                      <a:endParaRPr lang="es-CO" sz="1600" dirty="0"/>
-                    </a:p>
-                  </a:txBody>
-                  <a:tcPr/>
-                </a:tc>
-                <a:tc>
-                  <a:txBody>
-                    <a:bodyPr/>
-                    <a:lstStyle/>
-                    <a:p>
-                      <a:r>
-                        <a:rPr lang="es-CO" sz="1600" b="0" i="0" kern="1200" dirty="0">
-                          <a:solidFill>
-                            <a:schemeClr val="dk1"/>
-                          </a:solidFill>
-                          <a:effectLst/>
-                          <a:latin typeface="+mn-lt"/>
-                          <a:ea typeface="+mn-ea"/>
-                          <a:cs typeface="+mn-cs"/>
-                        </a:rPr>
-                        <a:t>Muchos componentes dependen unos de otros</a:t>
-                      </a:r>
-                      <a:endParaRPr lang="es-CO" sz="1600" dirty="0"/>
-                    </a:p>
-                  </a:txBody>
-                  <a:tcPr/>
-                </a:tc>
-                <a:extLst>
-                  <a:ext uri="{0D108BD9-81ED-4DB2-BD59-A6C34878D82A}">
-                    <a16:rowId xmlns:a16="http://schemas.microsoft.com/office/drawing/2014/main" val="1645957312"/>
-                  </a:ext>
-                </a:extLst>
-              </a:tr>
-              <a:tr h="370840">
-                <a:tc>
-                  <a:txBody>
-                    <a:bodyPr/>
-                    <a:lstStyle/>
-                    <a:p>
-                      <a:r>
-                        <a:rPr lang="es-CO" sz="1600" dirty="0"/>
-                        <a:t>Evitar cuando</a:t>
-                      </a:r>
-                    </a:p>
-                  </a:txBody>
-                  <a:tcPr/>
-                </a:tc>
-                <a:tc>
-                  <a:txBody>
-                    <a:bodyPr/>
-                    <a:lstStyle/>
-                    <a:p>
-                      <a:r>
-                        <a:rPr lang="es-CO" sz="1600" b="0" i="0" kern="1200" dirty="0">
-                          <a:solidFill>
-                            <a:schemeClr val="dk1"/>
-                          </a:solidFill>
-                          <a:effectLst/>
-                          <a:latin typeface="+mn-lt"/>
-                          <a:ea typeface="+mn-ea"/>
-                          <a:cs typeface="+mn-cs"/>
-                        </a:rPr>
-                        <a:t>App pequeña o un solo equipo</a:t>
-                      </a:r>
-                      <a:endParaRPr lang="es-CO" sz="1600" dirty="0"/>
-                    </a:p>
-                  </a:txBody>
-                  <a:tcPr/>
-                </a:tc>
-                <a:tc>
-                  <a:txBody>
-                    <a:bodyPr/>
-                    <a:lstStyle/>
-                    <a:p>
-                      <a:r>
-                        <a:rPr lang="es-CO" sz="1600" b="0" i="0" kern="1200" dirty="0">
-                          <a:solidFill>
-                            <a:schemeClr val="dk1"/>
-                          </a:solidFill>
-                          <a:effectLst/>
-                          <a:latin typeface="+mn-lt"/>
-                          <a:ea typeface="+mn-ea"/>
-                          <a:cs typeface="+mn-cs"/>
-                        </a:rPr>
-                        <a:t>Se exige orden estricto de ejecución</a:t>
-                      </a:r>
-                      <a:endParaRPr lang="es-CO" sz="1600" dirty="0"/>
-                    </a:p>
-                  </a:txBody>
-                  <a:tcPr/>
-                </a:tc>
-                <a:tc>
-                  <a:txBody>
-                    <a:bodyPr/>
-                    <a:lstStyle/>
-                    <a:p>
-                      <a:r>
-                        <a:rPr lang="es-CO" sz="1600" b="0" i="0" kern="1200" dirty="0">
-                          <a:solidFill>
-                            <a:schemeClr val="dk1"/>
-                          </a:solidFill>
-                          <a:effectLst/>
-                          <a:latin typeface="+mn-lt"/>
-                          <a:ea typeface="+mn-ea"/>
-                          <a:cs typeface="+mn-cs"/>
-                        </a:rPr>
-                        <a:t>Solo hay dos componentes</a:t>
-                      </a:r>
-                      <a:endParaRPr lang="es-CO" sz="1600" dirty="0"/>
-                    </a:p>
-                  </a:txBody>
-                  <a:tcPr/>
-                </a:tc>
-                <a:extLst>
-                  <a:ext uri="{0D108BD9-81ED-4DB2-BD59-A6C34878D82A}">
-                    <a16:rowId xmlns:a16="http://schemas.microsoft.com/office/drawing/2014/main" val="2328104132"/>
-                  </a:ext>
-                </a:extLst>
-              </a:tr>
-              <a:tr h="370840">
-                <a:tc>
-                  <a:txBody>
-                    <a:bodyPr/>
-                    <a:lstStyle/>
-                    <a:p>
-                      <a:r>
-                        <a:rPr lang="es-CO" sz="1600" b="0" i="0" kern="1200" dirty="0">
-                          <a:solidFill>
-                            <a:schemeClr val="dk1"/>
-                          </a:solidFill>
-                          <a:effectLst/>
-                          <a:latin typeface="+mn-lt"/>
-                          <a:ea typeface="+mn-ea"/>
-                          <a:cs typeface="+mn-cs"/>
-                        </a:rPr>
-                        <a:t>Riesgo principal</a:t>
-                      </a:r>
-                      <a:endParaRPr lang="es-CO" sz="1600" dirty="0"/>
-                    </a:p>
-                  </a:txBody>
-                  <a:tcPr/>
-                </a:tc>
-                <a:tc>
-                  <a:txBody>
-                    <a:bodyPr/>
-                    <a:lstStyle/>
-                    <a:p>
-                      <a:r>
-                        <a:rPr lang="es-CO" sz="1600" b="0" i="0" kern="1200" dirty="0">
-                          <a:solidFill>
-                            <a:schemeClr val="dk1"/>
-                          </a:solidFill>
-                          <a:effectLst/>
-                          <a:latin typeface="+mn-lt"/>
-                          <a:ea typeface="+mn-ea"/>
-                          <a:cs typeface="+mn-cs"/>
-                        </a:rPr>
-                        <a:t>Complejidad y latencia</a:t>
-                      </a:r>
-                      <a:endParaRPr lang="es-CO" sz="1600" dirty="0"/>
-                    </a:p>
-                  </a:txBody>
-                  <a:tcPr/>
-                </a:tc>
-                <a:tc>
-                  <a:txBody>
-                    <a:bodyPr/>
-                    <a:lstStyle/>
-                    <a:p>
-                      <a:r>
-                        <a:rPr lang="es-CO" sz="1600" b="0" i="0" kern="1200" dirty="0">
-                          <a:solidFill>
-                            <a:schemeClr val="dk1"/>
-                          </a:solidFill>
-                          <a:effectLst/>
-                          <a:latin typeface="+mn-lt"/>
-                          <a:ea typeface="+mn-ea"/>
-                          <a:cs typeface="+mn-cs"/>
-                        </a:rPr>
-                        <a:t>Cascadas difíciles de depurar</a:t>
-                      </a:r>
-                      <a:endParaRPr lang="es-CO" sz="1600" dirty="0"/>
-                    </a:p>
-                  </a:txBody>
-                  <a:tcPr/>
-                </a:tc>
-                <a:tc>
-                  <a:txBody>
-                    <a:bodyPr/>
-                    <a:lstStyle/>
-                    <a:p>
-                      <a:r>
-                        <a:rPr lang="es-CO" sz="1600" b="0" i="0" kern="1200" dirty="0">
-                          <a:solidFill>
-                            <a:schemeClr val="dk1"/>
-                          </a:solidFill>
-                          <a:effectLst/>
-                          <a:latin typeface="+mn-lt"/>
-                          <a:ea typeface="+mn-ea"/>
-                          <a:cs typeface="+mn-cs"/>
-                        </a:rPr>
-                        <a:t>Mediador sobrecargado</a:t>
-                      </a:r>
-                      <a:endParaRPr lang="es-CO" sz="1600" dirty="0"/>
-                    </a:p>
-                  </a:txBody>
-                  <a:tcPr/>
-                </a:tc>
-                <a:extLst>
-                  <a:ext uri="{0D108BD9-81ED-4DB2-BD59-A6C34878D82A}">
-                    <a16:rowId xmlns:a16="http://schemas.microsoft.com/office/drawing/2014/main" val="2464746392"/>
-                  </a:ext>
-                </a:extLst>
-              </a:tr>
-            </a:tbl>
-          </a:graphicData>
-        </a:graphic>
-      </p:graphicFrame>
+          <p:cNvPicPr>
+            <a:picLocks noChangeAspect="1"/>
+          </p:cNvPicPr>
+          <p:nvPr/>
+        </p:nvPicPr>
+        <p:blipFill>
+          <a:blip r:embed="rId2"/>
+          <a:srcRect l="7087" t="10007" r="7068" b="9250"/>
+          <a:stretch>
+            <a:fillRect/>
+          </a:stretch>
+        </p:blipFill>
+        <p:spPr>
+          <a:xfrm>
+            <a:off x="554454" y="999456"/>
+            <a:ext cx="6561241" cy="3974499"/>
+          </a:xfrm>
+          <a:prstGeom prst="rect">
+            <a:avLst/>
+          </a:prstGeom>
+        </p:spPr>
+      </p:pic>
     </p:spTree>
     <p:extLst>
       <p:ext uri="{BB962C8B-B14F-4D97-AF65-F5344CB8AC3E}">
-        <p14:creationId xmlns:p14="http://schemas.microsoft.com/office/powerpoint/2010/main" val="2051931542"/>
+        <p14:creationId xmlns:p14="http://schemas.microsoft.com/office/powerpoint/2010/main" val="582202036"/>
       </p:ext>
     </p:extLst>
   </p:cSld>
   <p:clrMapOvr>
     <a:masterClrMapping/>
   </p:clrMapOvr>
+  <mc:AlternateContent xmlns:mc="http://schemas.openxmlformats.org/markup-compatibility/2006">
+    <mc:Choice xmlns:p14="http://schemas.microsoft.com/office/powerpoint/2010/main" Requires="p14">
+      <p:transition spd="slow" p14:dur="2000">
+        <p:fade/>
+      </p:transition>
+    </mc:Choice>
+    <mc:Fallback>
+      <p:transition spd="slow">
+        <p:fade/>
+      </p:transition>
+    </mc:Fallback>
+  </mc:AlternateContent>
 </p:sld>
 </file>
 
 <file path=ppt/slides/slide11.xml><?xml version="1.0" encoding="utf-8"?>
 <p:sld xmlns:a="http://schemas.openxmlformats.org/drawingml/2006/main" xmlns:r="http://schemas.openxmlformats.org/officeDocument/2006/relationships" xmlns:p="http://schemas.openxmlformats.org/presentationml/2006/main">
   <p:cSld>
+    <p:bg>
+      <p:bgPr>
+        <a:solidFill>
+          <a:srgbClr val="0F122D"/>
+        </a:solidFill>
+        <a:effectLst/>
+      </p:bgPr>
+    </p:bg>
     <p:spTree>
       <p:nvGrpSpPr>
-        <p:cNvPr id="1" name="">
-          <a:extLst>
-            <a:ext uri="{FF2B5EF4-FFF2-40B4-BE49-F238E27FC236}">
-              <a16:creationId xmlns:a16="http://schemas.microsoft.com/office/drawing/2014/main" id="{23D0FF86-0624-57C6-5343-BA0D3A3984B6}"/>
-            </a:ext>
-          </a:extLst>
-        </p:cNvPr>
+        <p:cNvPr id="1" name=""/>
         <p:cNvGrpSpPr/>
         <p:nvPr/>
       </p:nvGrpSpPr>
@@ -2609,10 +2110,80 @@
       </p:grpSpPr>
       <p:sp>
         <p:nvSpPr>
-          <p:cNvPr id="2" name="Text 0">
+          <p:cNvPr id="3" name="Elipse 2">
             <a:extLst>
               <a:ext uri="{FF2B5EF4-FFF2-40B4-BE49-F238E27FC236}">
-                <a16:creationId xmlns:a16="http://schemas.microsoft.com/office/drawing/2014/main" id="{29F754E8-F711-BC98-F5FC-E895E92F6134}"/>
+                <a16:creationId xmlns:a16="http://schemas.microsoft.com/office/drawing/2014/main" id="{5FA4C54D-F8F7-667D-27BC-8658065CB91A}"/>
+              </a:ext>
+            </a:extLst>
+          </p:cNvPr>
+          <p:cNvSpPr/>
+          <p:nvPr/>
+        </p:nvSpPr>
+        <p:spPr>
+          <a:xfrm>
+            <a:off x="7620000" y="-762000"/>
+            <a:ext cx="2476500" cy="2476500"/>
+          </a:xfrm>
+          <a:prstGeom prst="ellipse">
+            <a:avLst/>
+          </a:prstGeom>
+          <a:solidFill>
+            <a:srgbClr val="6473F5">
+              <a:alpha val="20000"/>
+            </a:srgbClr>
+          </a:solidFill>
+          <a:ln w="19050" cap="flat" cmpd="sng" algn="ctr">
+            <a:noFill/>
+            <a:prstDash val="solid"/>
+            <a:miter lim="800000"/>
+          </a:ln>
+          <a:effectLst/>
+          <a:extLst>
+            <a:ext uri="{91240B29-F687-4F45-9708-019B960494DF}">
+              <a14:hiddenLine xmlns:a14="http://schemas.microsoft.com/office/drawing/2010/main" w="19050" cap="flat" cmpd="sng" algn="ctr">
+                <a:solidFill>
+                  <a:schemeClr val="accent1">
+                    <a:shade val="15000"/>
+                  </a:schemeClr>
+                </a:solidFill>
+                <a:prstDash val="solid"/>
+                <a:miter lim="800000"/>
+              </a14:hiddenLine>
+            </a:ext>
+          </a:extLst>
+        </p:spPr>
+        <p:style>
+          <a:lnRef idx="2">
+            <a:schemeClr val="accent1">
+              <a:shade val="15000"/>
+            </a:schemeClr>
+          </a:lnRef>
+          <a:fillRef idx="1">
+            <a:schemeClr val="accent1"/>
+          </a:fillRef>
+          <a:effectRef idx="0">
+            <a:schemeClr val="accent1"/>
+          </a:effectRef>
+          <a:fontRef idx="minor">
+            <a:schemeClr val="lt1"/>
+          </a:fontRef>
+        </p:style>
+        <p:txBody>
+          <a:bodyPr rtlCol="0" anchor="ctr"/>
+          <a:lstStyle/>
+          <a:p>
+            <a:pPr algn="ctr"/>
+            <a:endParaRPr lang="es-CO" sz="1350"/>
+          </a:p>
+        </p:txBody>
+      </p:sp>
+      <p:sp>
+        <p:nvSpPr>
+          <p:cNvPr id="2" name="Título 1">
+            <a:extLst>
+              <a:ext uri="{FF2B5EF4-FFF2-40B4-BE49-F238E27FC236}">
+                <a16:creationId xmlns:a16="http://schemas.microsoft.com/office/drawing/2014/main" id="{E7116F78-536A-8DEB-2C90-7E0E23F1D148}"/>
               </a:ext>
             </a:extLst>
           </p:cNvPr>
@@ -2620,45 +2191,251 @@
             <a:spLocks noGrp="1"/>
           </p:cNvSpPr>
           <p:nvPr>
-            <p:ph type="title" idx="100" hasCustomPrompt="1"/>
+            <p:ph type="title"/>
           </p:nvPr>
         </p:nvSpPr>
         <p:spPr>
           <a:xfrm>
-            <a:off x="548640" y="274320"/>
-            <a:ext cx="8046720" cy="640080"/>
-          </a:xfrm>
-          <a:prstGeom prst="rect">
-            <a:avLst/>
-          </a:prstGeom>
-          <a:noFill/>
-          <a:ln/>
-        </p:spPr>
-        <p:txBody>
-          <a:bodyPr wrap="square" lIns="0" tIns="0" rIns="0" bIns="0" rtlCol="0" anchor="ctr"/>
-          <a:lstStyle/>
-          <a:p>
-            <a:pPr marL="0" indent="0" algn="l">
-              <a:buNone/>
-            </a:pPr>
-            <a:r>
-              <a:rPr lang="en-US" dirty="0"/>
-              <a:t>7.1 </a:t>
-            </a:r>
-            <a:r>
-              <a:rPr lang="en-US" dirty="0" err="1"/>
-              <a:t>Conclusión</a:t>
-            </a:r>
-            <a:endParaRPr lang="en-US" sz="3400" dirty="0"/>
-          </a:p>
-        </p:txBody>
-      </p:sp>
-      <p:sp>
-        <p:nvSpPr>
-          <p:cNvPr id="25" name="Slide Number Placeholder 0">
+            <a:off x="476250" y="238125"/>
+            <a:ext cx="7620000" cy="666750"/>
+          </a:xfrm>
+        </p:spPr>
+        <p:txBody>
+          <a:bodyPr anchor="ctr">
+            <a:normAutofit/>
+          </a:bodyPr>
+          <a:lstStyle/>
+          <a:p>
+            <a:pPr algn="l"/>
+            <a:r>
+              <a:rPr lang="es-MX" sz="2700" b="1" dirty="0">
+                <a:solidFill>
+                  <a:srgbClr val="FFFFFF"/>
+                </a:solidFill>
+                <a:latin typeface="Calibri" panose="020F0502020204030204" pitchFamily="34" charset="0"/>
+              </a:rPr>
+              <a:t>6</a:t>
+            </a:r>
+            <a:r>
+              <a:rPr lang="es-CO" sz="2700" b="1" dirty="0">
+                <a:solidFill>
+                  <a:srgbClr val="FFFFFF"/>
+                </a:solidFill>
+                <a:latin typeface="Calibri" panose="020F0502020204030204" pitchFamily="34" charset="0"/>
+              </a:rPr>
+              <a:t>. Demostración Mediator</a:t>
+            </a:r>
+          </a:p>
+        </p:txBody>
+      </p:sp>
+      <p:sp>
+        <p:nvSpPr>
+          <p:cNvPr id="24" name="Rounded Rectangle 2">
             <a:extLst>
               <a:ext uri="{FF2B5EF4-FFF2-40B4-BE49-F238E27FC236}">
-                <a16:creationId xmlns:a16="http://schemas.microsoft.com/office/drawing/2014/main" id="{1D467414-34F1-38CB-3B36-74E762D5ABCE}"/>
+                <a16:creationId xmlns:a16="http://schemas.microsoft.com/office/drawing/2014/main" id="{251F3E1A-00CD-40F5-8C3B-ED106DFDCE14}"/>
+              </a:ext>
+            </a:extLst>
+          </p:cNvPr>
+          <p:cNvSpPr/>
+          <p:nvPr/>
+        </p:nvSpPr>
+        <p:spPr>
+          <a:xfrm>
+            <a:off x="389113" y="904875"/>
+            <a:ext cx="7392811" cy="4069080"/>
+          </a:xfrm>
+          <a:prstGeom prst="roundRect">
+            <a:avLst>
+              <a:gd name="adj" fmla="val 4067"/>
+            </a:avLst>
+          </a:prstGeom>
+          <a:solidFill>
+            <a:srgbClr val="1A1B26"/>
+          </a:solidFill>
+          <a:ln>
+            <a:noFill/>
+          </a:ln>
+          <a:effectLst/>
+        </p:spPr>
+        <p:style>
+          <a:lnRef idx="1">
+            <a:schemeClr val="accent1"/>
+          </a:lnRef>
+          <a:fillRef idx="3">
+            <a:schemeClr val="accent1"/>
+          </a:fillRef>
+          <a:effectRef idx="2">
+            <a:schemeClr val="accent1"/>
+          </a:effectRef>
+          <a:fontRef idx="minor">
+            <a:schemeClr val="lt1"/>
+          </a:fontRef>
+        </p:style>
+        <p:txBody>
+          <a:bodyPr rtlCol="0" anchor="ctr"/>
+          <a:lstStyle/>
+          <a:p>
+            <a:pPr algn="ctr"/>
+            <a:endParaRPr dirty="0"/>
+          </a:p>
+        </p:txBody>
+      </p:sp>
+      <p:pic>
+        <p:nvPicPr>
+          <p:cNvPr id="21" name="Imagen 20">
+            <a:extLst>
+              <a:ext uri="{FF2B5EF4-FFF2-40B4-BE49-F238E27FC236}">
+                <a16:creationId xmlns:a16="http://schemas.microsoft.com/office/drawing/2014/main" id="{D0D8BA4A-1C0B-F821-C7A1-AF3C9FED97DB}"/>
+              </a:ext>
+            </a:extLst>
+          </p:cNvPr>
+          <p:cNvPicPr>
+            <a:picLocks noChangeAspect="1"/>
+          </p:cNvPicPr>
+          <p:nvPr/>
+        </p:nvPicPr>
+        <p:blipFill>
+          <a:blip r:embed="rId2"/>
+          <a:srcRect l="1732" r="2717"/>
+          <a:stretch/>
+        </p:blipFill>
+        <p:spPr>
+          <a:xfrm>
+            <a:off x="634944" y="982980"/>
+            <a:ext cx="6901148" cy="3826895"/>
+          </a:xfrm>
+          <a:prstGeom prst="rect">
+            <a:avLst/>
+          </a:prstGeom>
+        </p:spPr>
+      </p:pic>
+    </p:spTree>
+    <p:extLst>
+      <p:ext uri="{BB962C8B-B14F-4D97-AF65-F5344CB8AC3E}">
+        <p14:creationId xmlns:p14="http://schemas.microsoft.com/office/powerpoint/2010/main" val="73935032"/>
+      </p:ext>
+    </p:extLst>
+  </p:cSld>
+  <p:clrMapOvr>
+    <a:masterClrMapping/>
+  </p:clrMapOvr>
+  <mc:AlternateContent xmlns:mc="http://schemas.openxmlformats.org/markup-compatibility/2006">
+    <mc:Choice xmlns:p14="http://schemas.microsoft.com/office/powerpoint/2010/main" Requires="p14">
+      <p:transition spd="slow" p14:dur="2000">
+        <p:fade/>
+      </p:transition>
+    </mc:Choice>
+    <mc:Fallback>
+      <p:transition spd="slow">
+        <p:fade/>
+      </p:transition>
+    </mc:Fallback>
+  </mc:AlternateContent>
+</p:sld>
+</file>
+
+<file path=ppt/slides/slide12.xml><?xml version="1.0" encoding="utf-8"?>
+<p:sld xmlns:a="http://schemas.openxmlformats.org/drawingml/2006/main" xmlns:r="http://schemas.openxmlformats.org/officeDocument/2006/relationships" xmlns:p="http://schemas.openxmlformats.org/presentationml/2006/main">
+  <p:cSld>
+    <p:bg>
+      <p:bgPr>
+        <a:solidFill>
+          <a:srgbClr val="0F122D"/>
+        </a:solidFill>
+        <a:effectLst/>
+      </p:bgPr>
+    </p:bg>
+    <p:spTree>
+      <p:nvGrpSpPr>
+        <p:cNvPr id="1" name=""/>
+        <p:cNvGrpSpPr/>
+        <p:nvPr/>
+      </p:nvGrpSpPr>
+      <p:grpSpPr>
+        <a:xfrm>
+          <a:off x="0" y="0"/>
+          <a:ext cx="0" cy="0"/>
+          <a:chOff x="0" y="0"/>
+          <a:chExt cx="0" cy="0"/>
+        </a:xfrm>
+      </p:grpSpPr>
+      <p:sp>
+        <p:nvSpPr>
+          <p:cNvPr id="3" name="Elipse 2">
+            <a:extLst>
+              <a:ext uri="{FF2B5EF4-FFF2-40B4-BE49-F238E27FC236}">
+                <a16:creationId xmlns:a16="http://schemas.microsoft.com/office/drawing/2014/main" id="{6C99EE61-333B-7783-D814-D31484674B47}"/>
+              </a:ext>
+            </a:extLst>
+          </p:cNvPr>
+          <p:cNvSpPr/>
+          <p:nvPr/>
+        </p:nvSpPr>
+        <p:spPr>
+          <a:xfrm>
+            <a:off x="7620000" y="-762000"/>
+            <a:ext cx="2476500" cy="2476500"/>
+          </a:xfrm>
+          <a:prstGeom prst="ellipse">
+            <a:avLst/>
+          </a:prstGeom>
+          <a:solidFill>
+            <a:srgbClr val="6473F5">
+              <a:alpha val="20000"/>
+            </a:srgbClr>
+          </a:solidFill>
+          <a:ln w="19050" cap="flat" cmpd="sng" algn="ctr">
+            <a:noFill/>
+            <a:prstDash val="solid"/>
+            <a:miter lim="800000"/>
+          </a:ln>
+          <a:effectLst/>
+          <a:extLst>
+            <a:ext uri="{91240B29-F687-4F45-9708-019B960494DF}">
+              <a14:hiddenLine xmlns:a14="http://schemas.microsoft.com/office/drawing/2010/main" w="19050" cap="flat" cmpd="sng" algn="ctr">
+                <a:solidFill>
+                  <a:schemeClr val="accent1">
+                    <a:shade val="15000"/>
+                  </a:schemeClr>
+                </a:solidFill>
+                <a:prstDash val="solid"/>
+                <a:miter lim="800000"/>
+              </a14:hiddenLine>
+            </a:ext>
+          </a:extLst>
+        </p:spPr>
+        <p:style>
+          <a:lnRef idx="2">
+            <a:schemeClr val="accent1">
+              <a:shade val="15000"/>
+            </a:schemeClr>
+          </a:lnRef>
+          <a:fillRef idx="1">
+            <a:schemeClr val="accent1"/>
+          </a:fillRef>
+          <a:effectRef idx="0">
+            <a:schemeClr val="accent1"/>
+          </a:effectRef>
+          <a:fontRef idx="minor">
+            <a:schemeClr val="lt1"/>
+          </a:fontRef>
+        </p:style>
+        <p:txBody>
+          <a:bodyPr rtlCol="0" anchor="ctr"/>
+          <a:lstStyle/>
+          <a:p>
+            <a:pPr algn="ctr"/>
+            <a:endParaRPr lang="es-CO" sz="1350"/>
+          </a:p>
+        </p:txBody>
+      </p:sp>
+      <p:sp>
+        <p:nvSpPr>
+          <p:cNvPr id="2" name="Título 1">
+            <a:extLst>
+              <a:ext uri="{FF2B5EF4-FFF2-40B4-BE49-F238E27FC236}">
+                <a16:creationId xmlns:a16="http://schemas.microsoft.com/office/drawing/2014/main" id="{061CF72A-16DB-3521-6B3A-546C13096D3E}"/>
               </a:ext>
             </a:extLst>
           </p:cNvPr>
@@ -2666,50 +2443,46 @@
             <a:spLocks noGrp="1"/>
           </p:cNvSpPr>
           <p:nvPr>
-            <p:ph type="sldNum" sz="quarter" idx="4294967295"/>
+            <p:ph type="title"/>
           </p:nvPr>
         </p:nvSpPr>
         <p:spPr>
           <a:xfrm>
-            <a:off x="8321040" y="4754880"/>
-            <a:ext cx="457200" cy="274320"/>
-          </a:xfrm>
-          <a:prstGeom prst="rect">
-            <a:avLst/>
-          </a:prstGeom>
-          <a:extLst>
-            <a:ext uri="{C572A759-6A51-4108-AA02-DFA0A04FC94B}">
-              <ma14:wrappingTextBoxFlag xmlns="" xmlns:ma14="http://schemas.microsoft.com/office/mac/drawingml/2011/main" val="0"/>
-            </a:ext>
-          </a:extLst>
-        </p:spPr>
-        <p:txBody>
-          <a:bodyPr/>
-          <a:lstStyle>
-            <a:lvl1pPr>
-              <a:defRPr sz="1000">
-                <a:solidFill>
-                  <a:schemeClr val="tx1"/>
-                </a:solidFill>
-              </a:defRPr>
-            </a:lvl1pPr>
-          </a:lstStyle>
+            <a:off x="476253" y="238125"/>
+            <a:ext cx="2225383" cy="666750"/>
+          </a:xfrm>
+        </p:spPr>
+        <p:txBody>
+          <a:bodyPr anchor="ctr">
+            <a:normAutofit/>
+          </a:bodyPr>
+          <a:lstStyle/>
           <a:p>
             <a:pPr algn="l"/>
-            <a:fld id="{F7021451-1387-4CA6-816F-3879F97B5CBC}" type="slidenum">
-              <a:rPr lang="en-US" b="0"/>
-              <a:t>11</a:t>
-            </a:fld>
-            <a:endParaRPr lang="en-US"/>
+            <a:r>
+              <a:rPr lang="es-MX" sz="2700" b="1" dirty="0">
+                <a:solidFill>
+                  <a:srgbClr val="FFFFFF"/>
+                </a:solidFill>
+                <a:latin typeface="Calibri" panose="020F0502020204030204" pitchFamily="34" charset="0"/>
+              </a:rPr>
+              <a:t>7. Conclusión</a:t>
+            </a:r>
+            <a:endParaRPr lang="es-CO" sz="2700" b="1" dirty="0">
+              <a:solidFill>
+                <a:srgbClr val="FFFFFF"/>
+              </a:solidFill>
+              <a:latin typeface="Calibri" panose="020F0502020204030204" pitchFamily="34" charset="0"/>
+            </a:endParaRPr>
           </a:p>
         </p:txBody>
       </p:sp>
       <p:graphicFrame>
         <p:nvGraphicFramePr>
-          <p:cNvPr id="24" name="Tabla 23">
+          <p:cNvPr id="4" name="Tabla 3">
             <a:extLst>
               <a:ext uri="{FF2B5EF4-FFF2-40B4-BE49-F238E27FC236}">
-                <a16:creationId xmlns:a16="http://schemas.microsoft.com/office/drawing/2014/main" id="{AD78D5E1-78F2-3259-69A2-4B93809D3F3A}"/>
+                <a16:creationId xmlns:a16="http://schemas.microsoft.com/office/drawing/2014/main" id="{207870B7-4AD4-9A72-12C7-138960EE114F}"/>
               </a:ext>
             </a:extLst>
           </p:cNvPr>
@@ -2719,14 +2492,14 @@
           <p:nvPr>
             <p:extLst>
               <p:ext uri="{D42A27DB-BD31-4B8C-83A1-F6EECF244321}">
-                <p14:modId xmlns:p14="http://schemas.microsoft.com/office/powerpoint/2010/main" val="749578686"/>
+                <p14:modId xmlns:p14="http://schemas.microsoft.com/office/powerpoint/2010/main" val="1237402226"/>
               </p:ext>
             </p:extLst>
           </p:nvPr>
         </p:nvGraphicFramePr>
         <p:xfrm>
-          <a:off x="548640" y="1134110"/>
-          <a:ext cx="7825740" cy="1483360"/>
+          <a:off x="476252" y="1190625"/>
+          <a:ext cx="8069232" cy="2514600"/>
         </p:xfrm>
         <a:graphic>
           <a:graphicData uri="http://schemas.openxmlformats.org/drawingml/2006/table">
@@ -2735,34 +2508,43 @@
                 <a:tableStyleId>{5C22544A-7EE6-4342-B048-85BDC9FD1C3A}</a:tableStyleId>
               </a:tblPr>
               <a:tblGrid>
-                <a:gridCol w="6713220">
+                <a:gridCol w="6523064">
                   <a:extLst>
                     <a:ext uri="{9D8B030D-6E8A-4147-A177-3AD203B41FA5}">
-                      <a16:colId xmlns:a16="http://schemas.microsoft.com/office/drawing/2014/main" val="2693359899"/>
+                      <a16:colId xmlns:a16="http://schemas.microsoft.com/office/drawing/2014/main" val="544620253"/>
                     </a:ext>
                   </a:extLst>
                 </a:gridCol>
-                <a:gridCol w="1112520">
+                <a:gridCol w="1546168">
                   <a:extLst>
                     <a:ext uri="{9D8B030D-6E8A-4147-A177-3AD203B41FA5}">
-                      <a16:colId xmlns:a16="http://schemas.microsoft.com/office/drawing/2014/main" val="112609293"/>
+                      <a16:colId xmlns:a16="http://schemas.microsoft.com/office/drawing/2014/main" val="1056622285"/>
                     </a:ext>
                   </a:extLst>
                 </a:gridCol>
               </a:tblGrid>
-              <a:tr h="370840">
+              <a:tr h="628650">
                 <a:tc>
                   <a:txBody>
                     <a:bodyPr/>
                     <a:lstStyle/>
                     <a:p>
                       <a:r>
-                        <a:rPr lang="es-CO" dirty="0"/>
+                        <a:rPr lang="es-CO" sz="1600" b="1" dirty="0">
+                          <a:solidFill>
+                            <a:srgbClr val="FFFFFF"/>
+                          </a:solidFill>
+                          <a:latin typeface="Calibri" panose="020F0502020204030204" pitchFamily="34" charset="0"/>
+                        </a:rPr>
                         <a:t>Si necesitas</a:t>
                       </a:r>
                     </a:p>
                   </a:txBody>
-                  <a:tcPr/>
+                  <a:tcPr marL="68580" marR="68580" marT="34290" marB="34290" anchor="ctr">
+                    <a:solidFill>
+                      <a:srgbClr val="6473F5"/>
+                    </a:solidFill>
+                  </a:tcPr>
                 </a:tc>
                 <a:tc>
                   <a:txBody>
@@ -2770,41 +2552,50 @@
                     <a:lstStyle/>
                     <a:p>
                       <a:r>
-                        <a:rPr lang="es-CO" dirty="0"/>
+                        <a:rPr lang="es-CO" sz="1600" b="1" dirty="0">
+                          <a:solidFill>
+                            <a:srgbClr val="FFFFFF"/>
+                          </a:solidFill>
+                          <a:latin typeface="Calibri" panose="020F0502020204030204" pitchFamily="34" charset="0"/>
+                        </a:rPr>
                         <a:t>Usa</a:t>
                       </a:r>
                     </a:p>
                   </a:txBody>
-                  <a:tcPr/>
+                  <a:tcPr marL="68580" marR="68580" marT="34290" marB="34290" anchor="ctr">
+                    <a:solidFill>
+                      <a:srgbClr val="6473F5"/>
+                    </a:solidFill>
+                  </a:tcPr>
                 </a:tc>
                 <a:extLst>
                   <a:ext uri="{0D108BD9-81ED-4DB2-BD59-A6C34878D82A}">
-                    <a16:rowId xmlns:a16="http://schemas.microsoft.com/office/drawing/2014/main" val="3152399151"/>
+                    <a16:rowId xmlns:a16="http://schemas.microsoft.com/office/drawing/2014/main" val="11585898"/>
                   </a:ext>
                 </a:extLst>
               </a:tr>
-              <a:tr h="370840">
+              <a:tr h="628650">
                 <a:tc>
                   <a:txBody>
                     <a:bodyPr/>
                     <a:lstStyle/>
                     <a:p>
                       <a:r>
-                        <a:rPr lang="es-CO" sz="1800" b="0" i="0" kern="1200" dirty="0">
+                        <a:rPr lang="es-CO" sz="1600" b="1" dirty="0">
                           <a:solidFill>
-                            <a:schemeClr val="dk1"/>
+                            <a:srgbClr val="FFFFFF"/>
                           </a:solidFill>
-                          <a:effectLst/>
-                          <a:latin typeface="+mn-lt"/>
-                          <a:ea typeface="+mn-ea"/>
-                          <a:cs typeface="+mn-cs"/>
+                          <a:latin typeface="Calibri" panose="020F0502020204030204" pitchFamily="34" charset="0"/>
                         </a:rPr>
                         <a:t>Integrar sistemas o equipos independientes que escalan por separado</a:t>
                       </a:r>
-                      <a:endParaRPr lang="es-CO" sz="1600" dirty="0"/>
                     </a:p>
                   </a:txBody>
-                  <a:tcPr/>
+                  <a:tcPr marL="68580" marR="68580" marT="34290" marB="34290" anchor="ctr">
+                    <a:solidFill>
+                      <a:srgbClr val="303878"/>
+                    </a:solidFill>
+                  </a:tcPr>
                 </a:tc>
                 <a:tc>
                   <a:txBody>
@@ -2812,41 +2603,56 @@
                     <a:lstStyle/>
                     <a:p>
                       <a:r>
-                        <a:rPr lang="es-CO" sz="1600" dirty="0"/>
-                        <a:t>Soa</a:t>
+                        <a:rPr lang="es-CO" sz="1600" b="0" dirty="0">
+                          <a:solidFill>
+                            <a:srgbClr val="FFFFFF"/>
+                          </a:solidFill>
+                          <a:latin typeface="Calibri" panose="020F0502020204030204" pitchFamily="34" charset="0"/>
+                        </a:rPr>
+                        <a:t>SOA</a:t>
                       </a:r>
                     </a:p>
                   </a:txBody>
-                  <a:tcPr/>
+                  <a:tcPr marL="68580" marR="68580" marT="34290" marB="34290" anchor="ctr">
+                    <a:solidFill>
+                      <a:srgbClr val="202658"/>
+                    </a:solidFill>
+                  </a:tcPr>
                 </a:tc>
                 <a:extLst>
                   <a:ext uri="{0D108BD9-81ED-4DB2-BD59-A6C34878D82A}">
-                    <a16:rowId xmlns:a16="http://schemas.microsoft.com/office/drawing/2014/main" val="2681534231"/>
+                    <a16:rowId xmlns:a16="http://schemas.microsoft.com/office/drawing/2014/main" val="716793442"/>
                   </a:ext>
                 </a:extLst>
               </a:tr>
-              <a:tr h="370840">
+              <a:tr h="628650">
                 <a:tc>
                   <a:txBody>
                     <a:bodyPr/>
                     <a:lstStyle/>
                     <a:p>
                       <a:r>
-                        <a:rPr lang="es-CO" sz="1800" b="0" i="0" kern="1200" dirty="0">
+                        <a:rPr lang="es-MX" sz="1600" b="1" dirty="0">
                           <a:solidFill>
-                            <a:schemeClr val="dk1"/>
+                            <a:srgbClr val="FFFFFF"/>
                           </a:solidFill>
-                          <a:effectLst/>
-                          <a:latin typeface="+mn-lt"/>
-                          <a:ea typeface="+mn-ea"/>
-                          <a:cs typeface="+mn-cs"/>
+                          <a:latin typeface="Calibri" panose="020F0502020204030204" pitchFamily="34" charset="0"/>
                         </a:rPr>
                         <a:t>Que varios objetos reaccionen a un cambio de estado</a:t>
                       </a:r>
-                      <a:endParaRPr lang="es-CO" sz="1600" dirty="0"/>
+                      <a:endParaRPr lang="es-CO" sz="1600" b="1" dirty="0">
+                        <a:solidFill>
+                          <a:srgbClr val="FFFFFF"/>
+                        </a:solidFill>
+                        <a:latin typeface="Calibri" panose="020F0502020204030204" pitchFamily="34" charset="0"/>
+                      </a:endParaRPr>
                     </a:p>
                   </a:txBody>
-                  <a:tcPr/>
+                  <a:tcPr marL="68580" marR="68580" marT="34290" marB="34290" anchor="ctr">
+                    <a:solidFill>
+                      <a:srgbClr val="303878"/>
+                    </a:solidFill>
+                  </a:tcPr>
                 </a:tc>
                 <a:tc>
                   <a:txBody>
@@ -2854,42 +2660,62 @@
                     <a:lstStyle/>
                     <a:p>
                       <a:r>
-                        <a:rPr lang="es-CO" sz="1600" dirty="0" err="1"/>
+                        <a:rPr lang="es-MX" sz="1600" b="0" dirty="0" err="1">
+                          <a:solidFill>
+                            <a:srgbClr val="FFFFFF"/>
+                          </a:solidFill>
+                          <a:latin typeface="Calibri" panose="020F0502020204030204" pitchFamily="34" charset="0"/>
+                        </a:rPr>
                         <a:t>Observer</a:t>
                       </a:r>
-                      <a:endParaRPr lang="es-CO" sz="1600" dirty="0"/>
+                      <a:endParaRPr lang="es-CO" sz="1600" b="0" dirty="0">
+                        <a:solidFill>
+                          <a:srgbClr val="FFFFFF"/>
+                        </a:solidFill>
+                        <a:latin typeface="Calibri" panose="020F0502020204030204" pitchFamily="34" charset="0"/>
+                      </a:endParaRPr>
                     </a:p>
                   </a:txBody>
-                  <a:tcPr/>
+                  <a:tcPr marL="68580" marR="68580" marT="34290" marB="34290" anchor="ctr">
+                    <a:solidFill>
+                      <a:srgbClr val="1A1F48"/>
+                    </a:solidFill>
+                  </a:tcPr>
                 </a:tc>
                 <a:extLst>
                   <a:ext uri="{0D108BD9-81ED-4DB2-BD59-A6C34878D82A}">
-                    <a16:rowId xmlns:a16="http://schemas.microsoft.com/office/drawing/2014/main" val="1645957312"/>
+                    <a16:rowId xmlns:a16="http://schemas.microsoft.com/office/drawing/2014/main" val="1394721793"/>
                   </a:ext>
                 </a:extLst>
               </a:tr>
-              <a:tr h="370840">
+              <a:tr h="628650">
                 <a:tc>
                   <a:txBody>
                     <a:bodyPr/>
                     <a:lstStyle/>
                     <a:p>
                       <a:r>
-                        <a:rPr lang="es-CO" sz="1800" b="0" i="0" kern="1200" dirty="0">
+                        <a:rPr lang="es-MX" sz="1600" b="1" dirty="0">
                           <a:solidFill>
-                            <a:schemeClr val="dk1"/>
+                            <a:srgbClr val="FFFFFF"/>
                           </a:solidFill>
-                          <a:effectLst/>
-                          <a:latin typeface="+mn-lt"/>
-                          <a:ea typeface="+mn-ea"/>
-                          <a:cs typeface="+mn-cs"/>
+                          <a:latin typeface="Calibri" panose="020F0502020204030204" pitchFamily="34" charset="0"/>
                         </a:rPr>
                         <a:t>Coordinar muchos componentes que hoy se llaman entre sí</a:t>
                       </a:r>
-                      <a:endParaRPr lang="es-CO" sz="1600" dirty="0"/>
+                      <a:endParaRPr lang="es-CO" sz="1600" b="1" dirty="0">
+                        <a:solidFill>
+                          <a:srgbClr val="FFFFFF"/>
+                        </a:solidFill>
+                        <a:latin typeface="Calibri" panose="020F0502020204030204" pitchFamily="34" charset="0"/>
+                      </a:endParaRPr>
                     </a:p>
                   </a:txBody>
-                  <a:tcPr/>
+                  <a:tcPr marL="68580" marR="68580" marT="34290" marB="34290" anchor="ctr">
+                    <a:solidFill>
+                      <a:srgbClr val="303878"/>
+                    </a:solidFill>
+                  </a:tcPr>
                 </a:tc>
                 <a:tc>
                   <a:txBody>
@@ -2897,25 +2723,31 @@
                     <a:lstStyle/>
                     <a:p>
                       <a:r>
-                        <a:rPr lang="es-CO" sz="1600" b="0" i="0" kern="1200" dirty="0">
+                        <a:rPr lang="es-MX" sz="1600" b="0" dirty="0">
                           <a:solidFill>
-                            <a:schemeClr val="dk1"/>
+                            <a:srgbClr val="FFFFFF"/>
                           </a:solidFill>
-                          <a:effectLst/>
-                          <a:latin typeface="+mn-lt"/>
-                          <a:ea typeface="+mn-ea"/>
-                          <a:cs typeface="+mn-cs"/>
+                          <a:latin typeface="Calibri" panose="020F0502020204030204" pitchFamily="34" charset="0"/>
                         </a:rPr>
                         <a:t>Mediator</a:t>
                       </a:r>
-                      <a:endParaRPr lang="es-CO" sz="1600" dirty="0"/>
+                      <a:endParaRPr lang="es-CO" sz="1600" b="0" dirty="0">
+                        <a:solidFill>
+                          <a:srgbClr val="FFFFFF"/>
+                        </a:solidFill>
+                        <a:latin typeface="Calibri" panose="020F0502020204030204" pitchFamily="34" charset="0"/>
+                      </a:endParaRPr>
                     </a:p>
                   </a:txBody>
-                  <a:tcPr/>
+                  <a:tcPr marL="68580" marR="68580" marT="34290" marB="34290" anchor="ctr">
+                    <a:solidFill>
+                      <a:srgbClr val="202658"/>
+                    </a:solidFill>
+                  </a:tcPr>
                 </a:tc>
                 <a:extLst>
                   <a:ext uri="{0D108BD9-81ED-4DB2-BD59-A6C34878D82A}">
-                    <a16:rowId xmlns:a16="http://schemas.microsoft.com/office/drawing/2014/main" val="2328104132"/>
+                    <a16:rowId xmlns:a16="http://schemas.microsoft.com/office/drawing/2014/main" val="4167621331"/>
                   </a:ext>
                 </a:extLst>
               </a:tr>
@@ -2925,70 +2757,261 @@
       </p:graphicFrame>
       <p:sp>
         <p:nvSpPr>
-          <p:cNvPr id="4" name="Text 4">
+          <p:cNvPr id="5" name="Rectángulo: esquinas redondeadas 4">
             <a:extLst>
               <a:ext uri="{FF2B5EF4-FFF2-40B4-BE49-F238E27FC236}">
-                <a16:creationId xmlns:a16="http://schemas.microsoft.com/office/drawing/2014/main" id="{5F80D3CE-653D-9CD9-D860-8D67725B51D6}"/>
+                <a16:creationId xmlns:a16="http://schemas.microsoft.com/office/drawing/2014/main" id="{5F5454D4-CD26-3A8C-F9B5-CA359EC50FC5}"/>
               </a:ext>
             </a:extLst>
           </p:cNvPr>
-          <p:cNvSpPr txBox="1"/>
+          <p:cNvSpPr/>
           <p:nvPr/>
         </p:nvSpPr>
         <p:spPr>
           <a:xfrm>
-            <a:off x="601980" y="2837181"/>
-            <a:ext cx="8176260" cy="332740"/>
-          </a:xfrm>
-          <a:prstGeom prst="rect">
-            <a:avLst/>
-          </a:prstGeom>
-          <a:noFill/>
-          <a:ln/>
-        </p:spPr>
-        <p:txBody>
-          <a:bodyPr wrap="square" lIns="0" tIns="0" rIns="0" bIns="0" rtlCol="0" anchor="t"/>
-          <a:lstStyle/>
-          <a:p>
-            <a:pPr>
-              <a:spcAft>
-                <a:spcPts val="500"/>
-              </a:spcAft>
-            </a:pPr>
-            <a:r>
-              <a:rPr lang="es-CO" sz="1600" b="1" dirty="0">
-                <a:solidFill>
-                  <a:schemeClr val="tx2"/>
-                </a:solidFill>
-              </a:rPr>
-              <a:t>No compiten:</a:t>
-            </a:r>
-            <a:r>
-              <a:rPr lang="es-CO" sz="1600" dirty="0"/>
-              <a:t> se combinan. SOA organiza el sistema; </a:t>
-            </a:r>
-            <a:r>
-              <a:rPr lang="es-CO" sz="1600" dirty="0" err="1"/>
+            <a:off x="476252" y="3924300"/>
+            <a:ext cx="8069232" cy="781050"/>
+          </a:xfrm>
+          <a:prstGeom prst="roundRect">
+            <a:avLst>
+              <a:gd name="adj" fmla="val 15000"/>
+            </a:avLst>
+          </a:prstGeom>
+          <a:solidFill>
+            <a:srgbClr val="202658"/>
+          </a:solidFill>
+          <a:ln w="19050" cap="flat" cmpd="sng" algn="ctr">
+            <a:noFill/>
+            <a:prstDash val="solid"/>
+            <a:miter lim="800000"/>
+          </a:ln>
+          <a:effectLst/>
+          <a:extLst>
+            <a:ext uri="{91240B29-F687-4F45-9708-019B960494DF}">
+              <a14:hiddenLine xmlns:a14="http://schemas.microsoft.com/office/drawing/2010/main" w="19050" cap="flat" cmpd="sng" algn="ctr">
+                <a:solidFill>
+                  <a:schemeClr val="accent1">
+                    <a:shade val="15000"/>
+                  </a:schemeClr>
+                </a:solidFill>
+                <a:prstDash val="solid"/>
+                <a:miter lim="800000"/>
+              </a14:hiddenLine>
+            </a:ext>
+          </a:extLst>
+        </p:spPr>
+        <p:style>
+          <a:lnRef idx="2">
+            <a:schemeClr val="accent1">
+              <a:shade val="15000"/>
+            </a:schemeClr>
+          </a:lnRef>
+          <a:fillRef idx="1">
+            <a:schemeClr val="accent1"/>
+          </a:fillRef>
+          <a:effectRef idx="0">
+            <a:schemeClr val="accent1"/>
+          </a:effectRef>
+          <a:fontRef idx="minor">
+            <a:schemeClr val="lt1"/>
+          </a:fontRef>
+        </p:style>
+        <p:txBody>
+          <a:bodyPr rtlCol="0" anchor="ctr"/>
+          <a:lstStyle/>
+          <a:p>
+            <a:pPr algn="ctr"/>
+            <a:r>
+              <a:rPr lang="es-MX" sz="1600" dirty="0">
+                <a:solidFill>
+                  <a:srgbClr val="FFC000"/>
+                </a:solidFill>
+                <a:latin typeface="Calibri" panose="020F0502020204030204" pitchFamily="34" charset="0"/>
+              </a:rPr>
+              <a:t>No compiten: se combinan. SOA organiza el sistema; </a:t>
+            </a:r>
+            <a:r>
+              <a:rPr lang="es-MX" sz="1600" dirty="0" err="1">
+                <a:solidFill>
+                  <a:srgbClr val="FFC000"/>
+                </a:solidFill>
+                <a:latin typeface="Calibri" panose="020F0502020204030204" pitchFamily="34" charset="0"/>
+              </a:rPr>
               <a:t>Observer</a:t>
             </a:r>
             <a:r>
-              <a:rPr lang="es-CO" sz="1600" dirty="0"/>
+              <a:rPr lang="es-MX" sz="1600" dirty="0">
+                <a:solidFill>
+                  <a:srgbClr val="FFC000"/>
+                </a:solidFill>
+                <a:latin typeface="Calibri" panose="020F0502020204030204" pitchFamily="34" charset="0"/>
+              </a:rPr>
               <a:t> y Mediator organizan su código.</a:t>
             </a:r>
-            <a:endParaRPr lang="en-US" sz="1600" dirty="0"/>
+            <a:endParaRPr lang="es-CO" sz="1600" dirty="0">
+              <a:solidFill>
+                <a:srgbClr val="FFC000"/>
+              </a:solidFill>
+              <a:latin typeface="Calibri" panose="020F0502020204030204" pitchFamily="34" charset="0"/>
+            </a:endParaRPr>
           </a:p>
         </p:txBody>
       </p:sp>
     </p:spTree>
     <p:extLst>
       <p:ext uri="{BB962C8B-B14F-4D97-AF65-F5344CB8AC3E}">
-        <p14:creationId xmlns:p14="http://schemas.microsoft.com/office/powerpoint/2010/main" val="2195922143"/>
+        <p14:creationId xmlns:p14="http://schemas.microsoft.com/office/powerpoint/2010/main" val="1017533656"/>
       </p:ext>
     </p:extLst>
   </p:cSld>
   <p:clrMapOvr>
     <a:masterClrMapping/>
   </p:clrMapOvr>
+  <mc:AlternateContent xmlns:mc="http://schemas.openxmlformats.org/markup-compatibility/2006" xmlns:p14="http://schemas.microsoft.com/office/powerpoint/2010/main">
+    <mc:Choice Requires="p14">
+      <p:transition spd="slow" p14:dur="2000">
+        <p:fade/>
+      </p:transition>
+    </mc:Choice>
+    <mc:Fallback xmlns="">
+      <p:transition spd="slow">
+        <p:fade/>
+      </p:transition>
+    </mc:Fallback>
+  </mc:AlternateContent>
+  <p:timing>
+    <p:tnLst>
+      <p:par>
+        <p:cTn id="1" dur="indefinite" restart="never" nodeType="tmRoot">
+          <p:childTnLst>
+            <p:seq concurrent="1" nextAc="seek">
+              <p:cTn id="2" dur="indefinite" nodeType="mainSeq">
+                <p:childTnLst>
+                  <p:par>
+                    <p:cTn id="3" fill="hold">
+                      <p:stCondLst>
+                        <p:cond delay="indefinite"/>
+                        <p:cond evt="onBegin" delay="0">
+                          <p:tn val="2"/>
+                        </p:cond>
+                      </p:stCondLst>
+                      <p:childTnLst>
+                        <p:par>
+                          <p:cTn id="4" fill="hold">
+                            <p:stCondLst>
+                              <p:cond delay="0"/>
+                            </p:stCondLst>
+                            <p:childTnLst>
+                              <p:par>
+                                <p:cTn id="5" presetID="10" presetClass="entr" presetSubtype="0" fill="hold" nodeType="afterEffect">
+                                  <p:stCondLst>
+                                    <p:cond delay="0"/>
+                                  </p:stCondLst>
+                                  <p:childTnLst>
+                                    <p:set>
+                                      <p:cBhvr>
+                                        <p:cTn id="6" dur="1" fill="hold">
+                                          <p:stCondLst>
+                                            <p:cond delay="0"/>
+                                          </p:stCondLst>
+                                        </p:cTn>
+                                        <p:tgtEl>
+                                          <p:spTgt spid="4"/>
+                                        </p:tgtEl>
+                                        <p:attrNameLst>
+                                          <p:attrName>style.visibility</p:attrName>
+                                        </p:attrNameLst>
+                                      </p:cBhvr>
+                                      <p:to>
+                                        <p:strVal val="visible"/>
+                                      </p:to>
+                                    </p:set>
+                                    <p:animEffect transition="in" filter="fade">
+                                      <p:cBhvr>
+                                        <p:cTn id="7" dur="500"/>
+                                        <p:tgtEl>
+                                          <p:spTgt spid="4"/>
+                                        </p:tgtEl>
+                                      </p:cBhvr>
+                                    </p:animEffect>
+                                  </p:childTnLst>
+                                </p:cTn>
+                              </p:par>
+                            </p:childTnLst>
+                          </p:cTn>
+                        </p:par>
+                        <p:par>
+                          <p:cTn id="8" fill="hold">
+                            <p:stCondLst>
+                              <p:cond delay="500"/>
+                            </p:stCondLst>
+                            <p:childTnLst>
+                              <p:par>
+                                <p:cTn id="9" presetID="10" presetClass="entr" presetSubtype="0" fill="hold" grpId="0" nodeType="afterEffect">
+                                  <p:stCondLst>
+                                    <p:cond delay="0"/>
+                                  </p:stCondLst>
+                                  <p:childTnLst>
+                                    <p:set>
+                                      <p:cBhvr>
+                                        <p:cTn id="10" dur="1" fill="hold">
+                                          <p:stCondLst>
+                                            <p:cond delay="0"/>
+                                          </p:stCondLst>
+                                        </p:cTn>
+                                        <p:tgtEl>
+                                          <p:spTgt spid="5"/>
+                                        </p:tgtEl>
+                                        <p:attrNameLst>
+                                          <p:attrName>style.visibility</p:attrName>
+                                        </p:attrNameLst>
+                                      </p:cBhvr>
+                                      <p:to>
+                                        <p:strVal val="visible"/>
+                                      </p:to>
+                                    </p:set>
+                                    <p:animEffect transition="in" filter="fade">
+                                      <p:cBhvr>
+                                        <p:cTn id="11" dur="500"/>
+                                        <p:tgtEl>
+                                          <p:spTgt spid="5"/>
+                                        </p:tgtEl>
+                                      </p:cBhvr>
+                                    </p:animEffect>
+                                  </p:childTnLst>
+                                </p:cTn>
+                              </p:par>
+                            </p:childTnLst>
+                          </p:cTn>
+                        </p:par>
+                      </p:childTnLst>
+                    </p:cTn>
+                  </p:par>
+                </p:childTnLst>
+              </p:cTn>
+              <p:prevCondLst>
+                <p:cond evt="onPrev" delay="0">
+                  <p:tgtEl>
+                    <p:sldTgt/>
+                  </p:tgtEl>
+                </p:cond>
+              </p:prevCondLst>
+              <p:nextCondLst>
+                <p:cond evt="onNext" delay="0">
+                  <p:tgtEl>
+                    <p:sldTgt/>
+                  </p:tgtEl>
+                </p:cond>
+              </p:nextCondLst>
+            </p:seq>
+          </p:childTnLst>
+        </p:cTn>
+      </p:par>
+    </p:tnLst>
+    <p:bldLst>
+      <p:bldP spid="5" grpId="0" animBg="1"/>
+    </p:bldLst>
+  </p:timing>
 </p:sld>
 </file>
 
@@ -3420,7 +3443,7 @@
           </a:prstGeom>
           <a:extLst>
             <a:ext uri="{C572A759-6A51-4108-AA02-DFA0A04FC94B}">
-              <ma14:wrappingTextBoxFlag xmlns="" xmlns:ma14="http://schemas.microsoft.com/office/mac/drawingml/2011/main" val="0"/>
+              <ma14:wrappingTextBoxFlag xmlns:ma14="http://schemas.microsoft.com/office/mac/drawingml/2011/main" xmlns="" val="0"/>
             </a:ext>
           </a:extLst>
         </p:spPr>
@@ -3896,7 +3919,7 @@
           </a:prstGeom>
           <a:extLst>
             <a:ext uri="{C572A759-6A51-4108-AA02-DFA0A04FC94B}">
-              <ma14:wrappingTextBoxFlag xmlns="" xmlns:ma14="http://schemas.microsoft.com/office/mac/drawingml/2011/main" val="0"/>
+              <ma14:wrappingTextBoxFlag xmlns:ma14="http://schemas.microsoft.com/office/mac/drawingml/2011/main" xmlns="" val="0"/>
             </a:ext>
           </a:extLst>
         </p:spPr>
@@ -4632,7 +4655,7 @@
           </a:prstGeom>
           <a:extLst>
             <a:ext uri="{C572A759-6A51-4108-AA02-DFA0A04FC94B}">
-              <ma14:wrappingTextBoxFlag xmlns="" xmlns:ma14="http://schemas.microsoft.com/office/mac/drawingml/2011/main" val="0"/>
+              <ma14:wrappingTextBoxFlag xmlns:ma14="http://schemas.microsoft.com/office/mac/drawingml/2011/main" xmlns="" val="0"/>
             </a:ext>
           </a:extLst>
         </p:spPr>
@@ -4666,6 +4689,258 @@
 </file>
 
 <file path=ppt/slides/slide5.xml><?xml version="1.0" encoding="utf-8"?>
+<p:sld xmlns:a="http://schemas.openxmlformats.org/drawingml/2006/main" xmlns:r="http://schemas.openxmlformats.org/officeDocument/2006/relationships" xmlns:p="http://schemas.openxmlformats.org/presentationml/2006/main">
+  <p:cSld>
+    <p:bg>
+      <p:bgPr>
+        <a:solidFill>
+          <a:srgbClr val="0F122D"/>
+        </a:solidFill>
+        <a:effectLst/>
+      </p:bgPr>
+    </p:bg>
+    <p:spTree>
+      <p:nvGrpSpPr>
+        <p:cNvPr id="1" name=""/>
+        <p:cNvGrpSpPr/>
+        <p:nvPr/>
+      </p:nvGrpSpPr>
+      <p:grpSpPr>
+        <a:xfrm>
+          <a:off x="0" y="0"/>
+          <a:ext cx="0" cy="0"/>
+          <a:chOff x="0" y="0"/>
+          <a:chExt cx="0" cy="0"/>
+        </a:xfrm>
+      </p:grpSpPr>
+      <p:sp>
+        <p:nvSpPr>
+          <p:cNvPr id="3" name="Elipse 2">
+            <a:extLst>
+              <a:ext uri="{FF2B5EF4-FFF2-40B4-BE49-F238E27FC236}">
+                <a16:creationId xmlns:a16="http://schemas.microsoft.com/office/drawing/2014/main" id="{5FA4C54D-F8F7-667D-27BC-8658065CB91A}"/>
+              </a:ext>
+            </a:extLst>
+          </p:cNvPr>
+          <p:cNvSpPr/>
+          <p:nvPr/>
+        </p:nvSpPr>
+        <p:spPr>
+          <a:xfrm>
+            <a:off x="7620000" y="-762000"/>
+            <a:ext cx="2476500" cy="2476500"/>
+          </a:xfrm>
+          <a:prstGeom prst="ellipse">
+            <a:avLst/>
+          </a:prstGeom>
+          <a:solidFill>
+            <a:srgbClr val="6473F5">
+              <a:alpha val="20000"/>
+            </a:srgbClr>
+          </a:solidFill>
+          <a:ln w="19050" cap="flat" cmpd="sng" algn="ctr">
+            <a:noFill/>
+            <a:prstDash val="solid"/>
+            <a:miter lim="800000"/>
+          </a:ln>
+          <a:effectLst/>
+          <a:extLst>
+            <a:ext uri="{91240B29-F687-4F45-9708-019B960494DF}">
+              <a14:hiddenLine xmlns:a14="http://schemas.microsoft.com/office/drawing/2010/main" w="19050" cap="flat" cmpd="sng" algn="ctr">
+                <a:solidFill>
+                  <a:schemeClr val="accent1">
+                    <a:shade val="15000"/>
+                  </a:schemeClr>
+                </a:solidFill>
+                <a:prstDash val="solid"/>
+                <a:miter lim="800000"/>
+              </a14:hiddenLine>
+            </a:ext>
+          </a:extLst>
+        </p:spPr>
+        <p:style>
+          <a:lnRef idx="2">
+            <a:schemeClr val="accent1">
+              <a:shade val="15000"/>
+            </a:schemeClr>
+          </a:lnRef>
+          <a:fillRef idx="1">
+            <a:schemeClr val="accent1"/>
+          </a:fillRef>
+          <a:effectRef idx="0">
+            <a:schemeClr val="accent1"/>
+          </a:effectRef>
+          <a:fontRef idx="minor">
+            <a:schemeClr val="lt1"/>
+          </a:fontRef>
+        </p:style>
+        <p:txBody>
+          <a:bodyPr rtlCol="0" anchor="ctr"/>
+          <a:lstStyle/>
+          <a:p>
+            <a:pPr algn="ctr"/>
+            <a:endParaRPr lang="es-CO" sz="1350"/>
+          </a:p>
+        </p:txBody>
+      </p:sp>
+      <p:sp>
+        <p:nvSpPr>
+          <p:cNvPr id="2" name="Título 1">
+            <a:extLst>
+              <a:ext uri="{FF2B5EF4-FFF2-40B4-BE49-F238E27FC236}">
+                <a16:creationId xmlns:a16="http://schemas.microsoft.com/office/drawing/2014/main" id="{E7116F78-536A-8DEB-2C90-7E0E23F1D148}"/>
+              </a:ext>
+            </a:extLst>
+          </p:cNvPr>
+          <p:cNvSpPr>
+            <a:spLocks noGrp="1"/>
+          </p:cNvSpPr>
+          <p:nvPr>
+            <p:ph type="title"/>
+          </p:nvPr>
+        </p:nvSpPr>
+        <p:spPr>
+          <a:xfrm>
+            <a:off x="476250" y="238125"/>
+            <a:ext cx="7620000" cy="666750"/>
+          </a:xfrm>
+        </p:spPr>
+        <p:txBody>
+          <a:bodyPr anchor="ctr">
+            <a:normAutofit/>
+          </a:bodyPr>
+          <a:lstStyle/>
+          <a:p>
+            <a:pPr algn="l"/>
+            <a:r>
+              <a:rPr lang="es-MX" sz="2700" b="1" dirty="0">
+                <a:solidFill>
+                  <a:srgbClr val="FFFFFF"/>
+                </a:solidFill>
+                <a:latin typeface="Calibri" panose="020F0502020204030204" pitchFamily="34" charset="0"/>
+              </a:rPr>
+              <a:t>6</a:t>
+            </a:r>
+            <a:r>
+              <a:rPr lang="es-CO" sz="2700" b="1" dirty="0">
+                <a:solidFill>
+                  <a:srgbClr val="FFFFFF"/>
+                </a:solidFill>
+                <a:latin typeface="Calibri" panose="020F0502020204030204" pitchFamily="34" charset="0"/>
+              </a:rPr>
+              <a:t>. Demostración SOA</a:t>
+            </a:r>
+          </a:p>
+        </p:txBody>
+      </p:sp>
+      <p:sp>
+        <p:nvSpPr>
+          <p:cNvPr id="24" name="Rounded Rectangle 2">
+            <a:extLst>
+              <a:ext uri="{FF2B5EF4-FFF2-40B4-BE49-F238E27FC236}">
+                <a16:creationId xmlns:a16="http://schemas.microsoft.com/office/drawing/2014/main" id="{251F3E1A-00CD-40F5-8C3B-ED106DFDCE14}"/>
+              </a:ext>
+            </a:extLst>
+          </p:cNvPr>
+          <p:cNvSpPr/>
+          <p:nvPr/>
+        </p:nvSpPr>
+        <p:spPr>
+          <a:xfrm>
+            <a:off x="389113" y="904875"/>
+            <a:ext cx="8278637" cy="3143250"/>
+          </a:xfrm>
+          <a:prstGeom prst="roundRect">
+            <a:avLst>
+              <a:gd name="adj" fmla="val 4067"/>
+            </a:avLst>
+          </a:prstGeom>
+          <a:solidFill>
+            <a:srgbClr val="1A1B26"/>
+          </a:solidFill>
+          <a:ln>
+            <a:noFill/>
+          </a:ln>
+          <a:effectLst/>
+        </p:spPr>
+        <p:style>
+          <a:lnRef idx="1">
+            <a:schemeClr val="accent1"/>
+          </a:lnRef>
+          <a:fillRef idx="3">
+            <a:schemeClr val="accent1"/>
+          </a:fillRef>
+          <a:effectRef idx="2">
+            <a:schemeClr val="accent1"/>
+          </a:effectRef>
+          <a:fontRef idx="minor">
+            <a:schemeClr val="lt1"/>
+          </a:fontRef>
+        </p:style>
+        <p:txBody>
+          <a:bodyPr rtlCol="0" anchor="ctr"/>
+          <a:lstStyle/>
+          <a:p>
+            <a:pPr algn="ctr"/>
+            <a:endParaRPr dirty="0"/>
+          </a:p>
+        </p:txBody>
+      </p:sp>
+      <p:pic>
+        <p:nvPicPr>
+          <p:cNvPr id="5" name="Imagen 4">
+            <a:extLst>
+              <a:ext uri="{FF2B5EF4-FFF2-40B4-BE49-F238E27FC236}">
+                <a16:creationId xmlns:a16="http://schemas.microsoft.com/office/drawing/2014/main" id="{445EDA06-79F8-310E-8954-BFAD8F5E2927}"/>
+              </a:ext>
+            </a:extLst>
+          </p:cNvPr>
+          <p:cNvPicPr>
+            <a:picLocks noChangeAspect="1"/>
+          </p:cNvPicPr>
+          <p:nvPr/>
+        </p:nvPicPr>
+        <p:blipFill>
+          <a:blip r:embed="rId2"/>
+          <a:srcRect l="6094" t="14697" r="6094" b="16050"/>
+          <a:stretch/>
+        </p:blipFill>
+        <p:spPr>
+          <a:xfrm>
+            <a:off x="476250" y="1095375"/>
+            <a:ext cx="8029575" cy="2571750"/>
+          </a:xfrm>
+          <a:prstGeom prst="rect">
+            <a:avLst/>
+          </a:prstGeom>
+        </p:spPr>
+      </p:pic>
+    </p:spTree>
+    <p:extLst>
+      <p:ext uri="{BB962C8B-B14F-4D97-AF65-F5344CB8AC3E}">
+        <p14:creationId xmlns:p14="http://schemas.microsoft.com/office/powerpoint/2010/main" val="3891155880"/>
+      </p:ext>
+    </p:extLst>
+  </p:cSld>
+  <p:clrMapOvr>
+    <a:masterClrMapping/>
+  </p:clrMapOvr>
+  <mc:AlternateContent xmlns:mc="http://schemas.openxmlformats.org/markup-compatibility/2006">
+    <mc:Choice xmlns:p14="http://schemas.microsoft.com/office/powerpoint/2010/main" Requires="p14">
+      <p:transition spd="slow" p14:dur="2000">
+        <p:fade/>
+      </p:transition>
+    </mc:Choice>
+    <mc:Fallback>
+      <p:transition spd="slow">
+        <p:fade/>
+      </p:transition>
+    </mc:Fallback>
+  </mc:AlternateContent>
+</p:sld>
+</file>
+
+<file path=ppt/slides/slide6.xml><?xml version="1.0" encoding="utf-8"?>
 <p:sld xmlns:a="http://schemas.openxmlformats.org/drawingml/2006/main" xmlns:r="http://schemas.openxmlformats.org/officeDocument/2006/relationships" xmlns:p="http://schemas.openxmlformats.org/presentationml/2006/main">
   <p:cSld>
     <p:spTree>
@@ -4747,7 +5022,7 @@
 </p:sld>
 </file>
 
-<file path=ppt/slides/slide6.xml><?xml version="1.0" encoding="utf-8"?>
+<file path=ppt/slides/slide7.xml><?xml version="1.0" encoding="utf-8"?>
 <p:sld xmlns:a="http://schemas.openxmlformats.org/drawingml/2006/main" xmlns:r="http://schemas.openxmlformats.org/officeDocument/2006/relationships" xmlns:p="http://schemas.openxmlformats.org/presentationml/2006/main">
   <p:cSld name="Slide 6">
     <p:spTree>
@@ -5186,7 +5461,7 @@
           </a:prstGeom>
           <a:extLst>
             <a:ext uri="{C572A759-6A51-4108-AA02-DFA0A04FC94B}">
-              <ma14:wrappingTextBoxFlag xmlns="" xmlns:ma14="http://schemas.microsoft.com/office/mac/drawingml/2011/main" val="0"/>
+              <ma14:wrappingTextBoxFlag xmlns:ma14="http://schemas.microsoft.com/office/mac/drawingml/2011/main" xmlns="" val="0"/>
             </a:ext>
           </a:extLst>
         </p:spPr>
@@ -5205,7 +5480,7 @@
             <a:pPr algn="l"/>
             <a:fld id="{F7021451-1387-4CA6-816F-3879F97B5CBC}" type="slidenum">
               <a:rPr lang="en-US" b="0"/>
-              <a:t>6</a:t>
+              <a:t>7</a:t>
             </a:fld>
             <a:endParaRPr lang="en-US"/>
           </a:p>
@@ -5219,7 +5494,7 @@
 </p:sld>
 </file>
 
-<file path=ppt/slides/slide7.xml><?xml version="1.0" encoding="utf-8"?>
+<file path=ppt/slides/slide8.xml><?xml version="1.0" encoding="utf-8"?>
 <p:sld xmlns:a="http://schemas.openxmlformats.org/drawingml/2006/main" xmlns:r="http://schemas.openxmlformats.org/officeDocument/2006/relationships" xmlns:p="http://schemas.openxmlformats.org/presentationml/2006/main">
   <p:cSld name="Slide 7">
     <p:spTree>
@@ -5740,7 +6015,7 @@
           </a:prstGeom>
           <a:extLst>
             <a:ext uri="{C572A759-6A51-4108-AA02-DFA0A04FC94B}">
-              <ma14:wrappingTextBoxFlag xmlns="" xmlns:ma14="http://schemas.microsoft.com/office/mac/drawingml/2011/main" val="0"/>
+              <ma14:wrappingTextBoxFlag xmlns:ma14="http://schemas.microsoft.com/office/mac/drawingml/2011/main" xmlns="" val="0"/>
             </a:ext>
           </a:extLst>
         </p:spPr>
@@ -5759,7 +6034,7 @@
             <a:pPr algn="l"/>
             <a:fld id="{F7021451-1387-4CA6-816F-3879F97B5CBC}" type="slidenum">
               <a:rPr lang="en-US" b="0"/>
-              <a:t>7</a:t>
+              <a:t>8</a:t>
             </a:fld>
             <a:endParaRPr lang="en-US"/>
           </a:p>
@@ -5773,7 +6048,7 @@
 </p:sld>
 </file>
 
-<file path=ppt/slides/slide8.xml><?xml version="1.0" encoding="utf-8"?>
+<file path=ppt/slides/slide9.xml><?xml version="1.0" encoding="utf-8"?>
 <p:sld xmlns:a="http://schemas.openxmlformats.org/drawingml/2006/main" xmlns:r="http://schemas.openxmlformats.org/officeDocument/2006/relationships" xmlns:p="http://schemas.openxmlformats.org/presentationml/2006/main">
   <p:cSld name="Slide 8">
     <p:spTree>
@@ -6787,138 +7062,7 @@
           </a:prstGeom>
           <a:extLst>
             <a:ext uri="{C572A759-6A51-4108-AA02-DFA0A04FC94B}">
-              <ma14:wrappingTextBoxFlag xmlns="" xmlns:ma14="http://schemas.microsoft.com/office/mac/drawingml/2011/main" val="0"/>
-            </a:ext>
-          </a:extLst>
-        </p:spPr>
-        <p:txBody>
-          <a:bodyPr/>
-          <a:lstStyle>
-            <a:lvl1pPr>
-              <a:defRPr sz="1000">
-                <a:solidFill>
-                  <a:schemeClr val="tx1"/>
-                </a:solidFill>
-              </a:defRPr>
-            </a:lvl1pPr>
-          </a:lstStyle>
-          <a:p>
-            <a:pPr algn="l"/>
-            <a:fld id="{F7021451-1387-4CA6-816F-3879F97B5CBC}" type="slidenum">
-              <a:rPr lang="en-US" b="0"/>
-              <a:t>8</a:t>
-            </a:fld>
-            <a:endParaRPr lang="en-US"/>
-          </a:p>
-        </p:txBody>
-      </p:sp>
-    </p:spTree>
-  </p:cSld>
-  <p:clrMapOvr>
-    <a:masterClrMapping/>
-  </p:clrMapOvr>
-</p:sld>
-</file>
-
-<file path=ppt/slides/slide9.xml><?xml version="1.0" encoding="utf-8"?>
-<p:sld xmlns:a="http://schemas.openxmlformats.org/drawingml/2006/main" xmlns:r="http://schemas.openxmlformats.org/officeDocument/2006/relationships" xmlns:p="http://schemas.openxmlformats.org/presentationml/2006/main">
-  <p:cSld>
-    <p:spTree>
-      <p:nvGrpSpPr>
-        <p:cNvPr id="1" name="">
-          <a:extLst>
-            <a:ext uri="{FF2B5EF4-FFF2-40B4-BE49-F238E27FC236}">
-              <a16:creationId xmlns:a16="http://schemas.microsoft.com/office/drawing/2014/main" id="{F561C7DD-AE16-3396-A768-25871454625D}"/>
-            </a:ext>
-          </a:extLst>
-        </p:cNvPr>
-        <p:cNvGrpSpPr/>
-        <p:nvPr/>
-      </p:nvGrpSpPr>
-      <p:grpSpPr>
-        <a:xfrm>
-          <a:off x="0" y="0"/>
-          <a:ext cx="0" cy="0"/>
-          <a:chOff x="0" y="0"/>
-          <a:chExt cx="0" cy="0"/>
-        </a:xfrm>
-      </p:grpSpPr>
-      <p:sp>
-        <p:nvSpPr>
-          <p:cNvPr id="2" name="Text 0">
-            <a:extLst>
-              <a:ext uri="{FF2B5EF4-FFF2-40B4-BE49-F238E27FC236}">
-                <a16:creationId xmlns:a16="http://schemas.microsoft.com/office/drawing/2014/main" id="{91EBC240-CDC5-6022-2777-9FC32B90C690}"/>
-              </a:ext>
-            </a:extLst>
-          </p:cNvPr>
-          <p:cNvSpPr>
-            <a:spLocks noGrp="1"/>
-          </p:cNvSpPr>
-          <p:nvPr>
-            <p:ph type="title" idx="100" hasCustomPrompt="1"/>
-          </p:nvPr>
-        </p:nvSpPr>
-        <p:spPr>
-          <a:xfrm>
-            <a:off x="548640" y="274320"/>
-            <a:ext cx="8046720" cy="640080"/>
-          </a:xfrm>
-          <a:prstGeom prst="rect">
-            <a:avLst/>
-          </a:prstGeom>
-          <a:noFill/>
-          <a:ln/>
-        </p:spPr>
-        <p:txBody>
-          <a:bodyPr wrap="square" lIns="0" tIns="0" rIns="0" bIns="0" rtlCol="0" anchor="ctr"/>
-          <a:lstStyle/>
-          <a:p>
-            <a:pPr marL="0" indent="0" algn="l">
-              <a:buNone/>
-            </a:pPr>
-            <a:r>
-              <a:rPr lang="en-US" sz="3400" dirty="0"/>
-              <a:t>6. </a:t>
-            </a:r>
-            <a:r>
-              <a:rPr lang="en-US" sz="3400" dirty="0" err="1"/>
-              <a:t>Demostración</a:t>
-            </a:r>
-            <a:r>
-              <a:rPr lang="en-US" sz="3400" dirty="0"/>
-              <a:t> Observer</a:t>
-            </a:r>
-          </a:p>
-        </p:txBody>
-      </p:sp>
-      <p:sp>
-        <p:nvSpPr>
-          <p:cNvPr id="25" name="Slide Number Placeholder 0">
-            <a:extLst>
-              <a:ext uri="{FF2B5EF4-FFF2-40B4-BE49-F238E27FC236}">
-                <a16:creationId xmlns:a16="http://schemas.microsoft.com/office/drawing/2014/main" id="{B9A839D4-8AA5-259D-CBA6-6C4F86AE7ADB}"/>
-              </a:ext>
-            </a:extLst>
-          </p:cNvPr>
-          <p:cNvSpPr>
-            <a:spLocks noGrp="1"/>
-          </p:cNvSpPr>
-          <p:nvPr>
-            <p:ph type="sldNum" sz="quarter" idx="4294967295"/>
-          </p:nvPr>
-        </p:nvSpPr>
-        <p:spPr>
-          <a:xfrm>
-            <a:off x="8321040" y="4754880"/>
-            <a:ext cx="457200" cy="274320"/>
-          </a:xfrm>
-          <a:prstGeom prst="rect">
-            <a:avLst/>
-          </a:prstGeom>
-          <a:extLst>
-            <a:ext uri="{C572A759-6A51-4108-AA02-DFA0A04FC94B}">
-              <ma14:wrappingTextBoxFlag xmlns="" xmlns:ma14="http://schemas.microsoft.com/office/mac/drawingml/2011/main" val="0"/>
+              <ma14:wrappingTextBoxFlag xmlns:ma14="http://schemas.microsoft.com/office/mac/drawingml/2011/main" xmlns="" val="0"/>
             </a:ext>
           </a:extLst>
         </p:spPr>
@@ -6943,96 +7087,7 @@
           </a:p>
         </p:txBody>
       </p:sp>
-      <p:sp>
-        <p:nvSpPr>
-          <p:cNvPr id="4" name="Rounded Rectangle 2">
-            <a:extLst>
-              <a:ext uri="{FF2B5EF4-FFF2-40B4-BE49-F238E27FC236}">
-                <a16:creationId xmlns:a16="http://schemas.microsoft.com/office/drawing/2014/main" id="{9A0D3864-16E3-1F3C-FAA5-52B37E4B911E}"/>
-              </a:ext>
-            </a:extLst>
-          </p:cNvPr>
-          <p:cNvSpPr/>
-          <p:nvPr/>
-        </p:nvSpPr>
-        <p:spPr>
-          <a:xfrm>
-            <a:off x="548640" y="914400"/>
-            <a:ext cx="6374674" cy="4069080"/>
-          </a:xfrm>
-          <a:prstGeom prst="roundRect">
-            <a:avLst>
-              <a:gd name="adj" fmla="val 4067"/>
-            </a:avLst>
-          </a:prstGeom>
-          <a:solidFill>
-            <a:srgbClr val="1A1B26"/>
-          </a:solidFill>
-          <a:ln>
-            <a:noFill/>
-          </a:ln>
-          <a:effectLst/>
-        </p:spPr>
-        <p:style>
-          <a:lnRef idx="1">
-            <a:schemeClr val="accent1"/>
-          </a:lnRef>
-          <a:fillRef idx="3">
-            <a:schemeClr val="accent1"/>
-          </a:fillRef>
-          <a:effectRef idx="2">
-            <a:schemeClr val="accent1"/>
-          </a:effectRef>
-          <a:fontRef idx="minor">
-            <a:schemeClr val="lt1"/>
-          </a:fontRef>
-        </p:style>
-        <p:txBody>
-          <a:bodyPr rtlCol="0" anchor="ctr"/>
-          <a:lstStyle/>
-          <a:p>
-            <a:pPr algn="ctr"/>
-            <a:endParaRPr dirty="0"/>
-          </a:p>
-        </p:txBody>
-      </p:sp>
-      <p:pic>
-        <p:nvPicPr>
-          <p:cNvPr id="7" name="Imagen 6">
-            <a:extLst>
-              <a:ext uri="{FF2B5EF4-FFF2-40B4-BE49-F238E27FC236}">
-                <a16:creationId xmlns:a16="http://schemas.microsoft.com/office/drawing/2014/main" id="{9660477F-36C8-BC06-0385-E8E72D529B3C}"/>
-              </a:ext>
-            </a:extLst>
-          </p:cNvPr>
-          <p:cNvPicPr>
-            <a:picLocks noChangeAspect="1"/>
-          </p:cNvPicPr>
-          <p:nvPr/>
-        </p:nvPicPr>
-        <p:blipFill>
-          <a:blip r:embed="rId3"/>
-          <a:srcRect l="7087" t="10007" r="7068" b="9250"/>
-          <a:stretch>
-            <a:fillRect/>
-          </a:stretch>
-        </p:blipFill>
-        <p:spPr>
-          <a:xfrm>
-            <a:off x="685800" y="1059848"/>
-            <a:ext cx="6080760" cy="3771727"/>
-          </a:xfrm>
-          <a:prstGeom prst="rect">
-            <a:avLst/>
-          </a:prstGeom>
-        </p:spPr>
-      </p:pic>
     </p:spTree>
-    <p:extLst>
-      <p:ext uri="{BB962C8B-B14F-4D97-AF65-F5344CB8AC3E}">
-        <p14:creationId xmlns:p14="http://schemas.microsoft.com/office/powerpoint/2010/main" val="3122564168"/>
-      </p:ext>
-    </p:extLst>
   </p:cSld>
   <p:clrMapOvr>
     <a:masterClrMapping/>

</xml_diff>

<commit_message>
docs: cambios finales a la presentacion
</commit_message>
<xml_diff>
--- a/presentación/Arquitectura SOA  y Patrones Observer, Mediator.pptx
+++ b/presentación/Arquitectura SOA  y Patrones Observer, Mediator.pptx
@@ -227,7 +227,7 @@
           <a:p>
             <a:fld id="{F6AE3B52-FEC4-42BC-B06A-8CABB6F8B49F}" type="datetimeFigureOut">
               <a:rPr lang="es-CO" smtClean="0"/>
-              <a:t>15/10/26</a:t>
+              <a:t>15/10/2026</a:t>
             </a:fld>
             <a:endParaRPr lang="es-CO"/>
           </a:p>
@@ -1340,7 +1340,7 @@
           <a:p>
             <a:fld id="{228352A7-4D7D-4A5E-A016-C2965DC63AEC}" type="datetimeFigureOut">
               <a:rPr lang="es-CO" smtClean="0"/>
-              <a:t>15/10/26</a:t>
+              <a:t>15/10/2026</a:t>
             </a:fld>
             <a:endParaRPr lang="es-CO"/>
           </a:p>
@@ -1540,7 +1540,7 @@
           <a:p>
             <a:fld id="{228352A7-4D7D-4A5E-A016-C2965DC63AEC}" type="datetimeFigureOut">
               <a:rPr lang="es-CO" smtClean="0"/>
-              <a:t>15/10/26</a:t>
+              <a:t>15/10/2026</a:t>
             </a:fld>
             <a:endParaRPr lang="es-CO"/>
           </a:p>
@@ -1750,7 +1750,7 @@
           <a:p>
             <a:fld id="{228352A7-4D7D-4A5E-A016-C2965DC63AEC}" type="datetimeFigureOut">
               <a:rPr lang="es-CO" smtClean="0"/>
-              <a:t>15/10/26</a:t>
+              <a:t>15/10/2026</a:t>
             </a:fld>
             <a:endParaRPr lang="es-CO"/>
           </a:p>
@@ -1988,7 +1988,7 @@
           </a:prstGeom>
           <a:extLst>
             <a:ext uri="{C572A759-6A51-4108-AA02-DFA0A04FC94B}">
-              <ma14:wrappingTextBoxFlag xmlns="" xmlns:ma14="http://schemas.microsoft.com/office/mac/drawingml/2011/main" val="0"/>
+              <ma14:wrappingTextBoxFlag xmlns:ma14="http://schemas.microsoft.com/office/mac/drawingml/2011/main" xmlns="" val="0"/>
             </a:ext>
           </a:extLst>
         </p:spPr>
@@ -2153,7 +2153,7 @@
           <a:p>
             <a:fld id="{228352A7-4D7D-4A5E-A016-C2965DC63AEC}" type="datetimeFigureOut">
               <a:rPr lang="es-CO" smtClean="0"/>
-              <a:t>15/10/26</a:t>
+              <a:t>15/10/2026</a:t>
             </a:fld>
             <a:endParaRPr lang="es-CO"/>
           </a:p>
@@ -2429,7 +2429,7 @@
           <a:p>
             <a:fld id="{228352A7-4D7D-4A5E-A016-C2965DC63AEC}" type="datetimeFigureOut">
               <a:rPr lang="es-CO" smtClean="0"/>
-              <a:t>15/10/26</a:t>
+              <a:t>15/10/2026</a:t>
             </a:fld>
             <a:endParaRPr lang="es-CO"/>
           </a:p>
@@ -2697,7 +2697,7 @@
           <a:p>
             <a:fld id="{228352A7-4D7D-4A5E-A016-C2965DC63AEC}" type="datetimeFigureOut">
               <a:rPr lang="es-CO" smtClean="0"/>
-              <a:t>15/10/26</a:t>
+              <a:t>15/10/2026</a:t>
             </a:fld>
             <a:endParaRPr lang="es-CO"/>
           </a:p>
@@ -3112,7 +3112,7 @@
           <a:p>
             <a:fld id="{228352A7-4D7D-4A5E-A016-C2965DC63AEC}" type="datetimeFigureOut">
               <a:rPr lang="es-CO" smtClean="0"/>
-              <a:t>15/10/26</a:t>
+              <a:t>15/10/2026</a:t>
             </a:fld>
             <a:endParaRPr lang="es-CO"/>
           </a:p>
@@ -3254,7 +3254,7 @@
           <a:p>
             <a:fld id="{228352A7-4D7D-4A5E-A016-C2965DC63AEC}" type="datetimeFigureOut">
               <a:rPr lang="es-CO" smtClean="0"/>
-              <a:t>15/10/26</a:t>
+              <a:t>15/10/2026</a:t>
             </a:fld>
             <a:endParaRPr lang="es-CO"/>
           </a:p>
@@ -3367,7 +3367,7 @@
           <a:p>
             <a:fld id="{228352A7-4D7D-4A5E-A016-C2965DC63AEC}" type="datetimeFigureOut">
               <a:rPr lang="es-CO" smtClean="0"/>
-              <a:t>15/10/26</a:t>
+              <a:t>15/10/2026</a:t>
             </a:fld>
             <a:endParaRPr lang="es-CO"/>
           </a:p>
@@ -3680,7 +3680,7 @@
           <a:p>
             <a:fld id="{228352A7-4D7D-4A5E-A016-C2965DC63AEC}" type="datetimeFigureOut">
               <a:rPr lang="es-CO" smtClean="0"/>
-              <a:t>15/10/26</a:t>
+              <a:t>15/10/2026</a:t>
             </a:fld>
             <a:endParaRPr lang="es-CO"/>
           </a:p>
@@ -3969,7 +3969,7 @@
           <a:p>
             <a:fld id="{228352A7-4D7D-4A5E-A016-C2965DC63AEC}" type="datetimeFigureOut">
               <a:rPr lang="es-CO" smtClean="0"/>
-              <a:t>15/10/26</a:t>
+              <a:t>15/10/2026</a:t>
             </a:fld>
             <a:endParaRPr lang="es-CO"/>
           </a:p>
@@ -4212,7 +4212,7 @@
           <a:p>
             <a:fld id="{228352A7-4D7D-4A5E-A016-C2965DC63AEC}" type="datetimeFigureOut">
               <a:rPr lang="es-CO" smtClean="0"/>
-              <a:t>15/10/26</a:t>
+              <a:t>15/10/2026</a:t>
             </a:fld>
             <a:endParaRPr lang="es-CO"/>
           </a:p>
@@ -5192,7 +5192,7 @@
           </a:prstGeom>
           <a:extLst>
             <a:ext uri="{C572A759-6A51-4108-AA02-DFA0A04FC94B}">
-              <ma14:wrappingTextBoxFlag xmlns="" xmlns:ma14="http://schemas.microsoft.com/office/mac/drawingml/2011/main" val="0"/>
+              <ma14:wrappingTextBoxFlag xmlns:ma14="http://schemas.microsoft.com/office/mac/drawingml/2011/main" xmlns="" val="0"/>
             </a:ext>
           </a:extLst>
         </p:spPr>
@@ -5411,9 +5411,49 @@
                 </a:solidFill>
                 <a:latin typeface="Calibri"/>
               </a:rPr>
-              <a:t>reaccionar a cambios sin que el emisor conozca a quién avisa.</a:t>
-            </a:r>
-          </a:p>
+              <a:t>reaccionar a cambios sin que el emisor conozca a quién </a:t>
+            </a:r>
+            <a:r>
+              <a:rPr lang="en-US" sz="1867" dirty="0" err="1">
+                <a:solidFill>
+                  <a:srgbClr val="BEC5E6"/>
+                </a:solidFill>
+                <a:latin typeface="Calibri"/>
+              </a:rPr>
+              <a:t>avisa</a:t>
+            </a:r>
+            <a:r>
+              <a:rPr lang="en-US" sz="1867" dirty="0">
+                <a:solidFill>
+                  <a:srgbClr val="BEC5E6"/>
+                </a:solidFill>
+                <a:latin typeface="Calibri"/>
+              </a:rPr>
+              <a:t>.</a:t>
+            </a:r>
+          </a:p>
+        </p:txBody>
+      </p:sp>
+      <p:sp>
+        <p:nvSpPr>
+          <p:cNvPr id="7" name="Text 5"/>
+          <p:cNvSpPr txBox="1"/>
+          <p:nvPr/>
+        </p:nvSpPr>
+        <p:spPr>
+          <a:xfrm>
+            <a:off x="6461760" y="2011680"/>
+            <a:ext cx="4998720" cy="4145280"/>
+          </a:xfrm>
+          <a:prstGeom prst="rect">
+            <a:avLst/>
+          </a:prstGeom>
+          <a:noFill/>
+          <a:ln/>
+        </p:spPr>
+        <p:txBody>
+          <a:bodyPr wrap="square" lIns="0" tIns="0" rIns="0" bIns="0" rtlCol="0" anchor="t"/>
+          <a:lstStyle/>
           <a:p>
             <a:pPr>
               <a:spcAft>
@@ -5427,7 +5467,7 @@
                 </a:solidFill>
                 <a:latin typeface="Calibri"/>
               </a:rPr>
-              <a:t>En SOA: </a:t>
+              <a:t>Qué es: </a:t>
             </a:r>
             <a:r>
               <a:rPr lang="en-US" sz="1867" dirty="0">
@@ -5436,31 +5476,9 @@
                 </a:solidFill>
                 <a:latin typeface="Calibri"/>
               </a:rPr>
-              <a:t>publish/subscribe con un broker (RabbitMQ, Kafka).</a:t>
-            </a:r>
-          </a:p>
-        </p:txBody>
-      </p:sp>
-      <p:sp>
-        <p:nvSpPr>
-          <p:cNvPr id="7" name="Text 5"/>
-          <p:cNvSpPr txBox="1"/>
-          <p:nvPr/>
-        </p:nvSpPr>
-        <p:spPr>
-          <a:xfrm>
-            <a:off x="6461760" y="2011680"/>
-            <a:ext cx="4998720" cy="4145280"/>
-          </a:xfrm>
-          <a:prstGeom prst="rect">
-            <a:avLst/>
-          </a:prstGeom>
-          <a:noFill/>
-          <a:ln/>
-        </p:spPr>
-        <p:txBody>
-          <a:bodyPr wrap="square" lIns="0" tIns="0" rIns="0" bIns="0" rtlCol="0" anchor="t"/>
-          <a:lstStyle/>
+              <a:t>un intermediario que centraliza la comunicación entre componentes.</a:t>
+            </a:r>
+          </a:p>
           <a:p>
             <a:pPr>
               <a:spcAft>
@@ -5474,7 +5492,7 @@
                 </a:solidFill>
                 <a:latin typeface="Calibri"/>
               </a:rPr>
-              <a:t>Qué es: </a:t>
+              <a:t>Metáfora: </a:t>
             </a:r>
             <a:r>
               <a:rPr lang="en-US" sz="1867" dirty="0">
@@ -5483,7 +5501,7 @@
                 </a:solidFill>
                 <a:latin typeface="Calibri"/>
               </a:rPr>
-              <a:t>un intermediario que centraliza la comunicación entre componentes.</a:t>
+              <a:t>la torre de control de un aeropuerto.</a:t>
             </a:r>
           </a:p>
           <a:p>
@@ -5499,7 +5517,7 @@
                 </a:solidFill>
                 <a:latin typeface="Calibri"/>
               </a:rPr>
-              <a:t>Metáfora: </a:t>
+              <a:t>Sirve para: </a:t>
             </a:r>
             <a:r>
               <a:rPr lang="en-US" sz="1867" dirty="0">
@@ -5508,23 +5526,16 @@
                 </a:solidFill>
                 <a:latin typeface="Calibri"/>
               </a:rPr>
-              <a:t>la torre de control de un aeropuerto.</a:t>
-            </a:r>
-          </a:p>
-          <a:p>
-            <a:pPr>
-              <a:spcAft>
-                <a:spcPts val="1067"/>
-              </a:spcAft>
-            </a:pPr>
-            <a:r>
-              <a:rPr lang="en-US" sz="1867" b="1" dirty="0">
-                <a:solidFill>
-                  <a:srgbClr val="FFFFFF"/>
+              <a:t>evitar una maraña de dependencias y coordinar en un solo </a:t>
+            </a:r>
+            <a:r>
+              <a:rPr lang="en-US" sz="1867" dirty="0" err="1">
+                <a:solidFill>
+                  <a:srgbClr val="BEC5E6"/>
                 </a:solidFill>
                 <a:latin typeface="Calibri"/>
               </a:rPr>
-              <a:t>Sirve para: </a:t>
+              <a:t>lugar</a:t>
             </a:r>
             <a:r>
               <a:rPr lang="en-US" sz="1867" dirty="0">
@@ -5533,32 +5544,7 @@
                 </a:solidFill>
                 <a:latin typeface="Calibri"/>
               </a:rPr>
-              <a:t>evitar una maraña de dependencias y coordinar en un solo lugar.</a:t>
-            </a:r>
-          </a:p>
-          <a:p>
-            <a:pPr>
-              <a:spcAft>
-                <a:spcPts val="1067"/>
-              </a:spcAft>
-            </a:pPr>
-            <a:r>
-              <a:rPr lang="en-US" sz="1867" b="1" dirty="0">
-                <a:solidFill>
-                  <a:srgbClr val="FFFFFF"/>
-                </a:solidFill>
-                <a:latin typeface="Calibri"/>
-              </a:rPr>
-              <a:t>En SOA: </a:t>
-            </a:r>
-            <a:r>
-              <a:rPr lang="en-US" sz="1867" dirty="0">
-                <a:solidFill>
-                  <a:srgbClr val="BEC5E6"/>
-                </a:solidFill>
-                <a:latin typeface="Calibri"/>
-              </a:rPr>
-              <a:t>orquestador, ESB o API Gateway.</a:t>
+              <a:t>.</a:t>
             </a:r>
           </a:p>
         </p:txBody>
@@ -5743,7 +5729,7 @@
           </a:prstGeom>
           <a:extLst>
             <a:ext uri="{C572A759-6A51-4108-AA02-DFA0A04FC94B}">
-              <ma14:wrappingTextBoxFlag xmlns="" xmlns:ma14="http://schemas.microsoft.com/office/mac/drawingml/2011/main" val="0"/>
+              <ma14:wrappingTextBoxFlag xmlns:ma14="http://schemas.microsoft.com/office/mac/drawingml/2011/main" xmlns="" val="0"/>
             </a:ext>
           </a:extLst>
         </p:spPr>
@@ -5997,39 +5983,6 @@
               <a:t>cada uno recibe update()</a:t>
             </a:r>
           </a:p>
-          <a:p>
-            <a:pPr>
-              <a:spcAft>
-                <a:spcPts val="667"/>
-              </a:spcAft>
-            </a:pPr>
-            <a:endParaRPr lang="en-US" sz="1733" dirty="0"/>
-          </a:p>
-          <a:p>
-            <a:pPr>
-              <a:spcAft>
-                <a:spcPts val="667"/>
-              </a:spcAft>
-            </a:pPr>
-            <a:r>
-              <a:rPr lang="en-US" sz="1733" b="1" dirty="0">
-                <a:solidFill>
-                  <a:srgbClr val="FFFFFF"/>
-                </a:solidFill>
-                <a:latin typeface="Calibri"/>
-              </a:rPr>
-              <a:t>En SOA: </a:t>
-            </a:r>
-            <a:r>
-              <a:rPr lang="en-US" sz="1733" dirty="0">
-                <a:solidFill>
-                  <a:srgbClr val="BEC5E6"/>
-                </a:solidFill>
-                <a:latin typeface="Calibri"/>
-              </a:rPr>
-              <a:t>el broker hace de lista y entrega el evento a cada suscriptor.</a:t>
-            </a:r>
-          </a:p>
         </p:txBody>
       </p:sp>
       <p:sp>
@@ -6156,41 +6109,23 @@
                 </a:solidFill>
                 <a:latin typeface="Calibri"/>
               </a:rPr>
-              <a:t>los demás responden al mediador</a:t>
-            </a:r>
-          </a:p>
-          <a:p>
-            <a:pPr>
-              <a:spcAft>
-                <a:spcPts val="667"/>
-              </a:spcAft>
-            </a:pPr>
-            <a:endParaRPr lang="en-US" sz="1733" dirty="0"/>
-          </a:p>
-          <a:p>
-            <a:pPr>
-              <a:spcAft>
-                <a:spcPts val="667"/>
-              </a:spcAft>
-            </a:pPr>
-            <a:r>
-              <a:rPr lang="en-US" sz="1733" b="1" dirty="0">
-                <a:solidFill>
-                  <a:srgbClr val="FFFFFF"/>
+              <a:t>los demás responden al </a:t>
+            </a:r>
+            <a:r>
+              <a:rPr lang="en-US" sz="1733" dirty="0" err="1">
+                <a:solidFill>
+                  <a:srgbClr val="BEC5E6"/>
                 </a:solidFill>
                 <a:latin typeface="Calibri"/>
               </a:rPr>
-              <a:t>En SOA: </a:t>
-            </a:r>
-            <a:r>
-              <a:rPr lang="en-US" sz="1733" dirty="0">
-                <a:solidFill>
-                  <a:srgbClr val="BEC5E6"/>
-                </a:solidFill>
-                <a:latin typeface="Calibri"/>
-              </a:rPr>
-              <a:t>el ESB o gateway enruta, transforma y coordina.</a:t>
-            </a:r>
+              <a:t>mediador</a:t>
+            </a:r>
+            <a:endParaRPr lang="en-US" sz="1733" dirty="0">
+              <a:solidFill>
+                <a:srgbClr val="BEC5E6"/>
+              </a:solidFill>
+              <a:latin typeface="Calibri"/>
+            </a:endParaRPr>
           </a:p>
         </p:txBody>
       </p:sp>
@@ -6374,7 +6309,7 @@
           </a:prstGeom>
           <a:extLst>
             <a:ext uri="{C572A759-6A51-4108-AA02-DFA0A04FC94B}">
-              <ma14:wrappingTextBoxFlag xmlns="" xmlns:ma14="http://schemas.microsoft.com/office/mac/drawingml/2011/main" val="0"/>
+              <ma14:wrappingTextBoxFlag xmlns:ma14="http://schemas.microsoft.com/office/mac/drawingml/2011/main" xmlns="" val="0"/>
             </a:ext>
           </a:extLst>
         </p:spPr>
@@ -13470,7 +13405,7 @@
           </a:prstGeom>
           <a:extLst>
             <a:ext uri="{C572A759-6A51-4108-AA02-DFA0A04FC94B}">
-              <ma14:wrappingTextBoxFlag xmlns="" xmlns:ma14="http://schemas.microsoft.com/office/mac/drawingml/2011/main" val="0"/>
+              <ma14:wrappingTextBoxFlag xmlns:ma14="http://schemas.microsoft.com/office/mac/drawingml/2011/main" xmlns="" val="0"/>
             </a:ext>
           </a:extLst>
         </p:spPr>
@@ -14686,7 +14621,7 @@
           </a:prstGeom>
           <a:extLst>
             <a:ext uri="{C572A759-6A51-4108-AA02-DFA0A04FC94B}">
-              <ma14:wrappingTextBoxFlag xmlns="" xmlns:ma14="http://schemas.microsoft.com/office/mac/drawingml/2011/main" val="0"/>
+              <ma14:wrappingTextBoxFlag xmlns:ma14="http://schemas.microsoft.com/office/mac/drawingml/2011/main" xmlns="" val="0"/>
             </a:ext>
           </a:extLst>
         </p:spPr>
@@ -14723,7 +14658,7 @@
         </p:nvSpPr>
         <p:spPr>
           <a:xfrm>
-            <a:off x="731520" y="1402080"/>
+            <a:off x="670561" y="2425309"/>
             <a:ext cx="5242560" cy="487680"/>
           </a:xfrm>
           <a:prstGeom prst="rect">
@@ -14757,7 +14692,7 @@
         </p:nvSpPr>
         <p:spPr>
           <a:xfrm>
-            <a:off x="731520" y="2011680"/>
+            <a:off x="670561" y="3048000"/>
             <a:ext cx="5242560" cy="4145280"/>
           </a:xfrm>
           <a:prstGeom prst="rect">
@@ -14841,23 +14776,16 @@
                 </a:solidFill>
                 <a:latin typeface="Calibri"/>
               </a:rPr>
-              <a:t>catálogo donde se publican los contratos.</a:t>
-            </a:r>
-          </a:p>
-          <a:p>
-            <a:pPr>
-              <a:spcAft>
-                <a:spcPts val="1067"/>
-              </a:spcAft>
-            </a:pPr>
-            <a:r>
-              <a:rPr lang="en-US" sz="1867" b="1" dirty="0">
-                <a:solidFill>
-                  <a:srgbClr val="FFFFFF"/>
+              <a:t>catálogo donde se publican los </a:t>
+            </a:r>
+            <a:r>
+              <a:rPr lang="en-US" sz="1867" dirty="0" err="1">
+                <a:solidFill>
+                  <a:srgbClr val="BEC5E6"/>
                 </a:solidFill>
                 <a:latin typeface="Calibri"/>
               </a:rPr>
-              <a:t>Capas: </a:t>
+              <a:t>contratos</a:t>
             </a:r>
             <a:r>
               <a:rPr lang="en-US" sz="1867" dirty="0">
@@ -14866,7 +14794,7 @@
                 </a:solidFill>
                 <a:latin typeface="Calibri"/>
               </a:rPr>
-              <a:t>consumidores, procesos, servicios de negocio, datos e integración (ESB, gateway, broker).</a:t>
+              <a:t>.</a:t>
             </a:r>
           </a:p>
         </p:txBody>
@@ -14909,7 +14837,7 @@
         </p:nvSpPr>
         <p:spPr>
           <a:xfrm>
-            <a:off x="6583680" y="1402080"/>
+            <a:off x="6583680" y="2316480"/>
             <a:ext cx="4876800" cy="487680"/>
           </a:xfrm>
           <a:prstGeom prst="rect">
@@ -14943,7 +14871,7 @@
         </p:nvSpPr>
         <p:spPr>
           <a:xfrm>
-            <a:off x="6583680" y="2072640"/>
+            <a:off x="6583680" y="2844800"/>
             <a:ext cx="4876800" cy="2926080"/>
           </a:xfrm>
           <a:prstGeom prst="rect">
@@ -15009,7 +14937,43 @@
                 </a:solidFill>
                 <a:latin typeface="Calibri"/>
               </a:rPr>
-              <a:t>Envía un mensaje (SOAP/XML o REST/JSON) por HTTP o colas.</a:t>
+              <a:t>Envía un </a:t>
+            </a:r>
+            <a:r>
+              <a:rPr lang="en-US" sz="1867" dirty="0" err="1">
+                <a:solidFill>
+                  <a:srgbClr val="BEC5E6"/>
+                </a:solidFill>
+                <a:latin typeface="Calibri"/>
+              </a:rPr>
+              <a:t>mensaje</a:t>
+            </a:r>
+            <a:r>
+              <a:rPr lang="en-US" sz="1867" dirty="0">
+                <a:solidFill>
+                  <a:srgbClr val="BEC5E6"/>
+                </a:solidFill>
+                <a:latin typeface="Calibri"/>
+              </a:rPr>
+              <a:t> </a:t>
+            </a:r>
+            <a:r>
+              <a:rPr lang="en-US" sz="1867" dirty="0" err="1">
+                <a:solidFill>
+                  <a:srgbClr val="BEC5E6"/>
+                </a:solidFill>
+                <a:latin typeface="Calibri"/>
+              </a:rPr>
+              <a:t>por</a:t>
+            </a:r>
+            <a:r>
+              <a:rPr lang="en-US" sz="1867" dirty="0">
+                <a:solidFill>
+                  <a:srgbClr val="BEC5E6"/>
+                </a:solidFill>
+                <a:latin typeface="Calibri"/>
+              </a:rPr>
+              <a:t> HTTP.</a:t>
             </a:r>
           </a:p>
           <a:p>
@@ -15029,48 +14993,6 @@
                 <a:latin typeface="Calibri"/>
               </a:rPr>
               <a:t>El proveedor responde; su código interno no se ve.</a:t>
-            </a:r>
-          </a:p>
-        </p:txBody>
-      </p:sp>
-      <p:sp>
-        <p:nvSpPr>
-          <p:cNvPr id="8" name="Text 6"/>
-          <p:cNvSpPr txBox="1"/>
-          <p:nvPr/>
-        </p:nvSpPr>
-        <p:spPr>
-          <a:xfrm>
-            <a:off x="6583680" y="5120640"/>
-            <a:ext cx="4876800" cy="975360"/>
-          </a:xfrm>
-          <a:prstGeom prst="rect">
-            <a:avLst/>
-          </a:prstGeom>
-          <a:noFill/>
-          <a:ln/>
-        </p:spPr>
-        <p:txBody>
-          <a:bodyPr wrap="square" lIns="0" tIns="0" rIns="0" bIns="0" rtlCol="0" anchor="t"/>
-          <a:lstStyle/>
-          <a:p>
-            <a:r>
-              <a:rPr lang="en-US" sz="1867" b="1" dirty="0">
-                <a:solidFill>
-                  <a:srgbClr val="FFFFFF"/>
-                </a:solidFill>
-                <a:latin typeface="Calibri"/>
-              </a:rPr>
-              <a:t>Además: </a:t>
-            </a:r>
-            <a:r>
-              <a:rPr lang="en-US" sz="1867" dirty="0">
-                <a:solidFill>
-                  <a:srgbClr val="BEC5E6"/>
-                </a:solidFill>
-                <a:latin typeface="Calibri"/>
-              </a:rPr>
-              <a:t>los servicios no guardan estado y funcionan en distintas plataformas.</a:t>
             </a:r>
           </a:p>
         </p:txBody>
@@ -15237,7 +15159,7 @@
           </a:prstGeom>
           <a:extLst>
             <a:ext uri="{C572A759-6A51-4108-AA02-DFA0A04FC94B}">
-              <ma14:wrappingTextBoxFlag xmlns="" xmlns:ma14="http://schemas.microsoft.com/office/mac/drawingml/2011/main" val="0"/>
+              <ma14:wrappingTextBoxFlag xmlns:ma14="http://schemas.microsoft.com/office/mac/drawingml/2011/main" xmlns="" val="0"/>
             </a:ext>
           </a:extLst>
         </p:spPr>

</xml_diff>

<commit_message>
docs(soa): actualizar archivo de presentacion
Se integran las últimas modificaciones en el archivo de la presentación sobre arquitectura SOA y patrones Mediator y Observer, sincronizando el contenido de las diapositivas con los ajustes recientes de las demos interactivas.
</commit_message>
<xml_diff>
--- a/presentación/Arquitectura SOA  y Patrones Observer, Mediator.pptx
+++ b/presentación/Arquitectura SOA  y Patrones Observer, Mediator.pptx
@@ -1985,7 +1985,7 @@
           </a:prstGeom>
           <a:extLst>
             <a:ext uri="{C572A759-6A51-4108-AA02-DFA0A04FC94B}">
-              <ma14:wrappingTextBoxFlag xmlns="" xmlns:ma14="http://schemas.microsoft.com/office/mac/drawingml/2011/main" val="0"/>
+              <ma14:wrappingTextBoxFlag xmlns:ma14="http://schemas.microsoft.com/office/mac/drawingml/2011/main" xmlns="" val="0"/>
             </a:ext>
           </a:extLst>
         </p:spPr>
@@ -5034,7 +5034,7 @@
           </a:prstGeom>
           <a:extLst>
             <a:ext uri="{C572A759-6A51-4108-AA02-DFA0A04FC94B}">
-              <ma14:wrappingTextBoxFlag xmlns="" xmlns:ma14="http://schemas.microsoft.com/office/mac/drawingml/2011/main" val="0"/>
+              <ma14:wrappingTextBoxFlag xmlns:ma14="http://schemas.microsoft.com/office/mac/drawingml/2011/main" xmlns="" val="0"/>
             </a:ext>
           </a:extLst>
         </p:spPr>
@@ -5571,7 +5571,7 @@
           </a:prstGeom>
           <a:extLst>
             <a:ext uri="{C572A759-6A51-4108-AA02-DFA0A04FC94B}">
-              <ma14:wrappingTextBoxFlag xmlns="" xmlns:ma14="http://schemas.microsoft.com/office/mac/drawingml/2011/main" val="0"/>
+              <ma14:wrappingTextBoxFlag xmlns:ma14="http://schemas.microsoft.com/office/mac/drawingml/2011/main" xmlns="" val="0"/>
             </a:ext>
           </a:extLst>
         </p:spPr>
@@ -5932,7 +5932,25 @@
                 </a:solidFill>
                 <a:latin typeface="Calibri"/>
               </a:rPr>
-              <a:t>el mediador decide a quién, en qué orden y con qué reglas</a:t>
+              <a:t>el </a:t>
+            </a:r>
+            <a:r>
+              <a:rPr lang="en-US" sz="1733" dirty="0" err="1">
+                <a:solidFill>
+                  <a:srgbClr val="BEC5E6"/>
+                </a:solidFill>
+                <a:latin typeface="Calibri"/>
+              </a:rPr>
+              <a:t>mediador</a:t>
+            </a:r>
+            <a:r>
+              <a:rPr lang="en-US" sz="1733" dirty="0">
+                <a:solidFill>
+                  <a:srgbClr val="BEC5E6"/>
+                </a:solidFill>
+                <a:latin typeface="Calibri"/>
+              </a:rPr>
+              <a:t> decide a quién, en qué orden y con qué reglas</a:t>
             </a:r>
           </a:p>
           <a:p>
@@ -6151,7 +6169,7 @@
           </a:prstGeom>
           <a:extLst>
             <a:ext uri="{C572A759-6A51-4108-AA02-DFA0A04FC94B}">
-              <ma14:wrappingTextBoxFlag xmlns="" xmlns:ma14="http://schemas.microsoft.com/office/mac/drawingml/2011/main" val="0"/>
+              <ma14:wrappingTextBoxFlag xmlns:ma14="http://schemas.microsoft.com/office/mac/drawingml/2011/main" xmlns="" val="0"/>
             </a:ext>
           </a:extLst>
         </p:spPr>
@@ -6322,7 +6340,9 @@
           <a:prstGeom prst="rect">
             <a:avLst/>
           </a:prstGeom>
-          <a:noFill/>
+          <a:solidFill>
+            <a:srgbClr val="202658"/>
+          </a:solidFill>
           <a:ln/>
         </p:spPr>
         <p:txBody>
@@ -6400,7 +6420,9 @@
           <a:prstGeom prst="rect">
             <a:avLst/>
           </a:prstGeom>
-          <a:noFill/>
+          <a:solidFill>
+            <a:srgbClr val="202658"/>
+          </a:solidFill>
           <a:ln/>
         </p:spPr>
         <p:txBody>
@@ -6465,7 +6487,9 @@
           <a:prstGeom prst="rect">
             <a:avLst/>
           </a:prstGeom>
-          <a:noFill/>
+          <a:solidFill>
+            <a:srgbClr val="202658"/>
+          </a:solidFill>
           <a:ln/>
         </p:spPr>
         <p:txBody>
@@ -6530,7 +6554,9 @@
           <a:prstGeom prst="rect">
             <a:avLst/>
           </a:prstGeom>
-          <a:noFill/>
+          <a:solidFill>
+            <a:srgbClr val="202658"/>
+          </a:solidFill>
           <a:ln/>
         </p:spPr>
         <p:txBody>
@@ -6688,7 +6714,9 @@
           <a:prstGeom prst="rect">
             <a:avLst/>
           </a:prstGeom>
-          <a:noFill/>
+          <a:solidFill>
+            <a:srgbClr val="202658"/>
+          </a:solidFill>
           <a:ln/>
         </p:spPr>
         <p:txBody>
@@ -6753,7 +6781,9 @@
           <a:prstGeom prst="rect">
             <a:avLst/>
           </a:prstGeom>
-          <a:noFill/>
+          <a:solidFill>
+            <a:srgbClr val="202658"/>
+          </a:solidFill>
           <a:ln/>
         </p:spPr>
         <p:txBody>
@@ -6818,7 +6848,9 @@
           <a:prstGeom prst="rect">
             <a:avLst/>
           </a:prstGeom>
-          <a:noFill/>
+          <a:solidFill>
+            <a:srgbClr val="202658"/>
+          </a:solidFill>
           <a:ln/>
         </p:spPr>
         <p:txBody>
@@ -6883,7 +6915,9 @@
           <a:prstGeom prst="rect">
             <a:avLst/>
           </a:prstGeom>
-          <a:noFill/>
+          <a:solidFill>
+            <a:srgbClr val="202658"/>
+          </a:solidFill>
           <a:ln/>
         </p:spPr>
         <p:txBody>
@@ -8044,6 +8078,146 @@
               </a:solidFill>
               <a:latin typeface="Calibri" panose="020F0502020204030204" pitchFamily="34" charset="0"/>
             </a:endParaRPr>
+          </a:p>
+        </p:txBody>
+      </p:sp>
+      <p:sp>
+        <p:nvSpPr>
+          <p:cNvPr id="17" name="Slide Number Placeholder 0">
+            <a:extLst>
+              <a:ext uri="{FF2B5EF4-FFF2-40B4-BE49-F238E27FC236}">
+                <a16:creationId xmlns:a16="http://schemas.microsoft.com/office/drawing/2014/main" id="{A29B4CA9-8089-F9E3-EB03-A4CF676FD100}"/>
+              </a:ext>
+            </a:extLst>
+          </p:cNvPr>
+          <p:cNvSpPr txBox="1">
+            <a:spLocks/>
+          </p:cNvSpPr>
+          <p:nvPr/>
+        </p:nvSpPr>
+        <p:spPr>
+          <a:xfrm>
+            <a:off x="11094720" y="6339840"/>
+            <a:ext cx="609600" cy="365760"/>
+          </a:xfrm>
+          <a:prstGeom prst="rect">
+            <a:avLst/>
+          </a:prstGeom>
+          <a:extLst>
+            <a:ext uri="{C572A759-6A51-4108-AA02-DFA0A04FC94B}">
+              <ma14:wrappingTextBoxFlag xmlns:ma14="http://schemas.microsoft.com/office/mac/drawingml/2011/main" xmlns="" val="0"/>
+            </a:ext>
+          </a:extLst>
+        </p:spPr>
+        <p:txBody>
+          <a:bodyPr vert="horz" lIns="91440" tIns="45720" rIns="91440" bIns="45720" rtlCol="0" anchor="ctr"/>
+          <a:lstStyle>
+            <a:defPPr>
+              <a:defRPr lang="es-CO"/>
+            </a:defPPr>
+            <a:lvl1pPr marL="0" algn="r" defTabSz="914400" rtl="0" eaLnBrk="1" latinLnBrk="0" hangingPunct="1">
+              <a:defRPr sz="1333" kern="1200">
+                <a:solidFill>
+                  <a:schemeClr val="tx1"/>
+                </a:solidFill>
+                <a:latin typeface="+mn-lt"/>
+                <a:ea typeface="+mn-ea"/>
+                <a:cs typeface="+mn-cs"/>
+              </a:defRPr>
+            </a:lvl1pPr>
+            <a:lvl2pPr marL="457200" algn="l" defTabSz="914400" rtl="0" eaLnBrk="1" latinLnBrk="0" hangingPunct="1">
+              <a:defRPr sz="1800" kern="1200">
+                <a:solidFill>
+                  <a:schemeClr val="tx1"/>
+                </a:solidFill>
+                <a:latin typeface="+mn-lt"/>
+                <a:ea typeface="+mn-ea"/>
+                <a:cs typeface="+mn-cs"/>
+              </a:defRPr>
+            </a:lvl2pPr>
+            <a:lvl3pPr marL="914400" algn="l" defTabSz="914400" rtl="0" eaLnBrk="1" latinLnBrk="0" hangingPunct="1">
+              <a:defRPr sz="1800" kern="1200">
+                <a:solidFill>
+                  <a:schemeClr val="tx1"/>
+                </a:solidFill>
+                <a:latin typeface="+mn-lt"/>
+                <a:ea typeface="+mn-ea"/>
+                <a:cs typeface="+mn-cs"/>
+              </a:defRPr>
+            </a:lvl3pPr>
+            <a:lvl4pPr marL="1371600" algn="l" defTabSz="914400" rtl="0" eaLnBrk="1" latinLnBrk="0" hangingPunct="1">
+              <a:defRPr sz="1800" kern="1200">
+                <a:solidFill>
+                  <a:schemeClr val="tx1"/>
+                </a:solidFill>
+                <a:latin typeface="+mn-lt"/>
+                <a:ea typeface="+mn-ea"/>
+                <a:cs typeface="+mn-cs"/>
+              </a:defRPr>
+            </a:lvl4pPr>
+            <a:lvl5pPr marL="1828800" algn="l" defTabSz="914400" rtl="0" eaLnBrk="1" latinLnBrk="0" hangingPunct="1">
+              <a:defRPr sz="1800" kern="1200">
+                <a:solidFill>
+                  <a:schemeClr val="tx1"/>
+                </a:solidFill>
+                <a:latin typeface="+mn-lt"/>
+                <a:ea typeface="+mn-ea"/>
+                <a:cs typeface="+mn-cs"/>
+              </a:defRPr>
+            </a:lvl5pPr>
+            <a:lvl6pPr marL="2286000" algn="l" defTabSz="914400" rtl="0" eaLnBrk="1" latinLnBrk="0" hangingPunct="1">
+              <a:defRPr sz="1800" kern="1200">
+                <a:solidFill>
+                  <a:schemeClr val="tx1"/>
+                </a:solidFill>
+                <a:latin typeface="+mn-lt"/>
+                <a:ea typeface="+mn-ea"/>
+                <a:cs typeface="+mn-cs"/>
+              </a:defRPr>
+            </a:lvl6pPr>
+            <a:lvl7pPr marL="2743200" algn="l" defTabSz="914400" rtl="0" eaLnBrk="1" latinLnBrk="0" hangingPunct="1">
+              <a:defRPr sz="1800" kern="1200">
+                <a:solidFill>
+                  <a:schemeClr val="tx1"/>
+                </a:solidFill>
+                <a:latin typeface="+mn-lt"/>
+                <a:ea typeface="+mn-ea"/>
+                <a:cs typeface="+mn-cs"/>
+              </a:defRPr>
+            </a:lvl7pPr>
+            <a:lvl8pPr marL="3200400" algn="l" defTabSz="914400" rtl="0" eaLnBrk="1" latinLnBrk="0" hangingPunct="1">
+              <a:defRPr sz="1800" kern="1200">
+                <a:solidFill>
+                  <a:schemeClr val="tx1"/>
+                </a:solidFill>
+                <a:latin typeface="+mn-lt"/>
+                <a:ea typeface="+mn-ea"/>
+                <a:cs typeface="+mn-cs"/>
+              </a:defRPr>
+            </a:lvl8pPr>
+            <a:lvl9pPr marL="3657600" algn="l" defTabSz="914400" rtl="0" eaLnBrk="1" latinLnBrk="0" hangingPunct="1">
+              <a:defRPr sz="1800" kern="1200">
+                <a:solidFill>
+                  <a:schemeClr val="tx1"/>
+                </a:solidFill>
+                <a:latin typeface="+mn-lt"/>
+                <a:ea typeface="+mn-ea"/>
+                <a:cs typeface="+mn-cs"/>
+              </a:defRPr>
+            </a:lvl9pPr>
+          </a:lstStyle>
+          <a:p>
+            <a:pPr algn="l"/>
+            <a:fld id="{F7021451-1387-4CA6-816F-3879F97B5CBC}" type="slidenum">
+              <a:rPr lang="en-US" smtClean="0">
+                <a:solidFill>
+                  <a:srgbClr val="BEC5E6"/>
+                </a:solidFill>
+              </a:rPr>
+              <a:pPr algn="l"/>
+              <a:t>13</a:t>
+            </a:fld>
+            <a:endParaRPr lang="en-US" dirty="0"/>
           </a:p>
         </p:txBody>
       </p:sp>
@@ -9703,6 +9877,146 @@
               </a:solidFill>
               <a:latin typeface="Calibri" panose="020F0502020204030204" pitchFamily="34" charset="0"/>
             </a:endParaRPr>
+          </a:p>
+        </p:txBody>
+      </p:sp>
+      <p:sp>
+        <p:nvSpPr>
+          <p:cNvPr id="19" name="Slide Number Placeholder 0">
+            <a:extLst>
+              <a:ext uri="{FF2B5EF4-FFF2-40B4-BE49-F238E27FC236}">
+                <a16:creationId xmlns:a16="http://schemas.microsoft.com/office/drawing/2014/main" id="{41AC84D1-05AA-0109-3291-20151F30CEC2}"/>
+              </a:ext>
+            </a:extLst>
+          </p:cNvPr>
+          <p:cNvSpPr txBox="1">
+            <a:spLocks/>
+          </p:cNvSpPr>
+          <p:nvPr/>
+        </p:nvSpPr>
+        <p:spPr>
+          <a:xfrm>
+            <a:off x="11094720" y="6339840"/>
+            <a:ext cx="609600" cy="365760"/>
+          </a:xfrm>
+          <a:prstGeom prst="rect">
+            <a:avLst/>
+          </a:prstGeom>
+          <a:extLst>
+            <a:ext uri="{C572A759-6A51-4108-AA02-DFA0A04FC94B}">
+              <ma14:wrappingTextBoxFlag xmlns:ma14="http://schemas.microsoft.com/office/mac/drawingml/2011/main" xmlns="" val="0"/>
+            </a:ext>
+          </a:extLst>
+        </p:spPr>
+        <p:txBody>
+          <a:bodyPr vert="horz" lIns="91440" tIns="45720" rIns="91440" bIns="45720" rtlCol="0" anchor="ctr"/>
+          <a:lstStyle>
+            <a:defPPr>
+              <a:defRPr lang="es-CO"/>
+            </a:defPPr>
+            <a:lvl1pPr marL="0" algn="r" defTabSz="914400" rtl="0" eaLnBrk="1" latinLnBrk="0" hangingPunct="1">
+              <a:defRPr sz="1333" kern="1200">
+                <a:solidFill>
+                  <a:schemeClr val="tx1"/>
+                </a:solidFill>
+                <a:latin typeface="+mn-lt"/>
+                <a:ea typeface="+mn-ea"/>
+                <a:cs typeface="+mn-cs"/>
+              </a:defRPr>
+            </a:lvl1pPr>
+            <a:lvl2pPr marL="457200" algn="l" defTabSz="914400" rtl="0" eaLnBrk="1" latinLnBrk="0" hangingPunct="1">
+              <a:defRPr sz="1800" kern="1200">
+                <a:solidFill>
+                  <a:schemeClr val="tx1"/>
+                </a:solidFill>
+                <a:latin typeface="+mn-lt"/>
+                <a:ea typeface="+mn-ea"/>
+                <a:cs typeface="+mn-cs"/>
+              </a:defRPr>
+            </a:lvl2pPr>
+            <a:lvl3pPr marL="914400" algn="l" defTabSz="914400" rtl="0" eaLnBrk="1" latinLnBrk="0" hangingPunct="1">
+              <a:defRPr sz="1800" kern="1200">
+                <a:solidFill>
+                  <a:schemeClr val="tx1"/>
+                </a:solidFill>
+                <a:latin typeface="+mn-lt"/>
+                <a:ea typeface="+mn-ea"/>
+                <a:cs typeface="+mn-cs"/>
+              </a:defRPr>
+            </a:lvl3pPr>
+            <a:lvl4pPr marL="1371600" algn="l" defTabSz="914400" rtl="0" eaLnBrk="1" latinLnBrk="0" hangingPunct="1">
+              <a:defRPr sz="1800" kern="1200">
+                <a:solidFill>
+                  <a:schemeClr val="tx1"/>
+                </a:solidFill>
+                <a:latin typeface="+mn-lt"/>
+                <a:ea typeface="+mn-ea"/>
+                <a:cs typeface="+mn-cs"/>
+              </a:defRPr>
+            </a:lvl4pPr>
+            <a:lvl5pPr marL="1828800" algn="l" defTabSz="914400" rtl="0" eaLnBrk="1" latinLnBrk="0" hangingPunct="1">
+              <a:defRPr sz="1800" kern="1200">
+                <a:solidFill>
+                  <a:schemeClr val="tx1"/>
+                </a:solidFill>
+                <a:latin typeface="+mn-lt"/>
+                <a:ea typeface="+mn-ea"/>
+                <a:cs typeface="+mn-cs"/>
+              </a:defRPr>
+            </a:lvl5pPr>
+            <a:lvl6pPr marL="2286000" algn="l" defTabSz="914400" rtl="0" eaLnBrk="1" latinLnBrk="0" hangingPunct="1">
+              <a:defRPr sz="1800" kern="1200">
+                <a:solidFill>
+                  <a:schemeClr val="tx1"/>
+                </a:solidFill>
+                <a:latin typeface="+mn-lt"/>
+                <a:ea typeface="+mn-ea"/>
+                <a:cs typeface="+mn-cs"/>
+              </a:defRPr>
+            </a:lvl6pPr>
+            <a:lvl7pPr marL="2743200" algn="l" defTabSz="914400" rtl="0" eaLnBrk="1" latinLnBrk="0" hangingPunct="1">
+              <a:defRPr sz="1800" kern="1200">
+                <a:solidFill>
+                  <a:schemeClr val="tx1"/>
+                </a:solidFill>
+                <a:latin typeface="+mn-lt"/>
+                <a:ea typeface="+mn-ea"/>
+                <a:cs typeface="+mn-cs"/>
+              </a:defRPr>
+            </a:lvl7pPr>
+            <a:lvl8pPr marL="3200400" algn="l" defTabSz="914400" rtl="0" eaLnBrk="1" latinLnBrk="0" hangingPunct="1">
+              <a:defRPr sz="1800" kern="1200">
+                <a:solidFill>
+                  <a:schemeClr val="tx1"/>
+                </a:solidFill>
+                <a:latin typeface="+mn-lt"/>
+                <a:ea typeface="+mn-ea"/>
+                <a:cs typeface="+mn-cs"/>
+              </a:defRPr>
+            </a:lvl8pPr>
+            <a:lvl9pPr marL="3657600" algn="l" defTabSz="914400" rtl="0" eaLnBrk="1" latinLnBrk="0" hangingPunct="1">
+              <a:defRPr sz="1800" kern="1200">
+                <a:solidFill>
+                  <a:schemeClr val="tx1"/>
+                </a:solidFill>
+                <a:latin typeface="+mn-lt"/>
+                <a:ea typeface="+mn-ea"/>
+                <a:cs typeface="+mn-cs"/>
+              </a:defRPr>
+            </a:lvl9pPr>
+          </a:lstStyle>
+          <a:p>
+            <a:pPr algn="l"/>
+            <a:fld id="{F7021451-1387-4CA6-816F-3879F97B5CBC}" type="slidenum">
+              <a:rPr lang="en-US" smtClean="0">
+                <a:solidFill>
+                  <a:srgbClr val="BEC5E6"/>
+                </a:solidFill>
+              </a:rPr>
+              <a:pPr algn="l"/>
+              <a:t>14</a:t>
+            </a:fld>
+            <a:endParaRPr lang="en-US" dirty="0"/>
           </a:p>
         </p:txBody>
       </p:sp>
@@ -10618,6 +10932,146 @@
           </a:prstGeom>
         </p:spPr>
       </p:pic>
+      <p:sp>
+        <p:nvSpPr>
+          <p:cNvPr id="4" name="Slide Number Placeholder 0">
+            <a:extLst>
+              <a:ext uri="{FF2B5EF4-FFF2-40B4-BE49-F238E27FC236}">
+                <a16:creationId xmlns:a16="http://schemas.microsoft.com/office/drawing/2014/main" id="{44E2FF4A-AF77-C02B-AFD3-8D5358119CE8}"/>
+              </a:ext>
+            </a:extLst>
+          </p:cNvPr>
+          <p:cNvSpPr txBox="1">
+            <a:spLocks/>
+          </p:cNvSpPr>
+          <p:nvPr/>
+        </p:nvSpPr>
+        <p:spPr>
+          <a:xfrm>
+            <a:off x="11094720" y="6339840"/>
+            <a:ext cx="609600" cy="365760"/>
+          </a:xfrm>
+          <a:prstGeom prst="rect">
+            <a:avLst/>
+          </a:prstGeom>
+          <a:extLst>
+            <a:ext uri="{C572A759-6A51-4108-AA02-DFA0A04FC94B}">
+              <ma14:wrappingTextBoxFlag xmlns:ma14="http://schemas.microsoft.com/office/mac/drawingml/2011/main" xmlns="" val="0"/>
+            </a:ext>
+          </a:extLst>
+        </p:spPr>
+        <p:txBody>
+          <a:bodyPr vert="horz" lIns="91440" tIns="45720" rIns="91440" bIns="45720" rtlCol="0" anchor="ctr"/>
+          <a:lstStyle>
+            <a:defPPr>
+              <a:defRPr lang="es-CO"/>
+            </a:defPPr>
+            <a:lvl1pPr marL="0" algn="r" defTabSz="914400" rtl="0" eaLnBrk="1" latinLnBrk="0" hangingPunct="1">
+              <a:defRPr sz="1333" kern="1200">
+                <a:solidFill>
+                  <a:schemeClr val="tx1"/>
+                </a:solidFill>
+                <a:latin typeface="+mn-lt"/>
+                <a:ea typeface="+mn-ea"/>
+                <a:cs typeface="+mn-cs"/>
+              </a:defRPr>
+            </a:lvl1pPr>
+            <a:lvl2pPr marL="457200" algn="l" defTabSz="914400" rtl="0" eaLnBrk="1" latinLnBrk="0" hangingPunct="1">
+              <a:defRPr sz="1800" kern="1200">
+                <a:solidFill>
+                  <a:schemeClr val="tx1"/>
+                </a:solidFill>
+                <a:latin typeface="+mn-lt"/>
+                <a:ea typeface="+mn-ea"/>
+                <a:cs typeface="+mn-cs"/>
+              </a:defRPr>
+            </a:lvl2pPr>
+            <a:lvl3pPr marL="914400" algn="l" defTabSz="914400" rtl="0" eaLnBrk="1" latinLnBrk="0" hangingPunct="1">
+              <a:defRPr sz="1800" kern="1200">
+                <a:solidFill>
+                  <a:schemeClr val="tx1"/>
+                </a:solidFill>
+                <a:latin typeface="+mn-lt"/>
+                <a:ea typeface="+mn-ea"/>
+                <a:cs typeface="+mn-cs"/>
+              </a:defRPr>
+            </a:lvl3pPr>
+            <a:lvl4pPr marL="1371600" algn="l" defTabSz="914400" rtl="0" eaLnBrk="1" latinLnBrk="0" hangingPunct="1">
+              <a:defRPr sz="1800" kern="1200">
+                <a:solidFill>
+                  <a:schemeClr val="tx1"/>
+                </a:solidFill>
+                <a:latin typeface="+mn-lt"/>
+                <a:ea typeface="+mn-ea"/>
+                <a:cs typeface="+mn-cs"/>
+              </a:defRPr>
+            </a:lvl4pPr>
+            <a:lvl5pPr marL="1828800" algn="l" defTabSz="914400" rtl="0" eaLnBrk="1" latinLnBrk="0" hangingPunct="1">
+              <a:defRPr sz="1800" kern="1200">
+                <a:solidFill>
+                  <a:schemeClr val="tx1"/>
+                </a:solidFill>
+                <a:latin typeface="+mn-lt"/>
+                <a:ea typeface="+mn-ea"/>
+                <a:cs typeface="+mn-cs"/>
+              </a:defRPr>
+            </a:lvl5pPr>
+            <a:lvl6pPr marL="2286000" algn="l" defTabSz="914400" rtl="0" eaLnBrk="1" latinLnBrk="0" hangingPunct="1">
+              <a:defRPr sz="1800" kern="1200">
+                <a:solidFill>
+                  <a:schemeClr val="tx1"/>
+                </a:solidFill>
+                <a:latin typeface="+mn-lt"/>
+                <a:ea typeface="+mn-ea"/>
+                <a:cs typeface="+mn-cs"/>
+              </a:defRPr>
+            </a:lvl6pPr>
+            <a:lvl7pPr marL="2743200" algn="l" defTabSz="914400" rtl="0" eaLnBrk="1" latinLnBrk="0" hangingPunct="1">
+              <a:defRPr sz="1800" kern="1200">
+                <a:solidFill>
+                  <a:schemeClr val="tx1"/>
+                </a:solidFill>
+                <a:latin typeface="+mn-lt"/>
+                <a:ea typeface="+mn-ea"/>
+                <a:cs typeface="+mn-cs"/>
+              </a:defRPr>
+            </a:lvl7pPr>
+            <a:lvl8pPr marL="3200400" algn="l" defTabSz="914400" rtl="0" eaLnBrk="1" latinLnBrk="0" hangingPunct="1">
+              <a:defRPr sz="1800" kern="1200">
+                <a:solidFill>
+                  <a:schemeClr val="tx1"/>
+                </a:solidFill>
+                <a:latin typeface="+mn-lt"/>
+                <a:ea typeface="+mn-ea"/>
+                <a:cs typeface="+mn-cs"/>
+              </a:defRPr>
+            </a:lvl8pPr>
+            <a:lvl9pPr marL="3657600" algn="l" defTabSz="914400" rtl="0" eaLnBrk="1" latinLnBrk="0" hangingPunct="1">
+              <a:defRPr sz="1800" kern="1200">
+                <a:solidFill>
+                  <a:schemeClr val="tx1"/>
+                </a:solidFill>
+                <a:latin typeface="+mn-lt"/>
+                <a:ea typeface="+mn-ea"/>
+                <a:cs typeface="+mn-cs"/>
+              </a:defRPr>
+            </a:lvl9pPr>
+          </a:lstStyle>
+          <a:p>
+            <a:pPr algn="l"/>
+            <a:fld id="{F7021451-1387-4CA6-816F-3879F97B5CBC}" type="slidenum">
+              <a:rPr lang="en-US" smtClean="0">
+                <a:solidFill>
+                  <a:srgbClr val="BEC5E6"/>
+                </a:solidFill>
+              </a:rPr>
+              <a:pPr algn="l"/>
+              <a:t>15</a:t>
+            </a:fld>
+            <a:endParaRPr lang="en-US" dirty="0"/>
+          </a:p>
+        </p:txBody>
+      </p:sp>
     </p:spTree>
     <p:extLst>
       <p:ext uri="{BB962C8B-B14F-4D97-AF65-F5344CB8AC3E}">
@@ -10628,18 +11082,6 @@
   <p:clrMapOvr>
     <a:masterClrMapping/>
   </p:clrMapOvr>
-  <mc:AlternateContent xmlns:mc="http://schemas.openxmlformats.org/markup-compatibility/2006" xmlns:p14="http://schemas.microsoft.com/office/powerpoint/2010/main">
-    <mc:Choice Requires="p14">
-      <p:transition spd="slow" p14:dur="2000">
-        <p:fade/>
-      </p:transition>
-    </mc:Choice>
-    <mc:Fallback xmlns="">
-      <p:transition spd="slow">
-        <p:fade/>
-      </p:transition>
-    </mc:Fallback>
-  </mc:AlternateContent>
 </p:sld>
 </file>
 
@@ -10870,6 +11312,146 @@
           </a:prstGeom>
         </p:spPr>
       </p:pic>
+      <p:sp>
+        <p:nvSpPr>
+          <p:cNvPr id="4" name="Slide Number Placeholder 0">
+            <a:extLst>
+              <a:ext uri="{FF2B5EF4-FFF2-40B4-BE49-F238E27FC236}">
+                <a16:creationId xmlns:a16="http://schemas.microsoft.com/office/drawing/2014/main" id="{BFEB0F68-9DE0-4916-056C-7CEAF9C282E6}"/>
+              </a:ext>
+            </a:extLst>
+          </p:cNvPr>
+          <p:cNvSpPr txBox="1">
+            <a:spLocks/>
+          </p:cNvSpPr>
+          <p:nvPr/>
+        </p:nvSpPr>
+        <p:spPr>
+          <a:xfrm>
+            <a:off x="11094720" y="6339840"/>
+            <a:ext cx="609600" cy="365760"/>
+          </a:xfrm>
+          <a:prstGeom prst="rect">
+            <a:avLst/>
+          </a:prstGeom>
+          <a:extLst>
+            <a:ext uri="{C572A759-6A51-4108-AA02-DFA0A04FC94B}">
+              <ma14:wrappingTextBoxFlag xmlns:ma14="http://schemas.microsoft.com/office/mac/drawingml/2011/main" xmlns="" val="0"/>
+            </a:ext>
+          </a:extLst>
+        </p:spPr>
+        <p:txBody>
+          <a:bodyPr vert="horz" lIns="91440" tIns="45720" rIns="91440" bIns="45720" rtlCol="0" anchor="ctr"/>
+          <a:lstStyle>
+            <a:defPPr>
+              <a:defRPr lang="es-CO"/>
+            </a:defPPr>
+            <a:lvl1pPr marL="0" algn="r" defTabSz="914400" rtl="0" eaLnBrk="1" latinLnBrk="0" hangingPunct="1">
+              <a:defRPr sz="1333" kern="1200">
+                <a:solidFill>
+                  <a:schemeClr val="tx1"/>
+                </a:solidFill>
+                <a:latin typeface="+mn-lt"/>
+                <a:ea typeface="+mn-ea"/>
+                <a:cs typeface="+mn-cs"/>
+              </a:defRPr>
+            </a:lvl1pPr>
+            <a:lvl2pPr marL="457200" algn="l" defTabSz="914400" rtl="0" eaLnBrk="1" latinLnBrk="0" hangingPunct="1">
+              <a:defRPr sz="1800" kern="1200">
+                <a:solidFill>
+                  <a:schemeClr val="tx1"/>
+                </a:solidFill>
+                <a:latin typeface="+mn-lt"/>
+                <a:ea typeface="+mn-ea"/>
+                <a:cs typeface="+mn-cs"/>
+              </a:defRPr>
+            </a:lvl2pPr>
+            <a:lvl3pPr marL="914400" algn="l" defTabSz="914400" rtl="0" eaLnBrk="1" latinLnBrk="0" hangingPunct="1">
+              <a:defRPr sz="1800" kern="1200">
+                <a:solidFill>
+                  <a:schemeClr val="tx1"/>
+                </a:solidFill>
+                <a:latin typeface="+mn-lt"/>
+                <a:ea typeface="+mn-ea"/>
+                <a:cs typeface="+mn-cs"/>
+              </a:defRPr>
+            </a:lvl3pPr>
+            <a:lvl4pPr marL="1371600" algn="l" defTabSz="914400" rtl="0" eaLnBrk="1" latinLnBrk="0" hangingPunct="1">
+              <a:defRPr sz="1800" kern="1200">
+                <a:solidFill>
+                  <a:schemeClr val="tx1"/>
+                </a:solidFill>
+                <a:latin typeface="+mn-lt"/>
+                <a:ea typeface="+mn-ea"/>
+                <a:cs typeface="+mn-cs"/>
+              </a:defRPr>
+            </a:lvl4pPr>
+            <a:lvl5pPr marL="1828800" algn="l" defTabSz="914400" rtl="0" eaLnBrk="1" latinLnBrk="0" hangingPunct="1">
+              <a:defRPr sz="1800" kern="1200">
+                <a:solidFill>
+                  <a:schemeClr val="tx1"/>
+                </a:solidFill>
+                <a:latin typeface="+mn-lt"/>
+                <a:ea typeface="+mn-ea"/>
+                <a:cs typeface="+mn-cs"/>
+              </a:defRPr>
+            </a:lvl5pPr>
+            <a:lvl6pPr marL="2286000" algn="l" defTabSz="914400" rtl="0" eaLnBrk="1" latinLnBrk="0" hangingPunct="1">
+              <a:defRPr sz="1800" kern="1200">
+                <a:solidFill>
+                  <a:schemeClr val="tx1"/>
+                </a:solidFill>
+                <a:latin typeface="+mn-lt"/>
+                <a:ea typeface="+mn-ea"/>
+                <a:cs typeface="+mn-cs"/>
+              </a:defRPr>
+            </a:lvl6pPr>
+            <a:lvl7pPr marL="2743200" algn="l" defTabSz="914400" rtl="0" eaLnBrk="1" latinLnBrk="0" hangingPunct="1">
+              <a:defRPr sz="1800" kern="1200">
+                <a:solidFill>
+                  <a:schemeClr val="tx1"/>
+                </a:solidFill>
+                <a:latin typeface="+mn-lt"/>
+                <a:ea typeface="+mn-ea"/>
+                <a:cs typeface="+mn-cs"/>
+              </a:defRPr>
+            </a:lvl7pPr>
+            <a:lvl8pPr marL="3200400" algn="l" defTabSz="914400" rtl="0" eaLnBrk="1" latinLnBrk="0" hangingPunct="1">
+              <a:defRPr sz="1800" kern="1200">
+                <a:solidFill>
+                  <a:schemeClr val="tx1"/>
+                </a:solidFill>
+                <a:latin typeface="+mn-lt"/>
+                <a:ea typeface="+mn-ea"/>
+                <a:cs typeface="+mn-cs"/>
+              </a:defRPr>
+            </a:lvl8pPr>
+            <a:lvl9pPr marL="3657600" algn="l" defTabSz="914400" rtl="0" eaLnBrk="1" latinLnBrk="0" hangingPunct="1">
+              <a:defRPr sz="1800" kern="1200">
+                <a:solidFill>
+                  <a:schemeClr val="tx1"/>
+                </a:solidFill>
+                <a:latin typeface="+mn-lt"/>
+                <a:ea typeface="+mn-ea"/>
+                <a:cs typeface="+mn-cs"/>
+              </a:defRPr>
+            </a:lvl9pPr>
+          </a:lstStyle>
+          <a:p>
+            <a:pPr algn="l"/>
+            <a:fld id="{F7021451-1387-4CA6-816F-3879F97B5CBC}" type="slidenum">
+              <a:rPr lang="en-US" smtClean="0">
+                <a:solidFill>
+                  <a:srgbClr val="BEC5E6"/>
+                </a:solidFill>
+              </a:rPr>
+              <a:pPr algn="l"/>
+              <a:t>16</a:t>
+            </a:fld>
+            <a:endParaRPr lang="en-US" dirty="0"/>
+          </a:p>
+        </p:txBody>
+      </p:sp>
     </p:spTree>
     <p:extLst>
       <p:ext uri="{BB962C8B-B14F-4D97-AF65-F5344CB8AC3E}">
@@ -11411,6 +11993,146 @@
           </a:p>
         </p:txBody>
       </p:sp>
+      <p:sp>
+        <p:nvSpPr>
+          <p:cNvPr id="6" name="Slide Number Placeholder 0">
+            <a:extLst>
+              <a:ext uri="{FF2B5EF4-FFF2-40B4-BE49-F238E27FC236}">
+                <a16:creationId xmlns:a16="http://schemas.microsoft.com/office/drawing/2014/main" id="{231A26C2-4BE6-BD5B-79A7-B3DC57256F3D}"/>
+              </a:ext>
+            </a:extLst>
+          </p:cNvPr>
+          <p:cNvSpPr txBox="1">
+            <a:spLocks/>
+          </p:cNvSpPr>
+          <p:nvPr/>
+        </p:nvSpPr>
+        <p:spPr>
+          <a:xfrm>
+            <a:off x="11094720" y="6339840"/>
+            <a:ext cx="609600" cy="365760"/>
+          </a:xfrm>
+          <a:prstGeom prst="rect">
+            <a:avLst/>
+          </a:prstGeom>
+          <a:extLst>
+            <a:ext uri="{C572A759-6A51-4108-AA02-DFA0A04FC94B}">
+              <ma14:wrappingTextBoxFlag xmlns:ma14="http://schemas.microsoft.com/office/mac/drawingml/2011/main" xmlns="" val="0"/>
+            </a:ext>
+          </a:extLst>
+        </p:spPr>
+        <p:txBody>
+          <a:bodyPr vert="horz" lIns="91440" tIns="45720" rIns="91440" bIns="45720" rtlCol="0" anchor="ctr"/>
+          <a:lstStyle>
+            <a:defPPr>
+              <a:defRPr lang="es-CO"/>
+            </a:defPPr>
+            <a:lvl1pPr marL="0" algn="r" defTabSz="914400" rtl="0" eaLnBrk="1" latinLnBrk="0" hangingPunct="1">
+              <a:defRPr sz="1333" kern="1200">
+                <a:solidFill>
+                  <a:schemeClr val="tx1"/>
+                </a:solidFill>
+                <a:latin typeface="+mn-lt"/>
+                <a:ea typeface="+mn-ea"/>
+                <a:cs typeface="+mn-cs"/>
+              </a:defRPr>
+            </a:lvl1pPr>
+            <a:lvl2pPr marL="457200" algn="l" defTabSz="914400" rtl="0" eaLnBrk="1" latinLnBrk="0" hangingPunct="1">
+              <a:defRPr sz="1800" kern="1200">
+                <a:solidFill>
+                  <a:schemeClr val="tx1"/>
+                </a:solidFill>
+                <a:latin typeface="+mn-lt"/>
+                <a:ea typeface="+mn-ea"/>
+                <a:cs typeface="+mn-cs"/>
+              </a:defRPr>
+            </a:lvl2pPr>
+            <a:lvl3pPr marL="914400" algn="l" defTabSz="914400" rtl="0" eaLnBrk="1" latinLnBrk="0" hangingPunct="1">
+              <a:defRPr sz="1800" kern="1200">
+                <a:solidFill>
+                  <a:schemeClr val="tx1"/>
+                </a:solidFill>
+                <a:latin typeface="+mn-lt"/>
+                <a:ea typeface="+mn-ea"/>
+                <a:cs typeface="+mn-cs"/>
+              </a:defRPr>
+            </a:lvl3pPr>
+            <a:lvl4pPr marL="1371600" algn="l" defTabSz="914400" rtl="0" eaLnBrk="1" latinLnBrk="0" hangingPunct="1">
+              <a:defRPr sz="1800" kern="1200">
+                <a:solidFill>
+                  <a:schemeClr val="tx1"/>
+                </a:solidFill>
+                <a:latin typeface="+mn-lt"/>
+                <a:ea typeface="+mn-ea"/>
+                <a:cs typeface="+mn-cs"/>
+              </a:defRPr>
+            </a:lvl4pPr>
+            <a:lvl5pPr marL="1828800" algn="l" defTabSz="914400" rtl="0" eaLnBrk="1" latinLnBrk="0" hangingPunct="1">
+              <a:defRPr sz="1800" kern="1200">
+                <a:solidFill>
+                  <a:schemeClr val="tx1"/>
+                </a:solidFill>
+                <a:latin typeface="+mn-lt"/>
+                <a:ea typeface="+mn-ea"/>
+                <a:cs typeface="+mn-cs"/>
+              </a:defRPr>
+            </a:lvl5pPr>
+            <a:lvl6pPr marL="2286000" algn="l" defTabSz="914400" rtl="0" eaLnBrk="1" latinLnBrk="0" hangingPunct="1">
+              <a:defRPr sz="1800" kern="1200">
+                <a:solidFill>
+                  <a:schemeClr val="tx1"/>
+                </a:solidFill>
+                <a:latin typeface="+mn-lt"/>
+                <a:ea typeface="+mn-ea"/>
+                <a:cs typeface="+mn-cs"/>
+              </a:defRPr>
+            </a:lvl6pPr>
+            <a:lvl7pPr marL="2743200" algn="l" defTabSz="914400" rtl="0" eaLnBrk="1" latinLnBrk="0" hangingPunct="1">
+              <a:defRPr sz="1800" kern="1200">
+                <a:solidFill>
+                  <a:schemeClr val="tx1"/>
+                </a:solidFill>
+                <a:latin typeface="+mn-lt"/>
+                <a:ea typeface="+mn-ea"/>
+                <a:cs typeface="+mn-cs"/>
+              </a:defRPr>
+            </a:lvl7pPr>
+            <a:lvl8pPr marL="3200400" algn="l" defTabSz="914400" rtl="0" eaLnBrk="1" latinLnBrk="0" hangingPunct="1">
+              <a:defRPr sz="1800" kern="1200">
+                <a:solidFill>
+                  <a:schemeClr val="tx1"/>
+                </a:solidFill>
+                <a:latin typeface="+mn-lt"/>
+                <a:ea typeface="+mn-ea"/>
+                <a:cs typeface="+mn-cs"/>
+              </a:defRPr>
+            </a:lvl8pPr>
+            <a:lvl9pPr marL="3657600" algn="l" defTabSz="914400" rtl="0" eaLnBrk="1" latinLnBrk="0" hangingPunct="1">
+              <a:defRPr sz="1800" kern="1200">
+                <a:solidFill>
+                  <a:schemeClr val="tx1"/>
+                </a:solidFill>
+                <a:latin typeface="+mn-lt"/>
+                <a:ea typeface="+mn-ea"/>
+                <a:cs typeface="+mn-cs"/>
+              </a:defRPr>
+            </a:lvl9pPr>
+          </a:lstStyle>
+          <a:p>
+            <a:pPr algn="l"/>
+            <a:fld id="{F7021451-1387-4CA6-816F-3879F97B5CBC}" type="slidenum">
+              <a:rPr lang="en-US" smtClean="0">
+                <a:solidFill>
+                  <a:srgbClr val="BEC5E6"/>
+                </a:solidFill>
+              </a:rPr>
+              <a:pPr algn="l"/>
+              <a:t>17</a:t>
+            </a:fld>
+            <a:endParaRPr lang="en-US" dirty="0"/>
+          </a:p>
+        </p:txBody>
+      </p:sp>
     </p:spTree>
     <p:extLst>
       <p:ext uri="{BB962C8B-B14F-4D97-AF65-F5344CB8AC3E}">
@@ -11723,7 +12445,7 @@
           </a:prstGeom>
           <a:extLst>
             <a:ext uri="{C572A759-6A51-4108-AA02-DFA0A04FC94B}">
-              <ma14:wrappingTextBoxFlag xmlns="" xmlns:ma14="http://schemas.microsoft.com/office/mac/drawingml/2011/main" val="0"/>
+              <ma14:wrappingTextBoxFlag xmlns:ma14="http://schemas.microsoft.com/office/mac/drawingml/2011/main" xmlns="" val="0"/>
             </a:ext>
           </a:extLst>
         </p:spPr>
@@ -11748,7 +12470,7 @@
               </a:rPr>
               <a:t>2</a:t>
             </a:fld>
-            <a:endParaRPr lang="en-US"/>
+            <a:endParaRPr lang="en-US" dirty="0"/>
           </a:p>
         </p:txBody>
       </p:sp>
@@ -12265,7 +12987,7 @@
           </a:prstGeom>
           <a:extLst>
             <a:ext uri="{C572A759-6A51-4108-AA02-DFA0A04FC94B}">
-              <ma14:wrappingTextBoxFlag xmlns="" xmlns:ma14="http://schemas.microsoft.com/office/mac/drawingml/2011/main" val="0"/>
+              <ma14:wrappingTextBoxFlag xmlns:ma14="http://schemas.microsoft.com/office/mac/drawingml/2011/main" xmlns="" val="0"/>
             </a:ext>
           </a:extLst>
         </p:spPr>
@@ -12803,7 +13525,7 @@
           </a:prstGeom>
           <a:extLst>
             <a:ext uri="{C572A759-6A51-4108-AA02-DFA0A04FC94B}">
-              <ma14:wrappingTextBoxFlag xmlns="" xmlns:ma14="http://schemas.microsoft.com/office/mac/drawingml/2011/main" val="0"/>
+              <ma14:wrappingTextBoxFlag xmlns:ma14="http://schemas.microsoft.com/office/mac/drawingml/2011/main" xmlns="" val="0"/>
             </a:ext>
           </a:extLst>
         </p:spPr>
@@ -12876,7 +13598,9 @@
           <a:prstGeom prst="rect">
             <a:avLst/>
           </a:prstGeom>
-          <a:noFill/>
+          <a:solidFill>
+            <a:srgbClr val="202658"/>
+          </a:solidFill>
           <a:ln/>
         </p:spPr>
         <p:txBody>
@@ -12941,7 +13665,9 @@
           <a:prstGeom prst="rect">
             <a:avLst/>
           </a:prstGeom>
-          <a:noFill/>
+          <a:solidFill>
+            <a:srgbClr val="202658"/>
+          </a:solidFill>
           <a:ln/>
         </p:spPr>
         <p:txBody>
@@ -13006,7 +13732,9 @@
           <a:prstGeom prst="rect">
             <a:avLst/>
           </a:prstGeom>
-          <a:noFill/>
+          <a:solidFill>
+            <a:srgbClr val="202658"/>
+          </a:solidFill>
           <a:ln/>
         </p:spPr>
         <p:txBody>
@@ -14635,6 +15363,146 @@
           </a:p>
         </p:txBody>
       </p:sp>
+      <p:sp>
+        <p:nvSpPr>
+          <p:cNvPr id="22" name="Slide Number Placeholder 0">
+            <a:extLst>
+              <a:ext uri="{FF2B5EF4-FFF2-40B4-BE49-F238E27FC236}">
+                <a16:creationId xmlns:a16="http://schemas.microsoft.com/office/drawing/2014/main" id="{CF19A215-D7AB-F9EE-A636-D754D1A63FF1}"/>
+              </a:ext>
+            </a:extLst>
+          </p:cNvPr>
+          <p:cNvSpPr txBox="1">
+            <a:spLocks/>
+          </p:cNvSpPr>
+          <p:nvPr/>
+        </p:nvSpPr>
+        <p:spPr>
+          <a:xfrm>
+            <a:off x="11094720" y="6339840"/>
+            <a:ext cx="609600" cy="365760"/>
+          </a:xfrm>
+          <a:prstGeom prst="rect">
+            <a:avLst/>
+          </a:prstGeom>
+          <a:extLst>
+            <a:ext uri="{C572A759-6A51-4108-AA02-DFA0A04FC94B}">
+              <ma14:wrappingTextBoxFlag xmlns:ma14="http://schemas.microsoft.com/office/mac/drawingml/2011/main" xmlns="" val="0"/>
+            </a:ext>
+          </a:extLst>
+        </p:spPr>
+        <p:txBody>
+          <a:bodyPr vert="horz" lIns="91440" tIns="45720" rIns="91440" bIns="45720" rtlCol="0" anchor="ctr"/>
+          <a:lstStyle>
+            <a:defPPr>
+              <a:defRPr lang="es-CO"/>
+            </a:defPPr>
+            <a:lvl1pPr marL="0" algn="r" defTabSz="914400" rtl="0" eaLnBrk="1" latinLnBrk="0" hangingPunct="1">
+              <a:defRPr sz="1333" kern="1200">
+                <a:solidFill>
+                  <a:schemeClr val="tx1"/>
+                </a:solidFill>
+                <a:latin typeface="+mn-lt"/>
+                <a:ea typeface="+mn-ea"/>
+                <a:cs typeface="+mn-cs"/>
+              </a:defRPr>
+            </a:lvl1pPr>
+            <a:lvl2pPr marL="457200" algn="l" defTabSz="914400" rtl="0" eaLnBrk="1" latinLnBrk="0" hangingPunct="1">
+              <a:defRPr sz="1800" kern="1200">
+                <a:solidFill>
+                  <a:schemeClr val="tx1"/>
+                </a:solidFill>
+                <a:latin typeface="+mn-lt"/>
+                <a:ea typeface="+mn-ea"/>
+                <a:cs typeface="+mn-cs"/>
+              </a:defRPr>
+            </a:lvl2pPr>
+            <a:lvl3pPr marL="914400" algn="l" defTabSz="914400" rtl="0" eaLnBrk="1" latinLnBrk="0" hangingPunct="1">
+              <a:defRPr sz="1800" kern="1200">
+                <a:solidFill>
+                  <a:schemeClr val="tx1"/>
+                </a:solidFill>
+                <a:latin typeface="+mn-lt"/>
+                <a:ea typeface="+mn-ea"/>
+                <a:cs typeface="+mn-cs"/>
+              </a:defRPr>
+            </a:lvl3pPr>
+            <a:lvl4pPr marL="1371600" algn="l" defTabSz="914400" rtl="0" eaLnBrk="1" latinLnBrk="0" hangingPunct="1">
+              <a:defRPr sz="1800" kern="1200">
+                <a:solidFill>
+                  <a:schemeClr val="tx1"/>
+                </a:solidFill>
+                <a:latin typeface="+mn-lt"/>
+                <a:ea typeface="+mn-ea"/>
+                <a:cs typeface="+mn-cs"/>
+              </a:defRPr>
+            </a:lvl4pPr>
+            <a:lvl5pPr marL="1828800" algn="l" defTabSz="914400" rtl="0" eaLnBrk="1" latinLnBrk="0" hangingPunct="1">
+              <a:defRPr sz="1800" kern="1200">
+                <a:solidFill>
+                  <a:schemeClr val="tx1"/>
+                </a:solidFill>
+                <a:latin typeface="+mn-lt"/>
+                <a:ea typeface="+mn-ea"/>
+                <a:cs typeface="+mn-cs"/>
+              </a:defRPr>
+            </a:lvl5pPr>
+            <a:lvl6pPr marL="2286000" algn="l" defTabSz="914400" rtl="0" eaLnBrk="1" latinLnBrk="0" hangingPunct="1">
+              <a:defRPr sz="1800" kern="1200">
+                <a:solidFill>
+                  <a:schemeClr val="tx1"/>
+                </a:solidFill>
+                <a:latin typeface="+mn-lt"/>
+                <a:ea typeface="+mn-ea"/>
+                <a:cs typeface="+mn-cs"/>
+              </a:defRPr>
+            </a:lvl6pPr>
+            <a:lvl7pPr marL="2743200" algn="l" defTabSz="914400" rtl="0" eaLnBrk="1" latinLnBrk="0" hangingPunct="1">
+              <a:defRPr sz="1800" kern="1200">
+                <a:solidFill>
+                  <a:schemeClr val="tx1"/>
+                </a:solidFill>
+                <a:latin typeface="+mn-lt"/>
+                <a:ea typeface="+mn-ea"/>
+                <a:cs typeface="+mn-cs"/>
+              </a:defRPr>
+            </a:lvl7pPr>
+            <a:lvl8pPr marL="3200400" algn="l" defTabSz="914400" rtl="0" eaLnBrk="1" latinLnBrk="0" hangingPunct="1">
+              <a:defRPr sz="1800" kern="1200">
+                <a:solidFill>
+                  <a:schemeClr val="tx1"/>
+                </a:solidFill>
+                <a:latin typeface="+mn-lt"/>
+                <a:ea typeface="+mn-ea"/>
+                <a:cs typeface="+mn-cs"/>
+              </a:defRPr>
+            </a:lvl8pPr>
+            <a:lvl9pPr marL="3657600" algn="l" defTabSz="914400" rtl="0" eaLnBrk="1" latinLnBrk="0" hangingPunct="1">
+              <a:defRPr sz="1800" kern="1200">
+                <a:solidFill>
+                  <a:schemeClr val="tx1"/>
+                </a:solidFill>
+                <a:latin typeface="+mn-lt"/>
+                <a:ea typeface="+mn-ea"/>
+                <a:cs typeface="+mn-cs"/>
+              </a:defRPr>
+            </a:lvl9pPr>
+          </a:lstStyle>
+          <a:p>
+            <a:pPr algn="l"/>
+            <a:fld id="{F7021451-1387-4CA6-816F-3879F97B5CBC}" type="slidenum">
+              <a:rPr lang="en-US" smtClean="0">
+                <a:solidFill>
+                  <a:srgbClr val="BEC5E6"/>
+                </a:solidFill>
+              </a:rPr>
+              <a:pPr algn="l"/>
+              <a:t>5</a:t>
+            </a:fld>
+            <a:endParaRPr lang="en-US" dirty="0"/>
+          </a:p>
+        </p:txBody>
+      </p:sp>
     </p:spTree>
   </p:cSld>
   <p:clrMapOvr>
@@ -15827,6 +16695,146 @@
               </a:solidFill>
               <a:latin typeface="Calibri" panose="020F0502020204030204" pitchFamily="34" charset="0"/>
             </a:endParaRPr>
+          </a:p>
+        </p:txBody>
+      </p:sp>
+      <p:sp>
+        <p:nvSpPr>
+          <p:cNvPr id="21" name="Slide Number Placeholder 0">
+            <a:extLst>
+              <a:ext uri="{FF2B5EF4-FFF2-40B4-BE49-F238E27FC236}">
+                <a16:creationId xmlns:a16="http://schemas.microsoft.com/office/drawing/2014/main" id="{D8A0553B-6B6B-3BCB-E235-396D8A62E129}"/>
+              </a:ext>
+            </a:extLst>
+          </p:cNvPr>
+          <p:cNvSpPr txBox="1">
+            <a:spLocks/>
+          </p:cNvSpPr>
+          <p:nvPr/>
+        </p:nvSpPr>
+        <p:spPr>
+          <a:xfrm>
+            <a:off x="11094720" y="6339840"/>
+            <a:ext cx="609600" cy="365760"/>
+          </a:xfrm>
+          <a:prstGeom prst="rect">
+            <a:avLst/>
+          </a:prstGeom>
+          <a:extLst>
+            <a:ext uri="{C572A759-6A51-4108-AA02-DFA0A04FC94B}">
+              <ma14:wrappingTextBoxFlag xmlns:ma14="http://schemas.microsoft.com/office/mac/drawingml/2011/main" xmlns="" val="0"/>
+            </a:ext>
+          </a:extLst>
+        </p:spPr>
+        <p:txBody>
+          <a:bodyPr vert="horz" lIns="91440" tIns="45720" rIns="91440" bIns="45720" rtlCol="0" anchor="ctr"/>
+          <a:lstStyle>
+            <a:defPPr>
+              <a:defRPr lang="es-CO"/>
+            </a:defPPr>
+            <a:lvl1pPr marL="0" algn="r" defTabSz="914400" rtl="0" eaLnBrk="1" latinLnBrk="0" hangingPunct="1">
+              <a:defRPr sz="1333" kern="1200">
+                <a:solidFill>
+                  <a:schemeClr val="tx1"/>
+                </a:solidFill>
+                <a:latin typeface="+mn-lt"/>
+                <a:ea typeface="+mn-ea"/>
+                <a:cs typeface="+mn-cs"/>
+              </a:defRPr>
+            </a:lvl1pPr>
+            <a:lvl2pPr marL="457200" algn="l" defTabSz="914400" rtl="0" eaLnBrk="1" latinLnBrk="0" hangingPunct="1">
+              <a:defRPr sz="1800" kern="1200">
+                <a:solidFill>
+                  <a:schemeClr val="tx1"/>
+                </a:solidFill>
+                <a:latin typeface="+mn-lt"/>
+                <a:ea typeface="+mn-ea"/>
+                <a:cs typeface="+mn-cs"/>
+              </a:defRPr>
+            </a:lvl2pPr>
+            <a:lvl3pPr marL="914400" algn="l" defTabSz="914400" rtl="0" eaLnBrk="1" latinLnBrk="0" hangingPunct="1">
+              <a:defRPr sz="1800" kern="1200">
+                <a:solidFill>
+                  <a:schemeClr val="tx1"/>
+                </a:solidFill>
+                <a:latin typeface="+mn-lt"/>
+                <a:ea typeface="+mn-ea"/>
+                <a:cs typeface="+mn-cs"/>
+              </a:defRPr>
+            </a:lvl3pPr>
+            <a:lvl4pPr marL="1371600" algn="l" defTabSz="914400" rtl="0" eaLnBrk="1" latinLnBrk="0" hangingPunct="1">
+              <a:defRPr sz="1800" kern="1200">
+                <a:solidFill>
+                  <a:schemeClr val="tx1"/>
+                </a:solidFill>
+                <a:latin typeface="+mn-lt"/>
+                <a:ea typeface="+mn-ea"/>
+                <a:cs typeface="+mn-cs"/>
+              </a:defRPr>
+            </a:lvl4pPr>
+            <a:lvl5pPr marL="1828800" algn="l" defTabSz="914400" rtl="0" eaLnBrk="1" latinLnBrk="0" hangingPunct="1">
+              <a:defRPr sz="1800" kern="1200">
+                <a:solidFill>
+                  <a:schemeClr val="tx1"/>
+                </a:solidFill>
+                <a:latin typeface="+mn-lt"/>
+                <a:ea typeface="+mn-ea"/>
+                <a:cs typeface="+mn-cs"/>
+              </a:defRPr>
+            </a:lvl5pPr>
+            <a:lvl6pPr marL="2286000" algn="l" defTabSz="914400" rtl="0" eaLnBrk="1" latinLnBrk="0" hangingPunct="1">
+              <a:defRPr sz="1800" kern="1200">
+                <a:solidFill>
+                  <a:schemeClr val="tx1"/>
+                </a:solidFill>
+                <a:latin typeface="+mn-lt"/>
+                <a:ea typeface="+mn-ea"/>
+                <a:cs typeface="+mn-cs"/>
+              </a:defRPr>
+            </a:lvl6pPr>
+            <a:lvl7pPr marL="2743200" algn="l" defTabSz="914400" rtl="0" eaLnBrk="1" latinLnBrk="0" hangingPunct="1">
+              <a:defRPr sz="1800" kern="1200">
+                <a:solidFill>
+                  <a:schemeClr val="tx1"/>
+                </a:solidFill>
+                <a:latin typeface="+mn-lt"/>
+                <a:ea typeface="+mn-ea"/>
+                <a:cs typeface="+mn-cs"/>
+              </a:defRPr>
+            </a:lvl7pPr>
+            <a:lvl8pPr marL="3200400" algn="l" defTabSz="914400" rtl="0" eaLnBrk="1" latinLnBrk="0" hangingPunct="1">
+              <a:defRPr sz="1800" kern="1200">
+                <a:solidFill>
+                  <a:schemeClr val="tx1"/>
+                </a:solidFill>
+                <a:latin typeface="+mn-lt"/>
+                <a:ea typeface="+mn-ea"/>
+                <a:cs typeface="+mn-cs"/>
+              </a:defRPr>
+            </a:lvl8pPr>
+            <a:lvl9pPr marL="3657600" algn="l" defTabSz="914400" rtl="0" eaLnBrk="1" latinLnBrk="0" hangingPunct="1">
+              <a:defRPr sz="1800" kern="1200">
+                <a:solidFill>
+                  <a:schemeClr val="tx1"/>
+                </a:solidFill>
+                <a:latin typeface="+mn-lt"/>
+                <a:ea typeface="+mn-ea"/>
+                <a:cs typeface="+mn-cs"/>
+              </a:defRPr>
+            </a:lvl9pPr>
+          </a:lstStyle>
+          <a:p>
+            <a:pPr algn="l"/>
+            <a:fld id="{F7021451-1387-4CA6-816F-3879F97B5CBC}" type="slidenum">
+              <a:rPr lang="en-US" smtClean="0">
+                <a:solidFill>
+                  <a:srgbClr val="BEC5E6"/>
+                </a:solidFill>
+              </a:rPr>
+              <a:pPr algn="l"/>
+              <a:t>6</a:t>
+            </a:fld>
+            <a:endParaRPr lang="en-US" dirty="0"/>
           </a:p>
         </p:txBody>
       </p:sp>
@@ -17600,6 +18608,146 @@
           </a:p>
         </p:txBody>
       </p:sp>
+      <p:sp>
+        <p:nvSpPr>
+          <p:cNvPr id="19" name="Slide Number Placeholder 0">
+            <a:extLst>
+              <a:ext uri="{FF2B5EF4-FFF2-40B4-BE49-F238E27FC236}">
+                <a16:creationId xmlns:a16="http://schemas.microsoft.com/office/drawing/2014/main" id="{7566D090-DF0B-5930-31CA-DFF70AA7B212}"/>
+              </a:ext>
+            </a:extLst>
+          </p:cNvPr>
+          <p:cNvSpPr txBox="1">
+            <a:spLocks/>
+          </p:cNvSpPr>
+          <p:nvPr/>
+        </p:nvSpPr>
+        <p:spPr>
+          <a:xfrm>
+            <a:off x="11094720" y="6339840"/>
+            <a:ext cx="609600" cy="365760"/>
+          </a:xfrm>
+          <a:prstGeom prst="rect">
+            <a:avLst/>
+          </a:prstGeom>
+          <a:extLst>
+            <a:ext uri="{C572A759-6A51-4108-AA02-DFA0A04FC94B}">
+              <ma14:wrappingTextBoxFlag xmlns:ma14="http://schemas.microsoft.com/office/mac/drawingml/2011/main" xmlns="" val="0"/>
+            </a:ext>
+          </a:extLst>
+        </p:spPr>
+        <p:txBody>
+          <a:bodyPr vert="horz" lIns="91440" tIns="45720" rIns="91440" bIns="45720" rtlCol="0" anchor="ctr"/>
+          <a:lstStyle>
+            <a:defPPr>
+              <a:defRPr lang="es-CO"/>
+            </a:defPPr>
+            <a:lvl1pPr marL="0" algn="r" defTabSz="914400" rtl="0" eaLnBrk="1" latinLnBrk="0" hangingPunct="1">
+              <a:defRPr sz="1333" kern="1200">
+                <a:solidFill>
+                  <a:schemeClr val="tx1"/>
+                </a:solidFill>
+                <a:latin typeface="+mn-lt"/>
+                <a:ea typeface="+mn-ea"/>
+                <a:cs typeface="+mn-cs"/>
+              </a:defRPr>
+            </a:lvl1pPr>
+            <a:lvl2pPr marL="457200" algn="l" defTabSz="914400" rtl="0" eaLnBrk="1" latinLnBrk="0" hangingPunct="1">
+              <a:defRPr sz="1800" kern="1200">
+                <a:solidFill>
+                  <a:schemeClr val="tx1"/>
+                </a:solidFill>
+                <a:latin typeface="+mn-lt"/>
+                <a:ea typeface="+mn-ea"/>
+                <a:cs typeface="+mn-cs"/>
+              </a:defRPr>
+            </a:lvl2pPr>
+            <a:lvl3pPr marL="914400" algn="l" defTabSz="914400" rtl="0" eaLnBrk="1" latinLnBrk="0" hangingPunct="1">
+              <a:defRPr sz="1800" kern="1200">
+                <a:solidFill>
+                  <a:schemeClr val="tx1"/>
+                </a:solidFill>
+                <a:latin typeface="+mn-lt"/>
+                <a:ea typeface="+mn-ea"/>
+                <a:cs typeface="+mn-cs"/>
+              </a:defRPr>
+            </a:lvl3pPr>
+            <a:lvl4pPr marL="1371600" algn="l" defTabSz="914400" rtl="0" eaLnBrk="1" latinLnBrk="0" hangingPunct="1">
+              <a:defRPr sz="1800" kern="1200">
+                <a:solidFill>
+                  <a:schemeClr val="tx1"/>
+                </a:solidFill>
+                <a:latin typeface="+mn-lt"/>
+                <a:ea typeface="+mn-ea"/>
+                <a:cs typeface="+mn-cs"/>
+              </a:defRPr>
+            </a:lvl4pPr>
+            <a:lvl5pPr marL="1828800" algn="l" defTabSz="914400" rtl="0" eaLnBrk="1" latinLnBrk="0" hangingPunct="1">
+              <a:defRPr sz="1800" kern="1200">
+                <a:solidFill>
+                  <a:schemeClr val="tx1"/>
+                </a:solidFill>
+                <a:latin typeface="+mn-lt"/>
+                <a:ea typeface="+mn-ea"/>
+                <a:cs typeface="+mn-cs"/>
+              </a:defRPr>
+            </a:lvl5pPr>
+            <a:lvl6pPr marL="2286000" algn="l" defTabSz="914400" rtl="0" eaLnBrk="1" latinLnBrk="0" hangingPunct="1">
+              <a:defRPr sz="1800" kern="1200">
+                <a:solidFill>
+                  <a:schemeClr val="tx1"/>
+                </a:solidFill>
+                <a:latin typeface="+mn-lt"/>
+                <a:ea typeface="+mn-ea"/>
+                <a:cs typeface="+mn-cs"/>
+              </a:defRPr>
+            </a:lvl6pPr>
+            <a:lvl7pPr marL="2743200" algn="l" defTabSz="914400" rtl="0" eaLnBrk="1" latinLnBrk="0" hangingPunct="1">
+              <a:defRPr sz="1800" kern="1200">
+                <a:solidFill>
+                  <a:schemeClr val="tx1"/>
+                </a:solidFill>
+                <a:latin typeface="+mn-lt"/>
+                <a:ea typeface="+mn-ea"/>
+                <a:cs typeface="+mn-cs"/>
+              </a:defRPr>
+            </a:lvl7pPr>
+            <a:lvl8pPr marL="3200400" algn="l" defTabSz="914400" rtl="0" eaLnBrk="1" latinLnBrk="0" hangingPunct="1">
+              <a:defRPr sz="1800" kern="1200">
+                <a:solidFill>
+                  <a:schemeClr val="tx1"/>
+                </a:solidFill>
+                <a:latin typeface="+mn-lt"/>
+                <a:ea typeface="+mn-ea"/>
+                <a:cs typeface="+mn-cs"/>
+              </a:defRPr>
+            </a:lvl8pPr>
+            <a:lvl9pPr marL="3657600" algn="l" defTabSz="914400" rtl="0" eaLnBrk="1" latinLnBrk="0" hangingPunct="1">
+              <a:defRPr sz="1800" kern="1200">
+                <a:solidFill>
+                  <a:schemeClr val="tx1"/>
+                </a:solidFill>
+                <a:latin typeface="+mn-lt"/>
+                <a:ea typeface="+mn-ea"/>
+                <a:cs typeface="+mn-cs"/>
+              </a:defRPr>
+            </a:lvl9pPr>
+          </a:lstStyle>
+          <a:p>
+            <a:pPr algn="l"/>
+            <a:fld id="{F7021451-1387-4CA6-816F-3879F97B5CBC}" type="slidenum">
+              <a:rPr lang="en-US" smtClean="0">
+                <a:solidFill>
+                  <a:srgbClr val="BEC5E6"/>
+                </a:solidFill>
+              </a:rPr>
+              <a:pPr algn="l"/>
+              <a:t>7</a:t>
+            </a:fld>
+            <a:endParaRPr lang="en-US" dirty="0"/>
+          </a:p>
+        </p:txBody>
+      </p:sp>
     </p:spTree>
     <p:extLst>
       <p:ext uri="{BB962C8B-B14F-4D97-AF65-F5344CB8AC3E}">
@@ -18463,6 +19611,146 @@
           </a:prstGeom>
         </p:spPr>
       </p:pic>
+      <p:sp>
+        <p:nvSpPr>
+          <p:cNvPr id="4" name="Slide Number Placeholder 0">
+            <a:extLst>
+              <a:ext uri="{FF2B5EF4-FFF2-40B4-BE49-F238E27FC236}">
+                <a16:creationId xmlns:a16="http://schemas.microsoft.com/office/drawing/2014/main" id="{A8AB2E6D-704E-6B64-D423-26F23DF79B06}"/>
+              </a:ext>
+            </a:extLst>
+          </p:cNvPr>
+          <p:cNvSpPr txBox="1">
+            <a:spLocks/>
+          </p:cNvSpPr>
+          <p:nvPr/>
+        </p:nvSpPr>
+        <p:spPr>
+          <a:xfrm>
+            <a:off x="11094720" y="6339840"/>
+            <a:ext cx="609600" cy="365760"/>
+          </a:xfrm>
+          <a:prstGeom prst="rect">
+            <a:avLst/>
+          </a:prstGeom>
+          <a:extLst>
+            <a:ext uri="{C572A759-6A51-4108-AA02-DFA0A04FC94B}">
+              <ma14:wrappingTextBoxFlag xmlns:ma14="http://schemas.microsoft.com/office/mac/drawingml/2011/main" xmlns="" val="0"/>
+            </a:ext>
+          </a:extLst>
+        </p:spPr>
+        <p:txBody>
+          <a:bodyPr vert="horz" lIns="91440" tIns="45720" rIns="91440" bIns="45720" rtlCol="0" anchor="ctr"/>
+          <a:lstStyle>
+            <a:defPPr>
+              <a:defRPr lang="es-CO"/>
+            </a:defPPr>
+            <a:lvl1pPr marL="0" algn="r" defTabSz="914400" rtl="0" eaLnBrk="1" latinLnBrk="0" hangingPunct="1">
+              <a:defRPr sz="1333" kern="1200">
+                <a:solidFill>
+                  <a:schemeClr val="tx1"/>
+                </a:solidFill>
+                <a:latin typeface="+mn-lt"/>
+                <a:ea typeface="+mn-ea"/>
+                <a:cs typeface="+mn-cs"/>
+              </a:defRPr>
+            </a:lvl1pPr>
+            <a:lvl2pPr marL="457200" algn="l" defTabSz="914400" rtl="0" eaLnBrk="1" latinLnBrk="0" hangingPunct="1">
+              <a:defRPr sz="1800" kern="1200">
+                <a:solidFill>
+                  <a:schemeClr val="tx1"/>
+                </a:solidFill>
+                <a:latin typeface="+mn-lt"/>
+                <a:ea typeface="+mn-ea"/>
+                <a:cs typeface="+mn-cs"/>
+              </a:defRPr>
+            </a:lvl2pPr>
+            <a:lvl3pPr marL="914400" algn="l" defTabSz="914400" rtl="0" eaLnBrk="1" latinLnBrk="0" hangingPunct="1">
+              <a:defRPr sz="1800" kern="1200">
+                <a:solidFill>
+                  <a:schemeClr val="tx1"/>
+                </a:solidFill>
+                <a:latin typeface="+mn-lt"/>
+                <a:ea typeface="+mn-ea"/>
+                <a:cs typeface="+mn-cs"/>
+              </a:defRPr>
+            </a:lvl3pPr>
+            <a:lvl4pPr marL="1371600" algn="l" defTabSz="914400" rtl="0" eaLnBrk="1" latinLnBrk="0" hangingPunct="1">
+              <a:defRPr sz="1800" kern="1200">
+                <a:solidFill>
+                  <a:schemeClr val="tx1"/>
+                </a:solidFill>
+                <a:latin typeface="+mn-lt"/>
+                <a:ea typeface="+mn-ea"/>
+                <a:cs typeface="+mn-cs"/>
+              </a:defRPr>
+            </a:lvl4pPr>
+            <a:lvl5pPr marL="1828800" algn="l" defTabSz="914400" rtl="0" eaLnBrk="1" latinLnBrk="0" hangingPunct="1">
+              <a:defRPr sz="1800" kern="1200">
+                <a:solidFill>
+                  <a:schemeClr val="tx1"/>
+                </a:solidFill>
+                <a:latin typeface="+mn-lt"/>
+                <a:ea typeface="+mn-ea"/>
+                <a:cs typeface="+mn-cs"/>
+              </a:defRPr>
+            </a:lvl5pPr>
+            <a:lvl6pPr marL="2286000" algn="l" defTabSz="914400" rtl="0" eaLnBrk="1" latinLnBrk="0" hangingPunct="1">
+              <a:defRPr sz="1800" kern="1200">
+                <a:solidFill>
+                  <a:schemeClr val="tx1"/>
+                </a:solidFill>
+                <a:latin typeface="+mn-lt"/>
+                <a:ea typeface="+mn-ea"/>
+                <a:cs typeface="+mn-cs"/>
+              </a:defRPr>
+            </a:lvl6pPr>
+            <a:lvl7pPr marL="2743200" algn="l" defTabSz="914400" rtl="0" eaLnBrk="1" latinLnBrk="0" hangingPunct="1">
+              <a:defRPr sz="1800" kern="1200">
+                <a:solidFill>
+                  <a:schemeClr val="tx1"/>
+                </a:solidFill>
+                <a:latin typeface="+mn-lt"/>
+                <a:ea typeface="+mn-ea"/>
+                <a:cs typeface="+mn-cs"/>
+              </a:defRPr>
+            </a:lvl7pPr>
+            <a:lvl8pPr marL="3200400" algn="l" defTabSz="914400" rtl="0" eaLnBrk="1" latinLnBrk="0" hangingPunct="1">
+              <a:defRPr sz="1800" kern="1200">
+                <a:solidFill>
+                  <a:schemeClr val="tx1"/>
+                </a:solidFill>
+                <a:latin typeface="+mn-lt"/>
+                <a:ea typeface="+mn-ea"/>
+                <a:cs typeface="+mn-cs"/>
+              </a:defRPr>
+            </a:lvl8pPr>
+            <a:lvl9pPr marL="3657600" algn="l" defTabSz="914400" rtl="0" eaLnBrk="1" latinLnBrk="0" hangingPunct="1">
+              <a:defRPr sz="1800" kern="1200">
+                <a:solidFill>
+                  <a:schemeClr val="tx1"/>
+                </a:solidFill>
+                <a:latin typeface="+mn-lt"/>
+                <a:ea typeface="+mn-ea"/>
+                <a:cs typeface="+mn-cs"/>
+              </a:defRPr>
+            </a:lvl9pPr>
+          </a:lstStyle>
+          <a:p>
+            <a:pPr algn="l"/>
+            <a:fld id="{F7021451-1387-4CA6-816F-3879F97B5CBC}" type="slidenum">
+              <a:rPr lang="en-US" smtClean="0">
+                <a:solidFill>
+                  <a:srgbClr val="BEC5E6"/>
+                </a:solidFill>
+              </a:rPr>
+              <a:pPr algn="l"/>
+              <a:t>8</a:t>
+            </a:fld>
+            <a:endParaRPr lang="en-US" dirty="0"/>
+          </a:p>
+        </p:txBody>
+      </p:sp>
     </p:spTree>
     <p:extLst>
       <p:ext uri="{BB962C8B-B14F-4D97-AF65-F5344CB8AC3E}">

</xml_diff>